<commit_message>
feat(slides): add practical prompt engineering methods
Add eight source-backed request examples before recurring project context.
Preserve every existing slide allocation and extend the course to 368 minutes.
Align 90 slide IDs, notes, previews, evidence links, and static fallbacks.
</commit_message>
<xml_diff>
--- a/production/ACT_2.pptx
+++ b/production/ACT_2.pptx
@@ -2,27 +2,27 @@
 <file path=ppt/presentation.xml><?xml version="1.0" encoding="utf-8"?>
 <p:presentation xmlns:p="http://schemas.openxmlformats.org/presentationml/2006/main">
   <p:sldMasterIdLst>
-    <p:sldMasterId xmlns:r="http://schemas.openxmlformats.org/officeDocument/2006/relationships" id="2147483648" r:id="R3fe6753ade3a4969"/>
+    <p:sldMasterId xmlns:r="http://schemas.openxmlformats.org/officeDocument/2006/relationships" id="2147483648" r:id="Ref5176de796e4ecf"/>
   </p:sldMasterIdLst>
   <p:notesMasterIdLst>
-    <p:notesMasterId xmlns:r="http://schemas.openxmlformats.org/officeDocument/2006/relationships" r:id="Rcbfa6c063d274d0c"/>
+    <p:notesMasterId xmlns:r="http://schemas.openxmlformats.org/officeDocument/2006/relationships" r:id="Rdc91cfe6260946dd"/>
   </p:notesMasterIdLst>
   <p:sldIdLst>
-    <p:sldId xmlns:r="http://schemas.openxmlformats.org/officeDocument/2006/relationships" id="256" r:id="R2c781d7d032a4105"/>
-    <p:sldId xmlns:r="http://schemas.openxmlformats.org/officeDocument/2006/relationships" id="257" r:id="R30d075eb5be14490"/>
-    <p:sldId xmlns:r="http://schemas.openxmlformats.org/officeDocument/2006/relationships" id="258" r:id="R1c155e570dc34f63"/>
-    <p:sldId xmlns:r="http://schemas.openxmlformats.org/officeDocument/2006/relationships" id="259" r:id="Rfbfd711d8dc14881"/>
-    <p:sldId xmlns:r="http://schemas.openxmlformats.org/officeDocument/2006/relationships" id="260" r:id="R8b5e30b3a121496b"/>
-    <p:sldId xmlns:r="http://schemas.openxmlformats.org/officeDocument/2006/relationships" id="261" r:id="Rc5204b05b5c14b59"/>
-    <p:sldId xmlns:r="http://schemas.openxmlformats.org/officeDocument/2006/relationships" id="262" r:id="Re0597e6c33fe4a4d"/>
-    <p:sldId xmlns:r="http://schemas.openxmlformats.org/officeDocument/2006/relationships" id="263" r:id="R2f2236cb1953404a"/>
-    <p:sldId xmlns:r="http://schemas.openxmlformats.org/officeDocument/2006/relationships" id="264" r:id="R155053507f1b453d"/>
-    <p:sldId xmlns:r="http://schemas.openxmlformats.org/officeDocument/2006/relationships" id="265" r:id="R5100a09c97d546f3"/>
-    <p:sldId xmlns:r="http://schemas.openxmlformats.org/officeDocument/2006/relationships" id="266" r:id="R00f8908e436b467a"/>
-    <p:sldId xmlns:r="http://schemas.openxmlformats.org/officeDocument/2006/relationships" id="267" r:id="R8cca08415d064fd4"/>
-    <p:sldId xmlns:r="http://schemas.openxmlformats.org/officeDocument/2006/relationships" id="268" r:id="R096b96132dbd48e8"/>
-    <p:sldId xmlns:r="http://schemas.openxmlformats.org/officeDocument/2006/relationships" id="269" r:id="R9ca327edd7a74c17"/>
-    <p:sldId xmlns:r="http://schemas.openxmlformats.org/officeDocument/2006/relationships" id="270" r:id="Ra2d90fa2a39d4aab"/>
+    <p:sldId xmlns:r="http://schemas.openxmlformats.org/officeDocument/2006/relationships" id="256" r:id="R62840e897c624e88"/>
+    <p:sldId xmlns:r="http://schemas.openxmlformats.org/officeDocument/2006/relationships" id="257" r:id="Rb1344b0df96845ac"/>
+    <p:sldId xmlns:r="http://schemas.openxmlformats.org/officeDocument/2006/relationships" id="258" r:id="Rbd910bfddb08485b"/>
+    <p:sldId xmlns:r="http://schemas.openxmlformats.org/officeDocument/2006/relationships" id="259" r:id="R8617adf3b4854f0f"/>
+    <p:sldId xmlns:r="http://schemas.openxmlformats.org/officeDocument/2006/relationships" id="260" r:id="R61da981287c545fe"/>
+    <p:sldId xmlns:r="http://schemas.openxmlformats.org/officeDocument/2006/relationships" id="261" r:id="R9fb1d4ea04484058"/>
+    <p:sldId xmlns:r="http://schemas.openxmlformats.org/officeDocument/2006/relationships" id="262" r:id="R51f9d52b25a34e18"/>
+    <p:sldId xmlns:r="http://schemas.openxmlformats.org/officeDocument/2006/relationships" id="263" r:id="R89278e629a8f494c"/>
+    <p:sldId xmlns:r="http://schemas.openxmlformats.org/officeDocument/2006/relationships" id="264" r:id="Rfe3b5bc1faf34bda"/>
+    <p:sldId xmlns:r="http://schemas.openxmlformats.org/officeDocument/2006/relationships" id="265" r:id="Rbb03b898e4ad4749"/>
+    <p:sldId xmlns:r="http://schemas.openxmlformats.org/officeDocument/2006/relationships" id="266" r:id="R1e2f7c913a674854"/>
+    <p:sldId xmlns:r="http://schemas.openxmlformats.org/officeDocument/2006/relationships" id="267" r:id="R34b58192e3674d65"/>
+    <p:sldId xmlns:r="http://schemas.openxmlformats.org/officeDocument/2006/relationships" id="268" r:id="Red12ceb17244463e"/>
+    <p:sldId xmlns:r="http://schemas.openxmlformats.org/officeDocument/2006/relationships" id="269" r:id="R2405336ccf8046b0"/>
+    <p:sldId xmlns:r="http://schemas.openxmlformats.org/officeDocument/2006/relationships" id="270" r:id="R200897ef6e6745d2"/>
   </p:sldIdLst>
   <p:sldSz cx="12192000" cy="6858000"/>
   <p:notesSz cx="6858000" cy="9144000"/>
@@ -456,7 +456,7 @@
           <a:lstStyle xmlns:a="http://schemas.openxmlformats.org/drawingml/2006/main"/>
           <a:p xmlns:a="http://schemas.openxmlformats.org/drawingml/2006/main">
             <a:r>
-              <a:t>## S24 — 다른 Task에 같은 설명이 반복된다</a:t>
+              <a:t>## S32 — 다른 Task에 같은 설명이 반복된다</a:t>
             </a:r>
           </a:p>
           <a:p xmlns:a="http://schemas.openxmlformats.org/drawingml/2006/main">
@@ -466,7 +466,7 @@
           </a:p>
           <a:p xmlns:a="http://schemas.openxmlformats.org/drawingml/2006/main">
             <a:r>
-              <a:t>Slide ID: S24</a:t>
+              <a:t>Slide ID: S32</a:t>
             </a:r>
           </a:p>
           <a:p xmlns:a="http://schemas.openxmlformats.org/drawingml/2006/main">
@@ -656,7 +656,7 @@
           </a:p>
           <a:p xmlns:a="http://schemas.openxmlformats.org/drawingml/2006/main">
             <a:r>
-              <a:t>Fallback: LOCAL STATIC ARTIFACT — 발표 기본 경로는 `production/ACT_2.pptx`의 S24 또는 `production/preview/act2/S24.png`다. 수정 초안 정적 화면은 존재하며 최종 release 경로·내용 일치는 통합 검토에서 확인한다. 실제 Trial 캡처나 현재 제품 실행으로 표현하지 않는다.</a:t>
+              <a:t>Fallback: LOCAL STATIC ARTIFACT — 발표 기본 경로는 `production/ACT_2.pptx`의 S32 또는 `production/preview/act2/S32.png`다. 수정 초안 정적 화면은 존재하며 최종 release 경로·내용 일치는 통합 검토에서 확인한다. 실제 Trial 캡처나 현재 제품 실행으로 표현하지 않는다.</a:t>
             </a:r>
           </a:p>
           <a:p xmlns:a="http://schemas.openxmlformats.org/drawingml/2006/main">
@@ -736,7 +736,7 @@
           <a:lstStyle xmlns:a="http://schemas.openxmlformats.org/drawingml/2006/main"/>
           <a:p xmlns:a="http://schemas.openxmlformats.org/drawingml/2006/main">
             <a:r>
-              <a:t>## S33 — Core Context에서 상세 정보로 가는 길</a:t>
+              <a:t>## S41 — Core Context에서 상세 정보로 가는 길</a:t>
             </a:r>
           </a:p>
           <a:p xmlns:a="http://schemas.openxmlformats.org/drawingml/2006/main">
@@ -746,7 +746,7 @@
           </a:p>
           <a:p xmlns:a="http://schemas.openxmlformats.org/drawingml/2006/main">
             <a:r>
-              <a:t>Slide ID: S33</a:t>
+              <a:t>Slide ID: S41</a:t>
             </a:r>
           </a:p>
           <a:p xmlns:a="http://schemas.openxmlformats.org/drawingml/2006/main">
@@ -846,7 +846,7 @@
           </a:p>
           <a:p xmlns:a="http://schemas.openxmlformats.org/drawingml/2006/main">
             <a:r>
-              <a:t>화면 진행: Core의 세 항목을 먼저 읽고 필요한 상세의 세 행으로 이동한다. S32의 탐색 경로를 반복 설명하기보다 항상 읽을 기본 안내와 필요할 때 찾을 상세의 경계를 확인한다.</a:t>
+              <a:t>화면 진행: Core의 세 항목을 먼저 읽고 필요한 상세의 세 행으로 이동한다. S40의 탐색 경로를 반복 설명하기보다 항상 읽을 기본 안내와 필요할 때 찾을 상세의 경계를 확인한다.</a:t>
             </a:r>
           </a:p>
           <a:p xmlns:a="http://schemas.openxmlformats.org/drawingml/2006/main">
@@ -856,7 +856,7 @@
           </a:p>
           <a:p xmlns:a="http://schemas.openxmlformats.org/drawingml/2006/main">
             <a:r>
-              <a:t>Evidence / Source: BEAT-014, CLM-0003, CLM-0005, CLM-0014, CLM-0015. TEACHING_MODEL / CONCEPTUAL; describe STATE-03 structure in S34.</a:t>
+              <a:t>Evidence / Source: BEAT-014, CLM-0003, CLM-0005, CLM-0014, CLM-0015. TEACHING_MODEL / CONCEPTUAL; describe STATE-03 structure in S42.</a:t>
             </a:r>
           </a:p>
           <a:p xmlns:a="http://schemas.openxmlformats.org/drawingml/2006/main">
@@ -906,7 +906,7 @@
           </a:p>
           <a:p xmlns:a="http://schemas.openxmlformats.org/drawingml/2006/main">
             <a:r>
-              <a:t>Demo Operation: N/A — the observed repository structure follows on S34.</a:t>
+              <a:t>Demo Operation: N/A — the observed repository structure follows on S42.</a:t>
             </a:r>
           </a:p>
           <a:p xmlns:a="http://schemas.openxmlformats.org/drawingml/2006/main">
@@ -946,7 +946,7 @@
           </a:p>
           <a:p xmlns:a="http://schemas.openxmlformats.org/drawingml/2006/main">
             <a:r>
-              <a:t>Fallback: LOCAL STATIC ARTIFACT — 발표 기본 경로는 `production/ACT_2.pptx`의 S33 또는 `production/preview/act2/S33.png`다. 수정 초안 정적 화면은 존재하며 최종 release 경로·내용 일치는 통합 검토에서 확인한다. 실제 Trial 캡처나 현재 제품 실행으로 표현하지 않는다.</a:t>
+              <a:t>Fallback: LOCAL STATIC ARTIFACT — 발표 기본 경로는 `production/ACT_2.pptx`의 S41 또는 `production/preview/act2/S41.png`다. 수정 초안 정적 화면은 존재하며 최종 release 경로·내용 일치는 통합 검토에서 확인한다. 실제 Trial 캡처나 현재 제품 실행으로 표현하지 않는다.</a:t>
             </a:r>
           </a:p>
           <a:p xmlns:a="http://schemas.openxmlformats.org/drawingml/2006/main">
@@ -1026,7 +1026,7 @@
           <a:lstStyle xmlns:a="http://schemas.openxmlformats.org/drawingml/2006/main"/>
           <a:p xmlns:a="http://schemas.openxmlformats.org/drawingml/2006/main">
             <a:r>
-              <a:t>## S34 — 정보를 지우지 않고 위치를 나누기</a:t>
+              <a:t>## S42 — 정보를 지우지 않고 위치를 나누기</a:t>
             </a:r>
           </a:p>
           <a:p xmlns:a="http://schemas.openxmlformats.org/drawingml/2006/main">
@@ -1036,7 +1036,7 @@
           </a:p>
           <a:p xmlns:a="http://schemas.openxmlformats.org/drawingml/2006/main">
             <a:r>
-              <a:t>Slide ID: S34</a:t>
+              <a:t>Slide ID: S42</a:t>
             </a:r>
           </a:p>
           <a:p xmlns:a="http://schemas.openxmlformats.org/drawingml/2006/main">
@@ -1231,7 +1231,7 @@
           </a:p>
           <a:p xmlns:a="http://schemas.openxmlformats.org/drawingml/2006/main">
             <a:r>
-              <a:t>Fallback: LOCAL STATIC ARTIFACT — 발표 기본 경로는 `production/ACT_2.pptx`의 S34 또는 `production/preview/act2/S34.png`다. 수정 초안 정적 화면은 존재하며 최종 release 경로·내용 일치는 통합 검토에서 확인한다. 실제 Trial 캡처나 현재 제품 실행으로 표현하지 않는다.</a:t>
+              <a:t>Fallback: LOCAL STATIC ARTIFACT — 발표 기본 경로는 `production/ACT_2.pptx`의 S42 또는 `production/preview/act2/S42.png`다. 수정 초안 정적 화면은 존재하며 최종 release 경로·내용 일치는 통합 검토에서 확인한다. 실제 Trial 캡처나 현재 제품 실행으로 표현하지 않는다.</a:t>
             </a:r>
           </a:p>
           <a:p xmlns:a="http://schemas.openxmlformats.org/drawingml/2006/main">
@@ -1311,7 +1311,7 @@
           <a:lstStyle xmlns:a="http://schemas.openxmlformats.org/drawingml/2006/main"/>
           <a:p xmlns:a="http://schemas.openxmlformats.org/drawingml/2006/main">
             <a:r>
-              <a:t>## S35 — 서로 다른 두 Task가 무엇을 읽을까?</a:t>
+              <a:t>## S43 — 서로 다른 두 Task가 무엇을 읽을까?</a:t>
             </a:r>
           </a:p>
           <a:p xmlns:a="http://schemas.openxmlformats.org/drawingml/2006/main">
@@ -1321,7 +1321,7 @@
           </a:p>
           <a:p xmlns:a="http://schemas.openxmlformats.org/drawingml/2006/main">
             <a:r>
-              <a:t>Slide ID: S35</a:t>
+              <a:t>Slide ID: S43</a:t>
             </a:r>
           </a:p>
           <a:p xmlns:a="http://schemas.openxmlformats.org/drawingml/2006/main">
@@ -1511,7 +1511,7 @@
           </a:p>
           <a:p xmlns:a="http://schemas.openxmlformats.org/drawingml/2006/main">
             <a:r>
-              <a:t>Fallback: LOCAL STATIC ARTIFACT — 발표 기본 경로는 `production/ACT_2.pptx`의 S35 또는 `production/preview/act2/S35.png`다. 수정 초안 정적 화면은 존재하며 최종 release 경로·내용 일치는 통합 검토에서 확인한다. 실제 Trial 캡처나 현재 제품 실행으로 표현하지 않는다.</a:t>
+              <a:t>Fallback: LOCAL STATIC ARTIFACT — 발표 기본 경로는 `production/ACT_2.pptx`의 S43 또는 `production/preview/act2/S43.png`다. 수정 초안 정적 화면은 존재하며 최종 release 경로·내용 일치는 통합 검토에서 확인한다. 실제 Trial 캡처나 현재 제품 실행으로 표현하지 않는다.</a:t>
             </a:r>
           </a:p>
           <a:p xmlns:a="http://schemas.openxmlformats.org/drawingml/2006/main">
@@ -1591,7 +1591,7 @@
           <a:lstStyle xmlns:a="http://schemas.openxmlformats.org/drawingml/2006/main"/>
           <a:p xmlns:a="http://schemas.openxmlformats.org/drawingml/2006/main">
             <a:r>
-              <a:t>## S36 — Crop Task에서 관찰한 접근</a:t>
+              <a:t>## S44 — Crop Task에서 관찰한 접근</a:t>
             </a:r>
           </a:p>
           <a:p xmlns:a="http://schemas.openxmlformats.org/drawingml/2006/main">
@@ -1601,7 +1601,7 @@
           </a:p>
           <a:p xmlns:a="http://schemas.openxmlformats.org/drawingml/2006/main">
             <a:r>
-              <a:t>Slide ID: S36</a:t>
+              <a:t>Slide ID: S44</a:t>
             </a:r>
           </a:p>
           <a:p xmlns:a="http://schemas.openxmlformats.org/drawingml/2006/main">
@@ -1796,7 +1796,7 @@
           </a:p>
           <a:p xmlns:a="http://schemas.openxmlformats.org/drawingml/2006/main">
             <a:r>
-              <a:t>Fallback: LOCAL STATIC ARTIFACT — 발표 기본 경로는 `production/ACT_2.pptx`의 S36 또는 `production/preview/act2/S36.png`다. 수정 초안 정적 화면은 존재하며 최종 release 경로·내용 일치는 통합 검토에서 확인한다. 실제 Trial 캡처나 현재 제품 실행으로 표현하지 않는다.</a:t>
+              <a:t>Fallback: LOCAL STATIC ARTIFACT — 발표 기본 경로는 `production/ACT_2.pptx`의 S44 또는 `production/preview/act2/S44.png`다. 수정 초안 정적 화면은 존재하며 최종 release 경로·내용 일치는 통합 검토에서 확인한다. 실제 Trial 캡처나 현재 제품 실행으로 표현하지 않는다.</a:t>
             </a:r>
           </a:p>
           <a:p xmlns:a="http://schemas.openxmlformats.org/drawingml/2006/main">
@@ -1876,7 +1876,7 @@
           <a:lstStyle xmlns:a="http://schemas.openxmlformats.org/drawingml/2006/main"/>
           <a:p xmlns:a="http://schemas.openxmlformats.org/drawingml/2006/main">
             <a:r>
-              <a:t>## S37 — Task별 접근은 달랐지만 완벽하지는 않다</a:t>
+              <a:t>## S45 — Task별 접근은 달랐지만 완벽하지는 않다</a:t>
             </a:r>
           </a:p>
           <a:p xmlns:a="http://schemas.openxmlformats.org/drawingml/2006/main">
@@ -1886,7 +1886,7 @@
           </a:p>
           <a:p xmlns:a="http://schemas.openxmlformats.org/drawingml/2006/main">
             <a:r>
-              <a:t>Slide ID: S37</a:t>
+              <a:t>Slide ID: S45</a:t>
             </a:r>
           </a:p>
           <a:p xmlns:a="http://schemas.openxmlformats.org/drawingml/2006/main">
@@ -2086,7 +2086,7 @@
           </a:p>
           <a:p xmlns:a="http://schemas.openxmlformats.org/drawingml/2006/main">
             <a:r>
-              <a:t>Fallback: LOCAL STATIC ARTIFACT — 발표 기본 경로는 `production/ACT_2.pptx`의 S37 또는 `production/preview/act2/S37.png`다. 수정 초안 정적 화면은 존재하며 최종 release 경로·내용 일치는 통합 검토에서 확인한다. 실제 Trial 캡처나 현재 제품 실행으로 표현하지 않는다.</a:t>
+              <a:t>Fallback: LOCAL STATIC ARTIFACT — 발표 기본 경로는 `production/ACT_2.pptx`의 S45 또는 `production/preview/act2/S45.png`다. 수정 초안 정적 화면은 존재하며 최종 release 경로·내용 일치는 통합 검토에서 확인한다. 실제 Trial 캡처나 현재 제품 실행으로 표현하지 않는다.</a:t>
             </a:r>
           </a:p>
           <a:p xmlns:a="http://schemas.openxmlformats.org/drawingml/2006/main">
@@ -2166,7 +2166,7 @@
           <a:lstStyle xmlns:a="http://schemas.openxmlformats.org/drawingml/2006/main"/>
           <a:p xmlns:a="http://schemas.openxmlformats.org/drawingml/2006/main">
             <a:r>
-              <a:t>## S38 — 지식은 정리됐지만 절차는 반복된다</a:t>
+              <a:t>## S46 — 지식은 정리됐지만 절차는 반복된다</a:t>
             </a:r>
           </a:p>
           <a:p xmlns:a="http://schemas.openxmlformats.org/drawingml/2006/main">
@@ -2176,7 +2176,7 @@
           </a:p>
           <a:p xmlns:a="http://schemas.openxmlformats.org/drawingml/2006/main">
             <a:r>
-              <a:t>Slide ID: S38</a:t>
+              <a:t>Slide ID: S46</a:t>
             </a:r>
           </a:p>
           <a:p xmlns:a="http://schemas.openxmlformats.org/drawingml/2006/main">
@@ -2366,7 +2366,7 @@
           </a:p>
           <a:p xmlns:a="http://schemas.openxmlformats.org/drawingml/2006/main">
             <a:r>
-              <a:t>Fallback: LOCAL STATIC ARTIFACT — 발표 기본 경로는 `production/ACT_2.pptx`의 S38 또는 `production/preview/act2/S38.png`다. 수정 초안 정적 화면은 존재하며 최종 release 경로·내용 일치는 통합 검토에서 확인한다. 실제 Trial 캡처나 현재 제품 실행으로 표현하지 않는다. 질문이 없으면 Audience Interaction의 준비 질문으로 진행한다.</a:t>
+              <a:t>Fallback: LOCAL STATIC ARTIFACT — 발표 기본 경로는 `production/ACT_2.pptx`의 S46 또는 `production/preview/act2/S46.png`다. 수정 초안 정적 화면은 존재하며 최종 release 경로·내용 일치는 통합 검토에서 확인한다. 실제 Trial 캡처나 현재 제품 실행으로 표현하지 않는다. 질문이 없으면 Audience Interaction의 준비 질문으로 진행한다.</a:t>
             </a:r>
           </a:p>
           <a:p xmlns:a="http://schemas.openxmlformats.org/drawingml/2006/main">
@@ -2446,7 +2446,7 @@
           <a:lstStyle xmlns:a="http://schemas.openxmlformats.org/drawingml/2006/main"/>
           <a:p xmlns:a="http://schemas.openxmlformats.org/drawingml/2006/main">
             <a:r>
-              <a:t>## S25 — 작은 Project Context의 첫 기록</a:t>
+              <a:t>## S33 — 작은 Project Context의 첫 기록</a:t>
             </a:r>
           </a:p>
           <a:p xmlns:a="http://schemas.openxmlformats.org/drawingml/2006/main">
@@ -2456,7 +2456,7 @@
           </a:p>
           <a:p xmlns:a="http://schemas.openxmlformats.org/drawingml/2006/main">
             <a:r>
-              <a:t>Slide ID: S25</a:t>
+              <a:t>Slide ID: S33</a:t>
             </a:r>
           </a:p>
           <a:p xmlns:a="http://schemas.openxmlformats.org/drawingml/2006/main">
@@ -2546,7 +2546,7 @@
           </a:p>
           <a:p xmlns:a="http://schemas.openxmlformats.org/drawingml/2006/main">
             <a:r>
-              <a:t>3. (3:00–4:00) Task마다 반복 설명하던 사실을 저장소에 둔 설계 의도를 정리하고, 실제 활용 관찰은 S26로 넘긴다.</a:t>
+              <a:t>3. (3:00–4:00) Task마다 반복 설명하던 사실을 저장소에 둔 설계 의도를 정리하고, 실제 활용 관찰은 S34로 넘긴다.</a:t>
             </a:r>
           </a:p>
           <a:p xmlns:a="http://schemas.openxmlformats.org/drawingml/2006/main">
@@ -2576,7 +2576,7 @@
           </a:p>
           <a:p xmlns:a="http://schemas.openxmlformats.org/drawingml/2006/main">
             <a:r>
-              <a:t>Claim Boundary: 실제 파일이 그 상태에 존재했다는 근거다. 성능, 정확도, 토큰 절감 또는 AGENTS.md 단독 인과효과를 주장하지 않는다. 제품 코드·테스트·README는 그 상태 전환에서 바뀌지 않았다. S26의 지침 활용 관찰을 이 장의 결과로 앞당기지 않는다. 현재 Desktop 자동 로딩이나 교육 환경을 검증한 것이 아니다.</a:t>
+              <a:t>Claim Boundary: 실제 파일이 그 상태에 존재했다는 근거다. 성능, 정확도, 토큰 절감 또는 AGENTS.md 단독 인과효과를 주장하지 않는다. 제품 코드·테스트·README는 그 상태 전환에서 바뀌지 않았다. S34의 지침 활용 관찰을 이 장의 결과로 앞당기지 않는다. 현재 Desktop 자동 로딩이나 교육 환경을 검증한 것이 아니다.</a:t>
             </a:r>
           </a:p>
           <a:p xmlns:a="http://schemas.openxmlformats.org/drawingml/2006/main">
@@ -2616,7 +2616,7 @@
           </a:p>
           <a:p xmlns:a="http://schemas.openxmlformats.org/drawingml/2006/main">
             <a:r>
-              <a:t>Demo Operation: `production/ACT_2.pptx`의 S25 및 `production/preview/act2/S25.png`에 있는 실제 AGENTS.md 원문 발췌를 가리킨다. 편집기 screenshot이 아니다. Live/HYBRID는 발표 환경 검증 전까지 비활성이다.</a:t>
+              <a:t>Demo Operation: `production/ACT_2.pptx`의 S33 및 `production/preview/act2/S33.png`에 있는 실제 AGENTS.md 원문 발췌를 가리킨다. 편집기 screenshot이 아니다. Live/HYBRID는 발표 환경 검증 전까지 비활성이다.</a:t>
             </a:r>
           </a:p>
           <a:p xmlns:a="http://schemas.openxmlformats.org/drawingml/2006/main">
@@ -2646,7 +2646,7 @@
           </a:p>
           <a:p xmlns:a="http://schemas.openxmlformats.org/drawingml/2006/main">
             <a:r>
-              <a:t>Time Management: Demo 4분 유지. 1분 상태 전환, 2분 네 발췌, 1분 의미와 S26 handoff. 명령어 옵션별 설명은 생략한다.</a:t>
+              <a:t>Time Management: Demo 4분 유지. 1분 상태 전환, 2분 네 발췌, 1분 의미와 S34 handoff. 명령어 옵션별 설명은 생략한다.</a:t>
             </a:r>
           </a:p>
           <a:p xmlns:a="http://schemas.openxmlformats.org/drawingml/2006/main">
@@ -2656,7 +2656,7 @@
           </a:p>
           <a:p xmlns:a="http://schemas.openxmlformats.org/drawingml/2006/main">
             <a:r>
-              <a:t>Fallback: LOCAL STATIC ARTIFACT — 발표 기본 경로는 `production/ACT_2.pptx`의 S25 또는 `production/preview/act2/S25.png`다. 수정 초안 정적 화면은 존재하며 최종 release 경로·내용 일치는 통합 검토에서 확인한다. 실제 Trial 캡처나 현재 제품 실행으로 표현하지 않는다.</a:t>
+              <a:t>Fallback: LOCAL STATIC ARTIFACT — 발표 기본 경로는 `production/ACT_2.pptx`의 S33 또는 `production/preview/act2/S33.png`다. 수정 초안 정적 화면은 존재하며 최종 release 경로·내용 일치는 통합 검토에서 확인한다. 실제 Trial 캡처나 현재 제품 실행으로 표현하지 않는다.</a:t>
             </a:r>
           </a:p>
           <a:p xmlns:a="http://schemas.openxmlformats.org/drawingml/2006/main">
@@ -2736,7 +2736,7 @@
           <a:lstStyle xmlns:a="http://schemas.openxmlformats.org/drawingml/2006/main"/>
           <a:p xmlns:a="http://schemas.openxmlformats.org/drawingml/2006/main">
             <a:r>
-              <a:t>## S26 — 한 번의 사용에서 확인된 것</a:t>
+              <a:t>## S34 — 한 번의 사용에서 확인된 것</a:t>
             </a:r>
           </a:p>
           <a:p xmlns:a="http://schemas.openxmlformats.org/drawingml/2006/main">
@@ -2746,7 +2746,7 @@
           </a:p>
           <a:p xmlns:a="http://schemas.openxmlformats.org/drawingml/2006/main">
             <a:r>
-              <a:t>Slide ID: S26</a:t>
+              <a:t>Slide ID: S34</a:t>
             </a:r>
           </a:p>
           <a:p xmlns:a="http://schemas.openxmlformats.org/drawingml/2006/main">
@@ -2936,7 +2936,7 @@
           </a:p>
           <a:p xmlns:a="http://schemas.openxmlformats.org/drawingml/2006/main">
             <a:r>
-              <a:t>Fallback: LOCAL STATIC ARTIFACT — 발표 기본 경로는 `production/ACT_2.pptx`의 S26 또는 `production/preview/act2/S26.png`다. 수정 초안 정적 화면은 존재하며 최종 release 경로·내용 일치는 통합 검토에서 확인한다. 실제 Trial 캡처나 현재 제품 실행으로 표현하지 않는다.</a:t>
+              <a:t>Fallback: LOCAL STATIC ARTIFACT — 발표 기본 경로는 `production/ACT_2.pptx`의 S34 또는 `production/preview/act2/S34.png`다. 수정 초안 정적 화면은 존재하며 최종 release 경로·내용 일치는 통합 검토에서 확인한다. 실제 Trial 캡처나 현재 제품 실행으로 표현하지 않는다.</a:t>
             </a:r>
           </a:p>
           <a:p xmlns:a="http://schemas.openxmlformats.org/drawingml/2006/main">
@@ -3016,7 +3016,7 @@
           <a:lstStyle xmlns:a="http://schemas.openxmlformats.org/drawingml/2006/main"/>
           <a:p xmlns:a="http://schemas.openxmlformats.org/drawingml/2006/main">
             <a:r>
-              <a:t>## S27 — Task Prompt와 Project Context</a:t>
+              <a:t>## S35 — Task Prompt와 Project Context</a:t>
             </a:r>
           </a:p>
           <a:p xmlns:a="http://schemas.openxmlformats.org/drawingml/2006/main">
@@ -3026,7 +3026,7 @@
           </a:p>
           <a:p xmlns:a="http://schemas.openxmlformats.org/drawingml/2006/main">
             <a:r>
-              <a:t>Slide ID: S27</a:t>
+              <a:t>Slide ID: S35</a:t>
             </a:r>
           </a:p>
           <a:p xmlns:a="http://schemas.openxmlformats.org/drawingml/2006/main">
@@ -3126,7 +3126,7 @@
           </a:p>
           <a:p xmlns:a="http://schemas.openxmlformats.org/drawingml/2006/main">
             <a:r>
-              <a:t>화면 진행: S26에서 본 기록을 회수한 뒤 두 열의 수명을 비교한다. 왼쪽은 다음 작업에서 바뀔 목표, 오른쪽은 여러 작업에서 다시 참고할 사실이다. S23의 분류 질문을 처음부터 반복하지 않는다.</a:t>
+              <a:t>화면 진행: S34에서 본 기록을 회수한 뒤 두 열의 수명을 비교한다. 왼쪽은 다음 작업에서 바뀔 목표, 오른쪽은 여러 작업에서 다시 참고할 사실이다. S31의 분류 질문을 처음부터 반복하지 않는다.</a:t>
             </a:r>
           </a:p>
           <a:p xmlns:a="http://schemas.openxmlformats.org/drawingml/2006/main">
@@ -3136,7 +3136,7 @@
           </a:p>
           <a:p xmlns:a="http://schemas.openxmlformats.org/drawingml/2006/main">
             <a:r>
-              <a:t>Evidence / Source: BEAT-009–010, TRANS-003, CLM-0003, CLM-0005. TEACHING_MODEL / CONCEPTUAL; examples summarize S24–S26.</a:t>
+              <a:t>Evidence / Source: BEAT-009–010, TRANS-003, CLM-0003, CLM-0005. TEACHING_MODEL / CONCEPTUAL; examples summarize S32–S34.</a:t>
             </a:r>
           </a:p>
           <a:p xmlns:a="http://schemas.openxmlformats.org/drawingml/2006/main">
@@ -3226,7 +3226,7 @@
           </a:p>
           <a:p xmlns:a="http://schemas.openxmlformats.org/drawingml/2006/main">
             <a:r>
-              <a:t>Fallback: LOCAL STATIC ARTIFACT — 발표 기본 경로는 `production/ACT_2.pptx`의 S27 또는 `production/preview/act2/S27.png`다. 수정 초안 정적 화면은 존재하며 최종 release 경로·내용 일치는 통합 검토에서 확인한다. 실제 Trial 캡처나 현재 제품 실행으로 표현하지 않는다.</a:t>
+              <a:t>Fallback: LOCAL STATIC ARTIFACT — 발표 기본 경로는 `production/ACT_2.pptx`의 S35 또는 `production/preview/act2/S35.png`다. 수정 초안 정적 화면은 존재하며 최종 release 경로·내용 일치는 통합 검토에서 확인한다. 실제 Trial 캡처나 현재 제품 실행으로 표현하지 않는다.</a:t>
             </a:r>
           </a:p>
           <a:p xmlns:a="http://schemas.openxmlformats.org/drawingml/2006/main">
@@ -3306,7 +3306,7 @@
           <a:lstStyle xmlns:a="http://schemas.openxmlformats.org/drawingml/2006/main"/>
           <a:p xmlns:a="http://schemas.openxmlformats.org/drawingml/2006/main">
             <a:r>
-              <a:t>## S28 — 정확한 정보도 계속 늘어난다</a:t>
+              <a:t>## S36 — 정확한 정보도 계속 늘어난다</a:t>
             </a:r>
           </a:p>
           <a:p xmlns:a="http://schemas.openxmlformats.org/drawingml/2006/main">
@@ -3316,7 +3316,7 @@
           </a:p>
           <a:p xmlns:a="http://schemas.openxmlformats.org/drawingml/2006/main">
             <a:r>
-              <a:t>Slide ID: S28</a:t>
+              <a:t>Slide ID: S36</a:t>
             </a:r>
           </a:p>
           <a:p xmlns:a="http://schemas.openxmlformats.org/drawingml/2006/main">
@@ -3506,7 +3506,7 @@
           </a:p>
           <a:p xmlns:a="http://schemas.openxmlformats.org/drawingml/2006/main">
             <a:r>
-              <a:t>Fallback: LOCAL STATIC ARTIFACT — 발표 기본 경로는 `production/ACT_2.pptx`의 S28 또는 `production/preview/act2/S28.png`다. 수정 초안 정적 화면은 존재하며 최종 release 경로·내용 일치는 통합 검토에서 확인한다. 실제 Trial 캡처나 현재 제품 실행으로 표현하지 않는다.</a:t>
+              <a:t>Fallback: LOCAL STATIC ARTIFACT — 발표 기본 경로는 `production/ACT_2.pptx`의 S36 또는 `production/preview/act2/S36.png`다. 수정 초안 정적 화면은 존재하며 최종 release 경로·내용 일치는 통합 검토에서 확인한다. 실제 Trial 캡처나 현재 제품 실행으로 표현하지 않는다.</a:t>
             </a:r>
           </a:p>
           <a:p xmlns:a="http://schemas.openxmlformats.org/drawingml/2006/main">
@@ -3586,7 +3586,7 @@
           <a:lstStyle xmlns:a="http://schemas.openxmlformats.org/drawingml/2006/main"/>
           <a:p xmlns:a="http://schemas.openxmlformats.org/drawingml/2006/main">
             <a:r>
-              <a:t>## S29 — 정확하지만 이번 Task에는 불필요한 정보</a:t>
+              <a:t>## S37 — 정확하지만 이번 Task에는 불필요한 정보</a:t>
             </a:r>
           </a:p>
           <a:p xmlns:a="http://schemas.openxmlformats.org/drawingml/2006/main">
@@ -3596,7 +3596,7 @@
           </a:p>
           <a:p xmlns:a="http://schemas.openxmlformats.org/drawingml/2006/main">
             <a:r>
-              <a:t>Slide ID: S29</a:t>
+              <a:t>Slide ID: S37</a:t>
             </a:r>
           </a:p>
           <a:p xmlns:a="http://schemas.openxmlformats.org/drawingml/2006/main">
@@ -3786,7 +3786,7 @@
           </a:p>
           <a:p xmlns:a="http://schemas.openxmlformats.org/drawingml/2006/main">
             <a:r>
-              <a:t>Fallback: LOCAL STATIC ARTIFACT — 발표 기본 경로는 `production/ACT_2.pptx`의 S29 또는 `production/preview/act2/S29.png`다. 수정 초안 정적 화면은 존재하며 최종 release 경로·내용 일치는 통합 검토에서 확인한다. 실제 Trial 캡처나 현재 제품 실행으로 표현하지 않는다.</a:t>
+              <a:t>Fallback: LOCAL STATIC ARTIFACT — 발표 기본 경로는 `production/ACT_2.pptx`의 S37 또는 `production/preview/act2/S37.png`다. 수정 초안 정적 화면은 존재하며 최종 release 경로·내용 일치는 통합 검토에서 확인한다. 실제 Trial 캡처나 현재 제품 실행으로 표현하지 않는다.</a:t>
             </a:r>
           </a:p>
           <a:p xmlns:a="http://schemas.openxmlformats.org/drawingml/2006/main">
@@ -3866,7 +3866,7 @@
           <a:lstStyle xmlns:a="http://schemas.openxmlformats.org/drawingml/2006/main"/>
           <a:p xmlns:a="http://schemas.openxmlformats.org/drawingml/2006/main">
             <a:r>
-              <a:t>## S30 — 정보의 범위와 제공 시점</a:t>
+              <a:t>## S38 — 정보의 범위와 제공 시점</a:t>
             </a:r>
           </a:p>
           <a:p xmlns:a="http://schemas.openxmlformats.org/drawingml/2006/main">
@@ -3876,7 +3876,7 @@
           </a:p>
           <a:p xmlns:a="http://schemas.openxmlformats.org/drawingml/2006/main">
             <a:r>
-              <a:t>Slide ID: S30</a:t>
+              <a:t>Slide ID: S38</a:t>
             </a:r>
           </a:p>
           <a:p xmlns:a="http://schemas.openxmlformats.org/drawingml/2006/main">
@@ -4066,7 +4066,7 @@
           </a:p>
           <a:p xmlns:a="http://schemas.openxmlformats.org/drawingml/2006/main">
             <a:r>
-              <a:t>Fallback: LOCAL STATIC ARTIFACT — 발표 기본 경로는 `production/ACT_2.pptx`의 S30 또는 `production/preview/act2/S30.png`다. 수정 초안 정적 화면은 존재하며 최종 release 경로·내용 일치는 통합 검토에서 확인한다. 실제 Trial 캡처나 현재 제품 실행으로 표현하지 않는다.</a:t>
+              <a:t>Fallback: LOCAL STATIC ARTIFACT — 발표 기본 경로는 `production/ACT_2.pptx`의 S38 또는 `production/preview/act2/S38.png`다. 수정 초안 정적 화면은 존재하며 최종 release 경로·내용 일치는 통합 검토에서 확인한다. 실제 Trial 캡처나 현재 제품 실행으로 표현하지 않는다.</a:t>
             </a:r>
           </a:p>
           <a:p xmlns:a="http://schemas.openxmlformats.org/drawingml/2006/main">
@@ -4146,7 +4146,7 @@
           <a:lstStyle xmlns:a="http://schemas.openxmlformats.org/drawingml/2006/main"/>
           <a:p xmlns:a="http://schemas.openxmlformats.org/drawingml/2006/main">
             <a:r>
-              <a:t>## S31 — Long Context 연구가 말해주는 범위</a:t>
+              <a:t>## S39 — Long Context 연구가 말해주는 범위</a:t>
             </a:r>
           </a:p>
           <a:p xmlns:a="http://schemas.openxmlformats.org/drawingml/2006/main">
@@ -4156,7 +4156,7 @@
           </a:p>
           <a:p xmlns:a="http://schemas.openxmlformats.org/drawingml/2006/main">
             <a:r>
-              <a:t>Slide ID: S31</a:t>
+              <a:t>Slide ID: S39</a:t>
             </a:r>
           </a:p>
           <a:p xmlns:a="http://schemas.openxmlformats.org/drawingml/2006/main">
@@ -4356,7 +4356,7 @@
           </a:p>
           <a:p xmlns:a="http://schemas.openxmlformats.org/drawingml/2006/main">
             <a:r>
-              <a:t>Fallback: LOCAL STATIC ARTIFACT — 발표 기본 경로는 `production/ACT_2.pptx`의 S31 또는 `production/preview/act2/S31.png`다. 수정 초안 정적 화면은 존재하며 최종 release 경로·내용 일치는 통합 검토에서 확인한다. 실제 Trial 캡처나 현재 제품 실행으로 표현하지 않는다.</a:t>
+              <a:t>Fallback: LOCAL STATIC ARTIFACT — 발표 기본 경로는 `production/ACT_2.pptx`의 S39 또는 `production/preview/act2/S39.png`다. 수정 초안 정적 화면은 존재하며 최종 release 경로·내용 일치는 통합 검토에서 확인한다. 실제 Trial 캡처나 현재 제품 실행으로 표현하지 않는다.</a:t>
             </a:r>
           </a:p>
           <a:p xmlns:a="http://schemas.openxmlformats.org/drawingml/2006/main">
@@ -4436,7 +4436,7 @@
           <a:lstStyle xmlns:a="http://schemas.openxmlformats.org/drawingml/2006/main"/>
           <a:p xmlns:a="http://schemas.openxmlformats.org/drawingml/2006/main">
             <a:r>
-              <a:t>## S32 — 필요한 상세 정보로 가는 길</a:t>
+              <a:t>## S40 — 필요한 상세 정보로 가는 길</a:t>
             </a:r>
           </a:p>
           <a:p xmlns:a="http://schemas.openxmlformats.org/drawingml/2006/main">
@@ -4446,7 +4446,7 @@
           </a:p>
           <a:p xmlns:a="http://schemas.openxmlformats.org/drawingml/2006/main">
             <a:r>
-              <a:t>Slide ID: S32</a:t>
+              <a:t>Slide ID: S40</a:t>
             </a:r>
           </a:p>
           <a:p xmlns:a="http://schemas.openxmlformats.org/drawingml/2006/main">
@@ -4646,7 +4646,7 @@
           </a:p>
           <a:p xmlns:a="http://schemas.openxmlformats.org/drawingml/2006/main">
             <a:r>
-              <a:t>Fallback: LOCAL STATIC ARTIFACT — 발표 기본 경로는 `production/ACT_2.pptx`의 S32 또는 `production/preview/act2/S32.png`다. 수정 초안 정적 화면은 존재하며 최종 release 경로·내용 일치는 통합 검토에서 확인한다. 실제 Trial 캡처나 현재 제품 실행으로 표현하지 않는다.</a:t>
+              <a:t>Fallback: LOCAL STATIC ARTIFACT — 발표 기본 경로는 `production/ACT_2.pptx`의 S40 또는 `production/preview/act2/S40.png`다. 수정 초안 정적 화면은 존재하며 최종 release 경로·내용 일치는 통합 검토에서 확인한다. 실제 Trial 캡처나 현재 제품 실행으로 표현하지 않는다.</a:t>
             </a:r>
           </a:p>
           <a:p xmlns:a="http://schemas.openxmlformats.org/drawingml/2006/main">
@@ -4703,7 +4703,7 @@
           <p:cNvPr id="3" name="Title">
             <a:extLst xmlns:a="http://schemas.openxmlformats.org/drawingml/2006/main">
               <a:ext uri="{FF2B5EF4-FFF2-40B4-BE49-F238E27FC236}">
-                <a16:creationId xmlns:a16="http://schemas.microsoft.com/office/drawing/2014/main" id="{225AA4F9-44D3-41D6-82D9-9857035AAC61}"/>
+                <a16:creationId xmlns:a16="http://schemas.microsoft.com/office/drawing/2014/main" id="{007A0870-7C90-46FA-854D-4258A25D3851}"/>
               </a:ext>
             </a:extLst>
           </p:cNvPr>
@@ -4932,7 +4932,7 @@
           <p:cNvPr id="2" name="Subtitle">
             <a:extLst xmlns:a="http://schemas.openxmlformats.org/drawingml/2006/main">
               <a:ext uri="{FF2B5EF4-FFF2-40B4-BE49-F238E27FC236}">
-                <a16:creationId xmlns:a16="http://schemas.microsoft.com/office/drawing/2014/main" id="{E1DA430D-D4B9-46B1-BCE3-281A973B6C4E}"/>
+                <a16:creationId xmlns:a16="http://schemas.microsoft.com/office/drawing/2014/main" id="{0D5C75F9-2616-4143-9AAF-84B2E42A7676}"/>
               </a:ext>
             </a:extLst>
           </p:cNvPr>
@@ -5178,7 +5178,7 @@
           <p:cNvPr id="2" name="Section title">
             <a:extLst xmlns:a="http://schemas.openxmlformats.org/drawingml/2006/main">
               <a:ext uri="{FF2B5EF4-FFF2-40B4-BE49-F238E27FC236}">
-                <a16:creationId xmlns:a16="http://schemas.microsoft.com/office/drawing/2014/main" id="{7CFC81A1-A640-4D48-9EB6-2D2FFD2F882D}"/>
+                <a16:creationId xmlns:a16="http://schemas.microsoft.com/office/drawing/2014/main" id="{E32039E4-9C48-48AC-9653-C32111F23AE9}"/>
               </a:ext>
             </a:extLst>
           </p:cNvPr>
@@ -5424,7 +5424,7 @@
           <p:cNvPr id="3" name="Title">
             <a:extLst xmlns:a="http://schemas.openxmlformats.org/drawingml/2006/main">
               <a:ext uri="{FF2B5EF4-FFF2-40B4-BE49-F238E27FC236}">
-                <a16:creationId xmlns:a16="http://schemas.microsoft.com/office/drawing/2014/main" id="{D468D8D4-16C7-4257-92D1-EC2BB04A0327}"/>
+                <a16:creationId xmlns:a16="http://schemas.microsoft.com/office/drawing/2014/main" id="{44917C48-E4B6-471E-B4E0-DCF77361CAD9}"/>
               </a:ext>
             </a:extLst>
           </p:cNvPr>
@@ -5653,7 +5653,7 @@
           <p:cNvPr id="2" name="Body">
             <a:extLst xmlns:a="http://schemas.openxmlformats.org/drawingml/2006/main">
               <a:ext uri="{FF2B5EF4-FFF2-40B4-BE49-F238E27FC236}">
-                <a16:creationId xmlns:a16="http://schemas.microsoft.com/office/drawing/2014/main" id="{90AAB1DE-13CE-4D56-93DB-006873E60EB5}"/>
+                <a16:creationId xmlns:a16="http://schemas.microsoft.com/office/drawing/2014/main" id="{2C9FA366-C8D4-4CAF-BCBA-D67A04503383}"/>
               </a:ext>
             </a:extLst>
           </p:cNvPr>
@@ -5899,7 +5899,7 @@
           <p:cNvPr id="4" name="Title">
             <a:extLst xmlns:a="http://schemas.openxmlformats.org/drawingml/2006/main">
               <a:ext uri="{FF2B5EF4-FFF2-40B4-BE49-F238E27FC236}">
-                <a16:creationId xmlns:a16="http://schemas.microsoft.com/office/drawing/2014/main" id="{5C2CC74D-674A-4342-9737-97268476ACC0}"/>
+                <a16:creationId xmlns:a16="http://schemas.microsoft.com/office/drawing/2014/main" id="{053C24BB-79E9-47E6-B28A-8AC01C4179B6}"/>
               </a:ext>
             </a:extLst>
           </p:cNvPr>
@@ -6128,7 +6128,7 @@
           <p:cNvPr id="2" name="Left column">
             <a:extLst xmlns:a="http://schemas.openxmlformats.org/drawingml/2006/main">
               <a:ext uri="{FF2B5EF4-FFF2-40B4-BE49-F238E27FC236}">
-                <a16:creationId xmlns:a16="http://schemas.microsoft.com/office/drawing/2014/main" id="{CB884949-8E5E-41A0-8D77-C8945E8444E6}"/>
+                <a16:creationId xmlns:a16="http://schemas.microsoft.com/office/drawing/2014/main" id="{E7D58B39-83C6-45BD-944E-B54CC68D1642}"/>
               </a:ext>
             </a:extLst>
           </p:cNvPr>
@@ -6357,7 +6357,7 @@
           <p:cNvPr id="3" name="Right column">
             <a:extLst xmlns:a="http://schemas.openxmlformats.org/drawingml/2006/main">
               <a:ext uri="{FF2B5EF4-FFF2-40B4-BE49-F238E27FC236}">
-                <a16:creationId xmlns:a16="http://schemas.microsoft.com/office/drawing/2014/main" id="{1A623C67-415A-47DD-AC15-5F48F408D3F1}"/>
+                <a16:creationId xmlns:a16="http://schemas.microsoft.com/office/drawing/2014/main" id="{7D72AA0E-DF5C-4CDC-AD0B-F67BB168EAD3}"/>
               </a:ext>
             </a:extLst>
           </p:cNvPr>
@@ -6603,7 +6603,7 @@
           <p:cNvPr id="3" name="Title">
             <a:extLst xmlns:a="http://schemas.openxmlformats.org/drawingml/2006/main">
               <a:ext uri="{FF2B5EF4-FFF2-40B4-BE49-F238E27FC236}">
-                <a16:creationId xmlns:a16="http://schemas.microsoft.com/office/drawing/2014/main" id="{28E3289F-6B7B-4AD6-BF51-24C557B95605}"/>
+                <a16:creationId xmlns:a16="http://schemas.microsoft.com/office/drawing/2014/main" id="{AE56343C-FE5D-419E-99D9-923904A47945}"/>
               </a:ext>
             </a:extLst>
           </p:cNvPr>
@@ -6832,7 +6832,7 @@
           <p:cNvPr id="2" name="Left column">
             <a:extLst xmlns:a="http://schemas.openxmlformats.org/drawingml/2006/main">
               <a:ext uri="{FF2B5EF4-FFF2-40B4-BE49-F238E27FC236}">
-                <a16:creationId xmlns:a16="http://schemas.microsoft.com/office/drawing/2014/main" id="{2D240CBA-2679-494D-8F8C-75CA73460C99}"/>
+                <a16:creationId xmlns:a16="http://schemas.microsoft.com/office/drawing/2014/main" id="{06D1CE9B-FE8A-4118-8F77-2B83D94BF2C7}"/>
               </a:ext>
             </a:extLst>
           </p:cNvPr>
@@ -7099,12 +7099,12 @@
   </p:cSld>
   <p:clrMap bg1="lt1" tx1="dk1" bg2="lt2" tx2="dk2" accent1="accent1" accent2="accent2" accent3="accent3" accent4="accent4" accent5="accent5" accent6="accent6" hlink="hlink" folHlink="folHlink"/>
   <p:sldLayoutIdLst>
-    <p:sldLayoutId xmlns:r="http://schemas.openxmlformats.org/officeDocument/2006/relationships" id="2147483649" r:id="R52d0a4563072455c"/>
-    <p:sldLayoutId xmlns:r="http://schemas.openxmlformats.org/officeDocument/2006/relationships" id="2147483650" r:id="Rdbd468a25e6d4380"/>
-    <p:sldLayoutId xmlns:r="http://schemas.openxmlformats.org/officeDocument/2006/relationships" id="2147483651" r:id="Rba9be64c0092470b"/>
-    <p:sldLayoutId xmlns:r="http://schemas.openxmlformats.org/officeDocument/2006/relationships" id="2147483652" r:id="Rd188ade1b3854ab5"/>
-    <p:sldLayoutId xmlns:r="http://schemas.openxmlformats.org/officeDocument/2006/relationships" id="2147483653" r:id="R33da9d9613b048b7"/>
-    <p:sldLayoutId xmlns:r="http://schemas.openxmlformats.org/officeDocument/2006/relationships" id="2147483654" r:id="R5ad62035cb234dc2"/>
+    <p:sldLayoutId xmlns:r="http://schemas.openxmlformats.org/officeDocument/2006/relationships" id="2147483649" r:id="R4a51a0b39c4141d2"/>
+    <p:sldLayoutId xmlns:r="http://schemas.openxmlformats.org/officeDocument/2006/relationships" id="2147483650" r:id="Rf9bd4775177e4486"/>
+    <p:sldLayoutId xmlns:r="http://schemas.openxmlformats.org/officeDocument/2006/relationships" id="2147483651" r:id="Rb45675ea0eb241d2"/>
+    <p:sldLayoutId xmlns:r="http://schemas.openxmlformats.org/officeDocument/2006/relationships" id="2147483652" r:id="R3dcd61b9fbf8483a"/>
+    <p:sldLayoutId xmlns:r="http://schemas.openxmlformats.org/officeDocument/2006/relationships" id="2147483653" r:id="Ra1220709701b4bb8"/>
+    <p:sldLayoutId xmlns:r="http://schemas.openxmlformats.org/officeDocument/2006/relationships" id="2147483654" r:id="R2d5e7bb1917d488d"/>
   </p:sldLayoutIdLst>
   <p:txStyles>
     <p:titleStyle>
@@ -7655,7 +7655,7 @@
           <p:cNvPr id="24" name="ACT 2 · 반복되는 프로젝트 설명">
             <a:extLst xmlns:a="http://schemas.openxmlformats.org/drawingml/2006/main">
               <a:ext uri="{FF2B5EF4-FFF2-40B4-BE49-F238E27FC236}">
-                <a16:creationId xmlns:a16="http://schemas.microsoft.com/office/drawing/2014/main" id="{D3466745-7086-4799-A2B4-210DCBEC9A2A}"/>
+                <a16:creationId xmlns:a16="http://schemas.microsoft.com/office/drawing/2014/main" id="{4A4247C4-E68E-4B22-AE4E-3C3CBD2D4FBC}"/>
               </a:ext>
             </a:extLst>
           </p:cNvPr>
@@ -7810,10 +7810,10 @@
       </p:sp>
       <p:sp>
         <p:nvSpPr>
-          <p:cNvPr id="2" name="S24">
+          <p:cNvPr id="2" name="S32">
             <a:extLst xmlns:a="http://schemas.openxmlformats.org/drawingml/2006/main">
               <a:ext uri="{FF2B5EF4-FFF2-40B4-BE49-F238E27FC236}">
-                <a16:creationId xmlns:a16="http://schemas.microsoft.com/office/drawing/2014/main" id="{D9D048CA-3E44-4B40-91F2-D725F5976779}"/>
+                <a16:creationId xmlns:a16="http://schemas.microsoft.com/office/drawing/2014/main" id="{6E2F74F3-98D9-4A65-BB78-E740F1BFD535}"/>
               </a:ext>
             </a:extLst>
           </p:cNvPr>
@@ -7961,7 +7961,7 @@
                 <a:ea typeface="Malgun Gothic"/>
                 <a:cs typeface="Malgun Gothic"/>
               </a:rPr>
-              <a:t>S24</a:t>
+              <a:t>S32</a:t>
             </a:r>
           </a:p>
         </p:txBody>
@@ -7971,7 +7971,7 @@
           <p:cNvPr id="3" name="다른 Task에 같은 설명이 반복된다">
             <a:extLst xmlns:a="http://schemas.openxmlformats.org/drawingml/2006/main">
               <a:ext uri="{FF2B5EF4-FFF2-40B4-BE49-F238E27FC236}">
-                <a16:creationId xmlns:a16="http://schemas.microsoft.com/office/drawing/2014/main" id="{26895B03-7C22-4664-B0BA-6E93F70207D7}"/>
+                <a16:creationId xmlns:a16="http://schemas.microsoft.com/office/drawing/2014/main" id="{9523D165-75B4-49CD-AC6A-A086771D57D0}"/>
               </a:ext>
             </a:extLst>
           </p:cNvPr>
@@ -8129,7 +8129,7 @@
           <p:cNvPr id="4" name="">
             <a:extLst xmlns:a="http://schemas.openxmlformats.org/drawingml/2006/main">
               <a:ext uri="{FF2B5EF4-FFF2-40B4-BE49-F238E27FC236}">
-                <a16:creationId xmlns:a16="http://schemas.microsoft.com/office/drawing/2014/main" id="{1B025458-C137-4679-802C-1315305F8918}"/>
+                <a16:creationId xmlns:a16="http://schemas.microsoft.com/office/drawing/2014/main" id="{86F2EDA0-A5CF-4134-B92D-27624D75D98B}"/>
               </a:ext>
             </a:extLst>
           </p:cNvPr>
@@ -8160,7 +8160,7 @@
           <p:cNvPr id="5" name="교육용 구성 사례 · Bug fix / Performance / README 작업">
             <a:extLst xmlns:a="http://schemas.openxmlformats.org/drawingml/2006/main">
               <a:ext uri="{FF2B5EF4-FFF2-40B4-BE49-F238E27FC236}">
-                <a16:creationId xmlns:a16="http://schemas.microsoft.com/office/drawing/2014/main" id="{60820342-7D9F-43A0-B314-382C3F8588E7}"/>
+                <a16:creationId xmlns:a16="http://schemas.microsoft.com/office/drawing/2014/main" id="{D1467637-EDAD-435A-BAF5-4DE5012C1BB0}"/>
               </a:ext>
             </a:extLst>
           </p:cNvPr>
@@ -8318,7 +8318,7 @@
           <p:cNvPr id="6" name="서로 다른 요청에 같은 프로젝트 정보가 반복되는 상황을 보여준다">
             <a:extLst xmlns:a="http://schemas.openxmlformats.org/drawingml/2006/main">
               <a:ext uri="{FF2B5EF4-FFF2-40B4-BE49-F238E27FC236}">
-                <a16:creationId xmlns:a16="http://schemas.microsoft.com/office/drawing/2014/main" id="{DC44D61A-160F-4BB4-9BAF-FBD543350AA8}"/>
+                <a16:creationId xmlns:a16="http://schemas.microsoft.com/office/drawing/2014/main" id="{8A2F0381-DADD-42B4-AACA-3F5927D8FDD7}"/>
               </a:ext>
             </a:extLst>
           </p:cNvPr>
@@ -8476,7 +8476,7 @@
           <p:cNvPr id="7" name="버그 수정">
             <a:extLst xmlns:a="http://schemas.openxmlformats.org/drawingml/2006/main">
               <a:ext uri="{FF2B5EF4-FFF2-40B4-BE49-F238E27FC236}">
-                <a16:creationId xmlns:a16="http://schemas.microsoft.com/office/drawing/2014/main" id="{72524DA4-1D0F-495E-9B2B-5A09F09C6E4D}"/>
+                <a16:creationId xmlns:a16="http://schemas.microsoft.com/office/drawing/2014/main" id="{62AE1473-8A9E-4A2D-9F77-07510B8FBF0F}"/>
               </a:ext>
             </a:extLst>
           </p:cNvPr>
@@ -8634,7 +8634,7 @@
           <p:cNvPr id="8" name="crop 경계를 수정해줘">
             <a:extLst xmlns:a="http://schemas.openxmlformats.org/drawingml/2006/main">
               <a:ext uri="{FF2B5EF4-FFF2-40B4-BE49-F238E27FC236}">
-                <a16:creationId xmlns:a16="http://schemas.microsoft.com/office/drawing/2014/main" id="{04F9214B-4EAE-4C70-A30A-7A785AF9F65D}"/>
+                <a16:creationId xmlns:a16="http://schemas.microsoft.com/office/drawing/2014/main" id="{89BDABD7-D870-42B2-AE63-EC0FA23C68AF}"/>
               </a:ext>
             </a:extLst>
           </p:cNvPr>
@@ -8792,7 +8792,7 @@
           <p:cNvPr id="9" name="">
             <a:extLst xmlns:a="http://schemas.openxmlformats.org/drawingml/2006/main">
               <a:ext uri="{FF2B5EF4-FFF2-40B4-BE49-F238E27FC236}">
-                <a16:creationId xmlns:a16="http://schemas.microsoft.com/office/drawing/2014/main" id="{B55DC843-DFB6-4200-8AB0-C9DBAB101B65}"/>
+                <a16:creationId xmlns:a16="http://schemas.microsoft.com/office/drawing/2014/main" id="{DB075F8A-921A-4550-AD77-CF13D2FAACB7}"/>
               </a:ext>
             </a:extLst>
           </p:cNvPr>
@@ -8823,7 +8823,7 @@
           <p:cNvPr id="10" name="">
             <a:extLst xmlns:a="http://schemas.openxmlformats.org/drawingml/2006/main">
               <a:ext uri="{FF2B5EF4-FFF2-40B4-BE49-F238E27FC236}">
-                <a16:creationId xmlns:a16="http://schemas.microsoft.com/office/drawing/2014/main" id="{60302E61-B39D-4306-B3F5-E526F9777823}"/>
+                <a16:creationId xmlns:a16="http://schemas.microsoft.com/office/drawing/2014/main" id="{1BF95B93-5717-4338-A4C3-E2DA1E4BC8E4}"/>
               </a:ext>
             </a:extLst>
           </p:cNvPr>
@@ -8854,7 +8854,7 @@
           <p:cNvPr id="11" name="지정된 테스트 실행&#10;의존성 추가에는 근거 필요&#10;로컬 합성 데이터 사용&#10;기존 동작 보존">
             <a:extLst xmlns:a="http://schemas.openxmlformats.org/drawingml/2006/main">
               <a:ext uri="{FF2B5EF4-FFF2-40B4-BE49-F238E27FC236}">
-                <a16:creationId xmlns:a16="http://schemas.microsoft.com/office/drawing/2014/main" id="{4A6092B1-2D09-4BA8-9FF9-B08D7AAA10E1}"/>
+                <a16:creationId xmlns:a16="http://schemas.microsoft.com/office/drawing/2014/main" id="{251B0F81-7530-413E-96CB-3B04B3859EAD}"/>
               </a:ext>
             </a:extLst>
           </p:cNvPr>
@@ -9081,7 +9081,7 @@
           <p:cNvPr id="12" name="성능 조사">
             <a:extLst xmlns:a="http://schemas.openxmlformats.org/drawingml/2006/main">
               <a:ext uri="{FF2B5EF4-FFF2-40B4-BE49-F238E27FC236}">
-                <a16:creationId xmlns:a16="http://schemas.microsoft.com/office/drawing/2014/main" id="{CFFF52F9-CAE1-49FD-8F64-D24C80F30E09}"/>
+                <a16:creationId xmlns:a16="http://schemas.microsoft.com/office/drawing/2014/main" id="{6A977824-D12A-428D-9A7F-C63C94B572E8}"/>
               </a:ext>
             </a:extLst>
           </p:cNvPr>
@@ -9239,7 +9239,7 @@
           <p:cNvPr id="13" name="통계 계산을 조사해줘">
             <a:extLst xmlns:a="http://schemas.openxmlformats.org/drawingml/2006/main">
               <a:ext uri="{FF2B5EF4-FFF2-40B4-BE49-F238E27FC236}">
-                <a16:creationId xmlns:a16="http://schemas.microsoft.com/office/drawing/2014/main" id="{F90DD313-9B47-4DB3-BC95-6E70961A2465}"/>
+                <a16:creationId xmlns:a16="http://schemas.microsoft.com/office/drawing/2014/main" id="{D280E139-2872-4E85-8983-302191E4A33A}"/>
               </a:ext>
             </a:extLst>
           </p:cNvPr>
@@ -9397,7 +9397,7 @@
           <p:cNvPr id="14" name="">
             <a:extLst xmlns:a="http://schemas.openxmlformats.org/drawingml/2006/main">
               <a:ext uri="{FF2B5EF4-FFF2-40B4-BE49-F238E27FC236}">
-                <a16:creationId xmlns:a16="http://schemas.microsoft.com/office/drawing/2014/main" id="{E4A1DA25-4AA8-416B-876F-63F12BA40E9C}"/>
+                <a16:creationId xmlns:a16="http://schemas.microsoft.com/office/drawing/2014/main" id="{E30A9A6A-9398-4289-B7FD-7583A1158B7D}"/>
               </a:ext>
             </a:extLst>
           </p:cNvPr>
@@ -9428,7 +9428,7 @@
           <p:cNvPr id="15" name="">
             <a:extLst xmlns:a="http://schemas.openxmlformats.org/drawingml/2006/main">
               <a:ext uri="{FF2B5EF4-FFF2-40B4-BE49-F238E27FC236}">
-                <a16:creationId xmlns:a16="http://schemas.microsoft.com/office/drawing/2014/main" id="{719B974C-6407-47C4-809D-30AB2B3D54F1}"/>
+                <a16:creationId xmlns:a16="http://schemas.microsoft.com/office/drawing/2014/main" id="{EBA1AC4F-2A09-4BE6-81F4-83EF90C6574B}"/>
               </a:ext>
             </a:extLst>
           </p:cNvPr>
@@ -9459,7 +9459,7 @@
           <p:cNvPr id="16" name="지정된 테스트 실행&#10;의존성 추가에는 근거 필요&#10;로컬 합성 데이터 사용&#10;기존 동작 보존">
             <a:extLst xmlns:a="http://schemas.openxmlformats.org/drawingml/2006/main">
               <a:ext uri="{FF2B5EF4-FFF2-40B4-BE49-F238E27FC236}">
-                <a16:creationId xmlns:a16="http://schemas.microsoft.com/office/drawing/2014/main" id="{922DAC3A-178C-4814-A300-C853C3F49DE4}"/>
+                <a16:creationId xmlns:a16="http://schemas.microsoft.com/office/drawing/2014/main" id="{7DB0345B-2446-43D5-BA91-63D465F99A2B}"/>
               </a:ext>
             </a:extLst>
           </p:cNvPr>
@@ -9686,7 +9686,7 @@
           <p:cNvPr id="17" name="README 수정">
             <a:extLst xmlns:a="http://schemas.openxmlformats.org/drawingml/2006/main">
               <a:ext uri="{FF2B5EF4-FFF2-40B4-BE49-F238E27FC236}">
-                <a16:creationId xmlns:a16="http://schemas.microsoft.com/office/drawing/2014/main" id="{0092E21B-311F-4F6F-8AFA-1601F6026E39}"/>
+                <a16:creationId xmlns:a16="http://schemas.microsoft.com/office/drawing/2014/main" id="{FB5E309A-43D5-4747-B374-FE48DB385FF8}"/>
               </a:ext>
             </a:extLst>
           </p:cNvPr>
@@ -9844,7 +9844,7 @@
           <p:cNvPr id="18" name="빌드 안내를 명확히 해줘">
             <a:extLst xmlns:a="http://schemas.openxmlformats.org/drawingml/2006/main">
               <a:ext uri="{FF2B5EF4-FFF2-40B4-BE49-F238E27FC236}">
-                <a16:creationId xmlns:a16="http://schemas.microsoft.com/office/drawing/2014/main" id="{126DF129-70AB-444B-9C35-86F3541EBB20}"/>
+                <a16:creationId xmlns:a16="http://schemas.microsoft.com/office/drawing/2014/main" id="{0F5DA080-CA6A-49C1-90E1-BDF2A837131A}"/>
               </a:ext>
             </a:extLst>
           </p:cNvPr>
@@ -10002,7 +10002,7 @@
           <p:cNvPr id="19" name="">
             <a:extLst xmlns:a="http://schemas.openxmlformats.org/drawingml/2006/main">
               <a:ext uri="{FF2B5EF4-FFF2-40B4-BE49-F238E27FC236}">
-                <a16:creationId xmlns:a16="http://schemas.microsoft.com/office/drawing/2014/main" id="{588F7A3F-F079-44C7-891E-4CE9E2D4C5DD}"/>
+                <a16:creationId xmlns:a16="http://schemas.microsoft.com/office/drawing/2014/main" id="{10535672-104A-41C8-B045-245837C40A3E}"/>
               </a:ext>
             </a:extLst>
           </p:cNvPr>
@@ -10033,7 +10033,7 @@
           <p:cNvPr id="20" name="">
             <a:extLst xmlns:a="http://schemas.openxmlformats.org/drawingml/2006/main">
               <a:ext uri="{FF2B5EF4-FFF2-40B4-BE49-F238E27FC236}">
-                <a16:creationId xmlns:a16="http://schemas.microsoft.com/office/drawing/2014/main" id="{BE91894A-C516-41DA-80DF-8B092C0F5BF8}"/>
+                <a16:creationId xmlns:a16="http://schemas.microsoft.com/office/drawing/2014/main" id="{0AFB77C3-A29D-439B-A7E9-ECBF21164EF1}"/>
               </a:ext>
             </a:extLst>
           </p:cNvPr>
@@ -10064,7 +10064,7 @@
           <p:cNvPr id="21" name="지정된 테스트 실행&#10;의존성 추가에는 근거 필요&#10;로컬 합성 데이터 사용&#10;기존 동작 보존">
             <a:extLst xmlns:a="http://schemas.openxmlformats.org/drawingml/2006/main">
               <a:ext uri="{FF2B5EF4-FFF2-40B4-BE49-F238E27FC236}">
-                <a16:creationId xmlns:a16="http://schemas.microsoft.com/office/drawing/2014/main" id="{006D8636-F730-450E-8B88-B3B8F4B47928}"/>
+                <a16:creationId xmlns:a16="http://schemas.microsoft.com/office/drawing/2014/main" id="{40773AD9-3DCB-4D7E-A421-8ADDE681FF34}"/>
               </a:ext>
             </a:extLst>
           </p:cNvPr>
@@ -10291,7 +10291,7 @@
           <p:cNvPr id="22" name="요청은 다른데, 아래 설명은 왜 계속 같을까?">
             <a:extLst xmlns:a="http://schemas.openxmlformats.org/drawingml/2006/main">
               <a:ext uri="{FF2B5EF4-FFF2-40B4-BE49-F238E27FC236}">
-                <a16:creationId xmlns:a16="http://schemas.microsoft.com/office/drawing/2014/main" id="{6501C640-C329-4596-AD6F-C42FD6A5E664}"/>
+                <a16:creationId xmlns:a16="http://schemas.microsoft.com/office/drawing/2014/main" id="{E23EADF8-91C3-4C89-B92C-CA6428EB86A8}"/>
               </a:ext>
             </a:extLst>
           </p:cNvPr>
@@ -10449,7 +10449,7 @@
           <p:cNvPr id="23" name="Legacy module connection">
             <a:extLst xmlns:a="http://schemas.openxmlformats.org/drawingml/2006/main">
               <a:ext uri="{FF2B5EF4-FFF2-40B4-BE49-F238E27FC236}">
-                <a16:creationId xmlns:a16="http://schemas.microsoft.com/office/drawing/2014/main" id="{8290108A-3614-4841-A0DA-26D805D39E96}"/>
+                <a16:creationId xmlns:a16="http://schemas.microsoft.com/office/drawing/2014/main" id="{A5558DDC-B0A1-40E3-B93F-0AC8BBAB452F}"/>
               </a:ext>
             </a:extLst>
           </p:cNvPr>
@@ -10605,7 +10605,7 @@
     </p:spTree>
     <p:extLst>
       <p:ext uri="{BB962C8B-B14F-4D97-AF65-F5344CB8AC3E}">
-        <p14:creationId xmlns:p14="http://schemas.microsoft.com/office/powerpoint/2010/main" val="1007247781"/>
+        <p14:creationId xmlns:p14="http://schemas.microsoft.com/office/powerpoint/2010/main" val="1947119079"/>
       </p:ext>
     </p:extLst>
   </p:cSld>
@@ -10636,7 +10636,7 @@
           <p:cNvPr id="24" name="ACT 2 · Core에 남길 기본 안내">
             <a:extLst xmlns:a="http://schemas.openxmlformats.org/drawingml/2006/main">
               <a:ext uri="{FF2B5EF4-FFF2-40B4-BE49-F238E27FC236}">
-                <a16:creationId xmlns:a16="http://schemas.microsoft.com/office/drawing/2014/main" id="{8A3A73D2-3997-43A9-AC7B-1719455D8780}"/>
+                <a16:creationId xmlns:a16="http://schemas.microsoft.com/office/drawing/2014/main" id="{F279B446-B9D8-47CE-88F2-C93B32D5BF8A}"/>
               </a:ext>
             </a:extLst>
           </p:cNvPr>
@@ -10791,10 +10791,10 @@
       </p:sp>
       <p:sp>
         <p:nvSpPr>
-          <p:cNvPr id="2" name="S33">
+          <p:cNvPr id="2" name="S41">
             <a:extLst xmlns:a="http://schemas.openxmlformats.org/drawingml/2006/main">
               <a:ext uri="{FF2B5EF4-FFF2-40B4-BE49-F238E27FC236}">
-                <a16:creationId xmlns:a16="http://schemas.microsoft.com/office/drawing/2014/main" id="{B5115B91-9E4E-4496-AD3B-4E628F3B4B61}"/>
+                <a16:creationId xmlns:a16="http://schemas.microsoft.com/office/drawing/2014/main" id="{CFDDF731-0B6E-49F5-BB51-A8EDC25B1592}"/>
               </a:ext>
             </a:extLst>
           </p:cNvPr>
@@ -10942,7 +10942,7 @@
                 <a:ea typeface="Malgun Gothic"/>
                 <a:cs typeface="Malgun Gothic"/>
               </a:rPr>
-              <a:t>S33</a:t>
+              <a:t>S41</a:t>
             </a:r>
           </a:p>
         </p:txBody>
@@ -10952,7 +10952,7 @@
           <p:cNvPr id="3" name="Core Context에서 상세 정보로 가는 길">
             <a:extLst xmlns:a="http://schemas.openxmlformats.org/drawingml/2006/main">
               <a:ext uri="{FF2B5EF4-FFF2-40B4-BE49-F238E27FC236}">
-                <a16:creationId xmlns:a16="http://schemas.microsoft.com/office/drawing/2014/main" id="{D70A43BF-F1D3-4E90-80F3-81023D8DE907}"/>
+                <a16:creationId xmlns:a16="http://schemas.microsoft.com/office/drawing/2014/main" id="{0FABFB5F-FE2A-4D60-A995-9C9C35AA059B}"/>
               </a:ext>
             </a:extLst>
           </p:cNvPr>
@@ -11110,7 +11110,7 @@
           <p:cNvPr id="4" name="">
             <a:extLst xmlns:a="http://schemas.openxmlformats.org/drawingml/2006/main">
               <a:ext uri="{FF2B5EF4-FFF2-40B4-BE49-F238E27FC236}">
-                <a16:creationId xmlns:a16="http://schemas.microsoft.com/office/drawing/2014/main" id="{AF8F4016-D7A2-4651-9A67-B6D1146A7C80}"/>
+                <a16:creationId xmlns:a16="http://schemas.microsoft.com/office/drawing/2014/main" id="{5D14997F-3F88-4914-BB61-E3CB0E82A281}"/>
               </a:ext>
             </a:extLst>
           </p:cNvPr>
@@ -11141,7 +11141,7 @@
           <p:cNvPr id="5" name="교육용 정보 설계 · Root/Core는 상세 정보의 출발점">
             <a:extLst xmlns:a="http://schemas.openxmlformats.org/drawingml/2006/main">
               <a:ext uri="{FF2B5EF4-FFF2-40B4-BE49-F238E27FC236}">
-                <a16:creationId xmlns:a16="http://schemas.microsoft.com/office/drawing/2014/main" id="{6CFF8BFC-8B3E-4C10-88D7-8E3BC77A3C78}"/>
+                <a16:creationId xmlns:a16="http://schemas.microsoft.com/office/drawing/2014/main" id="{4871D425-F804-406A-8918-288142E079A2}"/>
               </a:ext>
             </a:extLst>
           </p:cNvPr>
@@ -11299,7 +11299,7 @@
           <p:cNvPr id="6" name="C++ 예: build/test 진입점과 기본 제약 → 알고리즘 계약·하드웨어 조건">
             <a:extLst xmlns:a="http://schemas.openxmlformats.org/drawingml/2006/main">
               <a:ext uri="{FF2B5EF4-FFF2-40B4-BE49-F238E27FC236}">
-                <a16:creationId xmlns:a16="http://schemas.microsoft.com/office/drawing/2014/main" id="{27111A9B-27E8-4CB5-B61C-9B15AF96638D}"/>
+                <a16:creationId xmlns:a16="http://schemas.microsoft.com/office/drawing/2014/main" id="{BA50DB9F-E909-41F7-B26C-244F43C68682}"/>
               </a:ext>
             </a:extLst>
           </p:cNvPr>
@@ -11457,7 +11457,7 @@
           <p:cNvPr id="7" name="무엇을 항상 읽고, 무엇을 필요할 때 찾게 할까?">
             <a:extLst xmlns:a="http://schemas.openxmlformats.org/drawingml/2006/main">
               <a:ext uri="{FF2B5EF4-FFF2-40B4-BE49-F238E27FC236}">
-                <a16:creationId xmlns:a16="http://schemas.microsoft.com/office/drawing/2014/main" id="{70FC77B1-F8E9-45C6-91D9-440D4DB2213B}"/>
+                <a16:creationId xmlns:a16="http://schemas.microsoft.com/office/drawing/2014/main" id="{9BAF24EF-0706-4B92-BAC8-53342A9B2B39}"/>
               </a:ext>
             </a:extLst>
           </p:cNvPr>
@@ -11615,7 +11615,7 @@
           <p:cNvPr id="8" name="">
             <a:extLst xmlns:a="http://schemas.openxmlformats.org/drawingml/2006/main">
               <a:ext uri="{FF2B5EF4-FFF2-40B4-BE49-F238E27FC236}">
-                <a16:creationId xmlns:a16="http://schemas.microsoft.com/office/drawing/2014/main" id="{2F262897-D382-4D7B-802A-EEDCE54C7DDE}"/>
+                <a16:creationId xmlns:a16="http://schemas.microsoft.com/office/drawing/2014/main" id="{DAD28BBB-A3D7-4FB5-9B23-FBC7C9B9574C}"/>
               </a:ext>
             </a:extLst>
           </p:cNvPr>
@@ -11646,7 +11646,7 @@
           <p:cNvPr id="9" name="CORE · 기본 안내">
             <a:extLst xmlns:a="http://schemas.openxmlformats.org/drawingml/2006/main">
               <a:ext uri="{FF2B5EF4-FFF2-40B4-BE49-F238E27FC236}">
-                <a16:creationId xmlns:a16="http://schemas.microsoft.com/office/drawing/2014/main" id="{C901F962-E276-45FC-9F73-A5B45C22FB53}"/>
+                <a16:creationId xmlns:a16="http://schemas.microsoft.com/office/drawing/2014/main" id="{9571863D-5A34-4DDC-97E9-27FA34163964}"/>
               </a:ext>
             </a:extLst>
           </p:cNvPr>
@@ -11804,7 +11804,7 @@
           <p:cNvPr id="10" name="프로젝트의 목적&#10;항상 지켜야 할 제약&#10;상세 정보를 찾을 위치">
             <a:extLst xmlns:a="http://schemas.openxmlformats.org/drawingml/2006/main">
               <a:ext uri="{FF2B5EF4-FFF2-40B4-BE49-F238E27FC236}">
-                <a16:creationId xmlns:a16="http://schemas.microsoft.com/office/drawing/2014/main" id="{F63D33FC-C5DF-4B82-B14A-FA9A3527DBE9}"/>
+                <a16:creationId xmlns:a16="http://schemas.microsoft.com/office/drawing/2014/main" id="{248A41FC-0868-476A-B518-66D0511D7ED7}"/>
               </a:ext>
             </a:extLst>
           </p:cNvPr>
@@ -12008,7 +12008,7 @@
           <p:cNvPr id="11" name="">
             <a:extLst xmlns:a="http://schemas.openxmlformats.org/drawingml/2006/main">
               <a:ext uri="{FF2B5EF4-FFF2-40B4-BE49-F238E27FC236}">
-                <a16:creationId xmlns:a16="http://schemas.microsoft.com/office/drawing/2014/main" id="{D3E0FB86-E057-4B5E-842D-A780021D6204}"/>
+                <a16:creationId xmlns:a16="http://schemas.microsoft.com/office/drawing/2014/main" id="{748198BC-43F0-4A8D-A73B-84148D550917}"/>
               </a:ext>
             </a:extLst>
           </p:cNvPr>
@@ -12038,7 +12038,7 @@
           <p:cNvPr id="12" name="DETAIL · 필요한 상세">
             <a:extLst xmlns:a="http://schemas.openxmlformats.org/drawingml/2006/main">
               <a:ext uri="{FF2B5EF4-FFF2-40B4-BE49-F238E27FC236}">
-                <a16:creationId xmlns:a16="http://schemas.microsoft.com/office/drawing/2014/main" id="{996FCB9D-3978-4D7B-BC45-709B39176942}"/>
+                <a16:creationId xmlns:a16="http://schemas.microsoft.com/office/drawing/2014/main" id="{1DE7764A-50AD-4A4C-A09F-EEC2990441F1}"/>
               </a:ext>
             </a:extLst>
           </p:cNvPr>
@@ -12196,7 +12196,7 @@
           <p:cNvPr id="13" name="">
             <a:extLst xmlns:a="http://schemas.openxmlformats.org/drawingml/2006/main">
               <a:ext uri="{FF2B5EF4-FFF2-40B4-BE49-F238E27FC236}">
-                <a16:creationId xmlns:a16="http://schemas.microsoft.com/office/drawing/2014/main" id="{9FC7A149-9317-4827-B8D5-505E8C815283}"/>
+                <a16:creationId xmlns:a16="http://schemas.microsoft.com/office/drawing/2014/main" id="{8968EEF4-1F6B-43E5-AB86-425DDA227415}"/>
               </a:ext>
             </a:extLst>
           </p:cNvPr>
@@ -12227,7 +12227,7 @@
           <p:cNvPr id="14" name="architecture">
             <a:extLst xmlns:a="http://schemas.openxmlformats.org/drawingml/2006/main">
               <a:ext uri="{FF2B5EF4-FFF2-40B4-BE49-F238E27FC236}">
-                <a16:creationId xmlns:a16="http://schemas.microsoft.com/office/drawing/2014/main" id="{523D9235-4A74-46B4-A852-DDAC9C5DFB42}"/>
+                <a16:creationId xmlns:a16="http://schemas.microsoft.com/office/drawing/2014/main" id="{6A2E7FDF-059E-40CB-A557-CAFECCD8AB23}"/>
               </a:ext>
             </a:extLst>
           </p:cNvPr>
@@ -12385,7 +12385,7 @@
           <p:cNvPr id="15" name="모듈과 처리 순서">
             <a:extLst xmlns:a="http://schemas.openxmlformats.org/drawingml/2006/main">
               <a:ext uri="{FF2B5EF4-FFF2-40B4-BE49-F238E27FC236}">
-                <a16:creationId xmlns:a16="http://schemas.microsoft.com/office/drawing/2014/main" id="{5F85CDF1-6E11-4A01-9869-53C3754A198C}"/>
+                <a16:creationId xmlns:a16="http://schemas.microsoft.com/office/drawing/2014/main" id="{1C974FB6-0DC8-43E9-BE1B-98A189C50406}"/>
               </a:ext>
             </a:extLst>
           </p:cNvPr>
@@ -12543,7 +12543,7 @@
           <p:cNvPr id="16" name="">
             <a:extLst xmlns:a="http://schemas.openxmlformats.org/drawingml/2006/main">
               <a:ext uri="{FF2B5EF4-FFF2-40B4-BE49-F238E27FC236}">
-                <a16:creationId xmlns:a16="http://schemas.microsoft.com/office/drawing/2014/main" id="{5090C6CE-0D26-4B56-B48D-7E295A7856DD}"/>
+                <a16:creationId xmlns:a16="http://schemas.microsoft.com/office/drawing/2014/main" id="{55BB3D88-31F8-4E6A-B627-CFB5154CF05B}"/>
               </a:ext>
             </a:extLst>
           </p:cNvPr>
@@ -12574,7 +12574,7 @@
           <p:cNvPr id="17" name="image contracts">
             <a:extLst xmlns:a="http://schemas.openxmlformats.org/drawingml/2006/main">
               <a:ext uri="{FF2B5EF4-FFF2-40B4-BE49-F238E27FC236}">
-                <a16:creationId xmlns:a16="http://schemas.microsoft.com/office/drawing/2014/main" id="{6AD5821C-513A-446F-9127-5C4883CD66A3}"/>
+                <a16:creationId xmlns:a16="http://schemas.microsoft.com/office/drawing/2014/main" id="{8DC542C4-97FF-4200-898A-FF8B166E0B99}"/>
               </a:ext>
             </a:extLst>
           </p:cNvPr>
@@ -12732,7 +12732,7 @@
           <p:cNvPr id="18" name="이미지 동작의 계약">
             <a:extLst xmlns:a="http://schemas.openxmlformats.org/drawingml/2006/main">
               <a:ext uri="{FF2B5EF4-FFF2-40B4-BE49-F238E27FC236}">
-                <a16:creationId xmlns:a16="http://schemas.microsoft.com/office/drawing/2014/main" id="{D1ADE284-4830-4234-9EBB-BD49236AFAE1}"/>
+                <a16:creationId xmlns:a16="http://schemas.microsoft.com/office/drawing/2014/main" id="{B05862F5-5A5A-4F73-8527-5EDA31CE9977}"/>
               </a:ext>
             </a:extLst>
           </p:cNvPr>
@@ -12890,7 +12890,7 @@
           <p:cNvPr id="19" name="">
             <a:extLst xmlns:a="http://schemas.openxmlformats.org/drawingml/2006/main">
               <a:ext uri="{FF2B5EF4-FFF2-40B4-BE49-F238E27FC236}">
-                <a16:creationId xmlns:a16="http://schemas.microsoft.com/office/drawing/2014/main" id="{79B5D4D2-AB93-407B-86C6-743A2A1B5284}"/>
+                <a16:creationId xmlns:a16="http://schemas.microsoft.com/office/drawing/2014/main" id="{15D48E0D-CE0D-4EF9-8A85-9430811B3A7B}"/>
               </a:ext>
             </a:extLst>
           </p:cNvPr>
@@ -12921,7 +12921,7 @@
           <p:cNvPr id="20" name="testing">
             <a:extLst xmlns:a="http://schemas.openxmlformats.org/drawingml/2006/main">
               <a:ext uri="{FF2B5EF4-FFF2-40B4-BE49-F238E27FC236}">
-                <a16:creationId xmlns:a16="http://schemas.microsoft.com/office/drawing/2014/main" id="{E6C96C3D-33F1-4127-AF14-91D708C9653E}"/>
+                <a16:creationId xmlns:a16="http://schemas.microsoft.com/office/drawing/2014/main" id="{B103AB2F-8686-494E-BCDF-E99397072C23}"/>
               </a:ext>
             </a:extLst>
           </p:cNvPr>
@@ -13079,7 +13079,7 @@
           <p:cNvPr id="21" name="테스트 위치와 범위">
             <a:extLst xmlns:a="http://schemas.openxmlformats.org/drawingml/2006/main">
               <a:ext uri="{FF2B5EF4-FFF2-40B4-BE49-F238E27FC236}">
-                <a16:creationId xmlns:a16="http://schemas.microsoft.com/office/drawing/2014/main" id="{153D5219-50E7-414E-9432-A120315ADC2E}"/>
+                <a16:creationId xmlns:a16="http://schemas.microsoft.com/office/drawing/2014/main" id="{218125D9-F267-4305-8C91-2A8FA88DF43D}"/>
               </a:ext>
             </a:extLst>
           </p:cNvPr>
@@ -13237,7 +13237,7 @@
           <p:cNvPr id="22" name="모든 지식을 넣기보다, 상세 정보까지 가는 길을 안내한다">
             <a:extLst xmlns:a="http://schemas.openxmlformats.org/drawingml/2006/main">
               <a:ext uri="{FF2B5EF4-FFF2-40B4-BE49-F238E27FC236}">
-                <a16:creationId xmlns:a16="http://schemas.microsoft.com/office/drawing/2014/main" id="{37620AA0-4208-4932-8D09-41D00F096694}"/>
+                <a16:creationId xmlns:a16="http://schemas.microsoft.com/office/drawing/2014/main" id="{5327D5AE-3B0B-434F-B6B2-05949332B1E8}"/>
               </a:ext>
             </a:extLst>
           </p:cNvPr>
@@ -13395,7 +13395,7 @@
           <p:cNvPr id="23" name="Legacy module connection">
             <a:extLst xmlns:a="http://schemas.openxmlformats.org/drawingml/2006/main">
               <a:ext uri="{FF2B5EF4-FFF2-40B4-BE49-F238E27FC236}">
-                <a16:creationId xmlns:a16="http://schemas.microsoft.com/office/drawing/2014/main" id="{9A5C5B8D-C21F-4F35-A061-8AF35263FC44}"/>
+                <a16:creationId xmlns:a16="http://schemas.microsoft.com/office/drawing/2014/main" id="{ECE5C021-31A1-47AE-BD8B-D30BFDB1BB5E}"/>
               </a:ext>
             </a:extLst>
           </p:cNvPr>
@@ -13551,7 +13551,7 @@
     </p:spTree>
     <p:extLst>
       <p:ext uri="{BB962C8B-B14F-4D97-AF65-F5344CB8AC3E}">
-        <p14:creationId xmlns:p14="http://schemas.microsoft.com/office/powerpoint/2010/main" val="992549738"/>
+        <p14:creationId xmlns:p14="http://schemas.microsoft.com/office/powerpoint/2010/main" val="1865005977"/>
       </p:ext>
     </p:extLst>
   </p:cSld>
@@ -13582,7 +13582,7 @@
           <p:cNvPr id="23" name="ACT 2 · STATE-03의 문서 구조">
             <a:extLst xmlns:a="http://schemas.openxmlformats.org/drawingml/2006/main">
               <a:ext uri="{FF2B5EF4-FFF2-40B4-BE49-F238E27FC236}">
-                <a16:creationId xmlns:a16="http://schemas.microsoft.com/office/drawing/2014/main" id="{5806ED22-8CCE-4E0F-B9C5-D060D0E0CB5A}"/>
+                <a16:creationId xmlns:a16="http://schemas.microsoft.com/office/drawing/2014/main" id="{788C7682-62F6-4932-BC7E-D18B1B5438C4}"/>
               </a:ext>
             </a:extLst>
           </p:cNvPr>
@@ -13737,10 +13737,10 @@
       </p:sp>
       <p:sp>
         <p:nvSpPr>
-          <p:cNvPr id="2" name="S34">
+          <p:cNvPr id="2" name="S42">
             <a:extLst xmlns:a="http://schemas.openxmlformats.org/drawingml/2006/main">
               <a:ext uri="{FF2B5EF4-FFF2-40B4-BE49-F238E27FC236}">
-                <a16:creationId xmlns:a16="http://schemas.microsoft.com/office/drawing/2014/main" id="{F071112A-145F-4AF9-AF3B-CE6B7E4AAFDD}"/>
+                <a16:creationId xmlns:a16="http://schemas.microsoft.com/office/drawing/2014/main" id="{485D5109-07F8-44BF-A7CA-EF584EDA0344}"/>
               </a:ext>
             </a:extLst>
           </p:cNvPr>
@@ -13888,7 +13888,7 @@
                 <a:ea typeface="Malgun Gothic"/>
                 <a:cs typeface="Malgun Gothic"/>
               </a:rPr>
-              <a:t>S34</a:t>
+              <a:t>S42</a:t>
             </a:r>
           </a:p>
         </p:txBody>
@@ -13898,7 +13898,7 @@
           <p:cNvPr id="3" name="정보를 지우지 않고 위치를 나누기">
             <a:extLst xmlns:a="http://schemas.openxmlformats.org/drawingml/2006/main">
               <a:ext uri="{FF2B5EF4-FFF2-40B4-BE49-F238E27FC236}">
-                <a16:creationId xmlns:a16="http://schemas.microsoft.com/office/drawing/2014/main" id="{82CE19EC-F016-4C44-85FF-23AC4FC64BF4}"/>
+                <a16:creationId xmlns:a16="http://schemas.microsoft.com/office/drawing/2014/main" id="{A2A911FA-53BC-4251-A2ED-743BA7ABD2A3}"/>
               </a:ext>
             </a:extLst>
           </p:cNvPr>
@@ -14056,7 +14056,7 @@
           <p:cNvPr id="4" name="">
             <a:extLst xmlns:a="http://schemas.openxmlformats.org/drawingml/2006/main">
               <a:ext uri="{FF2B5EF4-FFF2-40B4-BE49-F238E27FC236}">
-                <a16:creationId xmlns:a16="http://schemas.microsoft.com/office/drawing/2014/main" id="{53D74C30-238A-4BD1-933B-5C365F3C92AC}"/>
+                <a16:creationId xmlns:a16="http://schemas.microsoft.com/office/drawing/2014/main" id="{C343BEF1-AC21-443B-B9DF-BB21B603EE6C}"/>
               </a:ext>
             </a:extLst>
           </p:cNvPr>
@@ -14087,7 +14087,7 @@
           <p:cNvPr id="5" name="STATE-02 → STATE-03 · 실제 파일 구조와 Routing 문구 발췌">
             <a:extLst xmlns:a="http://schemas.openxmlformats.org/drawingml/2006/main">
               <a:ext uri="{FF2B5EF4-FFF2-40B4-BE49-F238E27FC236}">
-                <a16:creationId xmlns:a16="http://schemas.microsoft.com/office/drawing/2014/main" id="{AD060CC0-DAB5-4FC9-A6C0-42A0A92EFA6E}"/>
+                <a16:creationId xmlns:a16="http://schemas.microsoft.com/office/drawing/2014/main" id="{E02A7D44-936E-47D2-962A-822CBD77A21E}"/>
               </a:ext>
             </a:extLst>
           </p:cNvPr>
@@ -14245,7 +14245,7 @@
           <p:cNvPr id="6" name="내용을 Scope에 맞춰 이동 · 구조 변화 자체가 완벽한 Routing이나 성능 향상 증거는 아님">
             <a:extLst xmlns:a="http://schemas.openxmlformats.org/drawingml/2006/main">
               <a:ext uri="{FF2B5EF4-FFF2-40B4-BE49-F238E27FC236}">
-                <a16:creationId xmlns:a16="http://schemas.microsoft.com/office/drawing/2014/main" id="{1C6073C8-B1B4-4ECC-B43B-2F64946554FF}"/>
+                <a16:creationId xmlns:a16="http://schemas.microsoft.com/office/drawing/2014/main" id="{567C2588-92EF-40C4-B06C-39174E335032}"/>
               </a:ext>
             </a:extLst>
           </p:cNvPr>
@@ -14403,7 +14403,7 @@
           <p:cNvPr id="7" name="이전: AGENTS.md 안에 세부사항까지">
             <a:extLst xmlns:a="http://schemas.openxmlformats.org/drawingml/2006/main">
               <a:ext uri="{FF2B5EF4-FFF2-40B4-BE49-F238E27FC236}">
-                <a16:creationId xmlns:a16="http://schemas.microsoft.com/office/drawing/2014/main" id="{7A93CFD9-3078-4C3F-80EE-BE7ABD9693DA}"/>
+                <a16:creationId xmlns:a16="http://schemas.microsoft.com/office/drawing/2014/main" id="{1810B824-E25D-4AD5-ADF8-2DFAFD5EEBEB}"/>
               </a:ext>
             </a:extLst>
           </p:cNvPr>
@@ -14561,7 +14561,7 @@
           <p:cNvPr id="8" name="이후: 기본 안내 + 상세 문서로 가는 링크">
             <a:extLst xmlns:a="http://schemas.openxmlformats.org/drawingml/2006/main">
               <a:ext uri="{FF2B5EF4-FFF2-40B4-BE49-F238E27FC236}">
-                <a16:creationId xmlns:a16="http://schemas.microsoft.com/office/drawing/2014/main" id="{8587CEB5-4243-4CED-AED7-E3C8A148EEB4}"/>
+                <a16:creationId xmlns:a16="http://schemas.microsoft.com/office/drawing/2014/main" id="{96F9D346-B233-4FD3-8858-F61B2CF50139}"/>
               </a:ext>
             </a:extLst>
           </p:cNvPr>
@@ -14719,7 +14719,7 @@
           <p:cNvPr id="9" name="">
             <a:extLst xmlns:a="http://schemas.openxmlformats.org/drawingml/2006/main">
               <a:ext uri="{FF2B5EF4-FFF2-40B4-BE49-F238E27FC236}">
-                <a16:creationId xmlns:a16="http://schemas.microsoft.com/office/drawing/2014/main" id="{0CE5C30B-670F-4864-9B96-16FED35E9672}"/>
+                <a16:creationId xmlns:a16="http://schemas.microsoft.com/office/drawing/2014/main" id="{8DA9F01A-4602-4715-B728-D217824526B8}"/>
               </a:ext>
             </a:extLst>
           </p:cNvPr>
@@ -14750,7 +14750,7 @@
           <p:cNvPr id="10" name="처리 순서 · 모듈 역할">
             <a:extLst xmlns:a="http://schemas.openxmlformats.org/drawingml/2006/main">
               <a:ext uri="{FF2B5EF4-FFF2-40B4-BE49-F238E27FC236}">
-                <a16:creationId xmlns:a16="http://schemas.microsoft.com/office/drawing/2014/main" id="{46227097-5539-4D01-9FF9-92ADCCCCA454}"/>
+                <a16:creationId xmlns:a16="http://schemas.microsoft.com/office/drawing/2014/main" id="{76284F08-992E-4361-BEF6-95B4267D307F}"/>
               </a:ext>
             </a:extLst>
           </p:cNvPr>
@@ -14908,7 +14908,7 @@
           <p:cNvPr id="11" name="">
             <a:extLst xmlns:a="http://schemas.openxmlformats.org/drawingml/2006/main">
               <a:ext uri="{FF2B5EF4-FFF2-40B4-BE49-F238E27FC236}">
-                <a16:creationId xmlns:a16="http://schemas.microsoft.com/office/drawing/2014/main" id="{1FAFAF25-2D07-4277-B7A8-B12919C9A091}"/>
+                <a16:creationId xmlns:a16="http://schemas.microsoft.com/office/drawing/2014/main" id="{767F4CC7-55BE-4CC4-AD84-19C1A9219F69}"/>
               </a:ext>
             </a:extLst>
           </p:cNvPr>
@@ -14938,7 +14938,7 @@
           <p:cNvPr id="12" name="docs/architecture.md">
             <a:extLst xmlns:a="http://schemas.openxmlformats.org/drawingml/2006/main">
               <a:ext uri="{FF2B5EF4-FFF2-40B4-BE49-F238E27FC236}">
-                <a16:creationId xmlns:a16="http://schemas.microsoft.com/office/drawing/2014/main" id="{0F3AE027-15B6-4D71-8020-C96DB6C7297A}"/>
+                <a16:creationId xmlns:a16="http://schemas.microsoft.com/office/drawing/2014/main" id="{D4CBBAD9-663C-4826-B198-131668892B7E}"/>
               </a:ext>
             </a:extLst>
           </p:cNvPr>
@@ -15096,7 +15096,7 @@
           <p:cNvPr id="13" name="">
             <a:extLst xmlns:a="http://schemas.openxmlformats.org/drawingml/2006/main">
               <a:ext uri="{FF2B5EF4-FFF2-40B4-BE49-F238E27FC236}">
-                <a16:creationId xmlns:a16="http://schemas.microsoft.com/office/drawing/2014/main" id="{F026E129-64E8-4CD9-B6FC-80640EED458E}"/>
+                <a16:creationId xmlns:a16="http://schemas.microsoft.com/office/drawing/2014/main" id="{759D69EE-1331-4590-BEAD-7271FB238C3E}"/>
               </a:ext>
             </a:extLst>
           </p:cNvPr>
@@ -15127,7 +15127,7 @@
           <p:cNvPr id="14" name="이미지 형식 · crop · resize">
             <a:extLst xmlns:a="http://schemas.openxmlformats.org/drawingml/2006/main">
               <a:ext uri="{FF2B5EF4-FFF2-40B4-BE49-F238E27FC236}">
-                <a16:creationId xmlns:a16="http://schemas.microsoft.com/office/drawing/2014/main" id="{AC8CDBB6-9D0D-4CEF-9FFD-2DB8E42ED9A0}"/>
+                <a16:creationId xmlns:a16="http://schemas.microsoft.com/office/drawing/2014/main" id="{7893676E-AA8E-4C95-AA0E-52A812736D87}"/>
               </a:ext>
             </a:extLst>
           </p:cNvPr>
@@ -15285,7 +15285,7 @@
           <p:cNvPr id="15" name="">
             <a:extLst xmlns:a="http://schemas.openxmlformats.org/drawingml/2006/main">
               <a:ext uri="{FF2B5EF4-FFF2-40B4-BE49-F238E27FC236}">
-                <a16:creationId xmlns:a16="http://schemas.microsoft.com/office/drawing/2014/main" id="{72482B81-7BF0-4448-AAC3-656E1E478A1C}"/>
+                <a16:creationId xmlns:a16="http://schemas.microsoft.com/office/drawing/2014/main" id="{28FEDE20-44F3-4D8D-9237-B3D945B95D67}"/>
               </a:ext>
             </a:extLst>
           </p:cNvPr>
@@ -15315,7 +15315,7 @@
           <p:cNvPr id="16" name="docs/image-contracts.md">
             <a:extLst xmlns:a="http://schemas.openxmlformats.org/drawingml/2006/main">
               <a:ext uri="{FF2B5EF4-FFF2-40B4-BE49-F238E27FC236}">
-                <a16:creationId xmlns:a16="http://schemas.microsoft.com/office/drawing/2014/main" id="{38C9D747-98B0-441C-951E-14780455596E}"/>
+                <a16:creationId xmlns:a16="http://schemas.microsoft.com/office/drawing/2014/main" id="{C158F668-C4D0-4483-B0DC-A49E66E5F0DF}"/>
               </a:ext>
             </a:extLst>
           </p:cNvPr>
@@ -15473,7 +15473,7 @@
           <p:cNvPr id="17" name="">
             <a:extLst xmlns:a="http://schemas.openxmlformats.org/drawingml/2006/main">
               <a:ext uri="{FF2B5EF4-FFF2-40B4-BE49-F238E27FC236}">
-                <a16:creationId xmlns:a16="http://schemas.microsoft.com/office/drawing/2014/main" id="{E6E0019F-845F-4823-AFF6-93B452DC75DC}"/>
+                <a16:creationId xmlns:a16="http://schemas.microsoft.com/office/drawing/2014/main" id="{99C00B97-688C-42D1-B38A-6D0917222F6D}"/>
               </a:ext>
             </a:extLst>
           </p:cNvPr>
@@ -15504,7 +15504,7 @@
           <p:cNvPr id="18" name="테스트 구조 · 관련 테스트">
             <a:extLst xmlns:a="http://schemas.openxmlformats.org/drawingml/2006/main">
               <a:ext uri="{FF2B5EF4-FFF2-40B4-BE49-F238E27FC236}">
-                <a16:creationId xmlns:a16="http://schemas.microsoft.com/office/drawing/2014/main" id="{667420AD-D3F7-4DFC-AD2D-714D13AD3AB9}"/>
+                <a16:creationId xmlns:a16="http://schemas.microsoft.com/office/drawing/2014/main" id="{83872947-375B-4EEC-A7DF-1D01038DC11B}"/>
               </a:ext>
             </a:extLst>
           </p:cNvPr>
@@ -15662,7 +15662,7 @@
           <p:cNvPr id="19" name="">
             <a:extLst xmlns:a="http://schemas.openxmlformats.org/drawingml/2006/main">
               <a:ext uri="{FF2B5EF4-FFF2-40B4-BE49-F238E27FC236}">
-                <a16:creationId xmlns:a16="http://schemas.microsoft.com/office/drawing/2014/main" id="{0AB00C2D-EA8D-4DD7-9741-27F0C1D2CD38}"/>
+                <a16:creationId xmlns:a16="http://schemas.microsoft.com/office/drawing/2014/main" id="{3654CAE9-99A1-4F5B-ADC4-BBCCAB66F2BC}"/>
               </a:ext>
             </a:extLst>
           </p:cNvPr>
@@ -15692,7 +15692,7 @@
           <p:cNvPr id="20" name="docs/testing.md">
             <a:extLst xmlns:a="http://schemas.openxmlformats.org/drawingml/2006/main">
               <a:ext uri="{FF2B5EF4-FFF2-40B4-BE49-F238E27FC236}">
-                <a16:creationId xmlns:a16="http://schemas.microsoft.com/office/drawing/2014/main" id="{FC28BF48-B360-4BF0-9B7F-EFE28FB75C81}"/>
+                <a16:creationId xmlns:a16="http://schemas.microsoft.com/office/drawing/2014/main" id="{08C1C694-D7E8-4977-9F5A-0C4B2E75922F}"/>
               </a:ext>
             </a:extLst>
           </p:cNvPr>
@@ -15850,7 +15850,7 @@
           <p:cNvPr id="21" name="원문: Test organization or relevant tests → docs/testing.md">
             <a:extLst xmlns:a="http://schemas.openxmlformats.org/drawingml/2006/main">
               <a:ext uri="{FF2B5EF4-FFF2-40B4-BE49-F238E27FC236}">
-                <a16:creationId xmlns:a16="http://schemas.microsoft.com/office/drawing/2014/main" id="{39FD4B9F-92AA-4D62-9F7D-820D403295DA}"/>
+                <a16:creationId xmlns:a16="http://schemas.microsoft.com/office/drawing/2014/main" id="{E0238A23-F41D-47B3-BBBF-EC08A9DF9526}"/>
               </a:ext>
             </a:extLst>
           </p:cNvPr>
@@ -16008,7 +16008,7 @@
           <p:cNvPr id="22" name="Legacy module connection">
             <a:extLst xmlns:a="http://schemas.openxmlformats.org/drawingml/2006/main">
               <a:ext uri="{FF2B5EF4-FFF2-40B4-BE49-F238E27FC236}">
-                <a16:creationId xmlns:a16="http://schemas.microsoft.com/office/drawing/2014/main" id="{C25AB7D9-09BD-499A-AB5C-8435D5FD8BEF}"/>
+                <a16:creationId xmlns:a16="http://schemas.microsoft.com/office/drawing/2014/main" id="{DD8BE3B5-CFE5-42FA-BF7A-278CEFB2931F}"/>
               </a:ext>
             </a:extLst>
           </p:cNvPr>
@@ -16164,7 +16164,7 @@
     </p:spTree>
     <p:extLst>
       <p:ext uri="{BB962C8B-B14F-4D97-AF65-F5344CB8AC3E}">
-        <p14:creationId xmlns:p14="http://schemas.microsoft.com/office/powerpoint/2010/main" val="482626291"/>
+        <p14:creationId xmlns:p14="http://schemas.microsoft.com/office/powerpoint/2010/main" val="2121864522"/>
       </p:ext>
     </p:extLst>
   </p:cSld>
@@ -16195,7 +16195,7 @@
           <p:cNvPr id="15" name="ACT 2 · 관찰하기 전에 질문하기">
             <a:extLst xmlns:a="http://schemas.openxmlformats.org/drawingml/2006/main">
               <a:ext uri="{FF2B5EF4-FFF2-40B4-BE49-F238E27FC236}">
-                <a16:creationId xmlns:a16="http://schemas.microsoft.com/office/drawing/2014/main" id="{A4C75A6D-D273-429E-B0D4-C84F3DD69A5A}"/>
+                <a16:creationId xmlns:a16="http://schemas.microsoft.com/office/drawing/2014/main" id="{24AD7013-AEC1-45F4-A8CD-5433D342BEBA}"/>
               </a:ext>
             </a:extLst>
           </p:cNvPr>
@@ -16350,10 +16350,10 @@
       </p:sp>
       <p:sp>
         <p:nvSpPr>
-          <p:cNvPr id="2" name="S35">
+          <p:cNvPr id="2" name="S43">
             <a:extLst xmlns:a="http://schemas.openxmlformats.org/drawingml/2006/main">
               <a:ext uri="{FF2B5EF4-FFF2-40B4-BE49-F238E27FC236}">
-                <a16:creationId xmlns:a16="http://schemas.microsoft.com/office/drawing/2014/main" id="{0B89FD35-12C9-482C-BD5D-D053857E3F8C}"/>
+                <a16:creationId xmlns:a16="http://schemas.microsoft.com/office/drawing/2014/main" id="{594878E5-2F57-44B3-96EE-1185E1EFCD4A}"/>
               </a:ext>
             </a:extLst>
           </p:cNvPr>
@@ -16501,7 +16501,7 @@
                 <a:ea typeface="Malgun Gothic"/>
                 <a:cs typeface="Malgun Gothic"/>
               </a:rPr>
-              <a:t>S35</a:t>
+              <a:t>S43</a:t>
             </a:r>
           </a:p>
         </p:txBody>
@@ -16511,7 +16511,7 @@
           <p:cNvPr id="3" name="서로 다른 두 Task가 무엇을 읽을까?">
             <a:extLst xmlns:a="http://schemas.openxmlformats.org/drawingml/2006/main">
               <a:ext uri="{FF2B5EF4-FFF2-40B4-BE49-F238E27FC236}">
-                <a16:creationId xmlns:a16="http://schemas.microsoft.com/office/drawing/2014/main" id="{3EB3115B-F0C1-4369-9432-5D6F20745169}"/>
+                <a16:creationId xmlns:a16="http://schemas.microsoft.com/office/drawing/2014/main" id="{6476FFDA-C39B-40BC-811E-732F448C7CE7}"/>
               </a:ext>
             </a:extLst>
           </p:cNvPr>
@@ -16669,7 +16669,7 @@
           <p:cNvPr id="4" name="">
             <a:extLst xmlns:a="http://schemas.openxmlformats.org/drawingml/2006/main">
               <a:ext uri="{FF2B5EF4-FFF2-40B4-BE49-F238E27FC236}">
-                <a16:creationId xmlns:a16="http://schemas.microsoft.com/office/drawing/2014/main" id="{E4DE2CAB-84DA-46BB-A7B6-9D2A29C1D839}"/>
+                <a16:creationId xmlns:a16="http://schemas.microsoft.com/office/drawing/2014/main" id="{ECCA15CD-FAF5-411E-B24E-5E3D99307636}"/>
               </a:ext>
             </a:extLst>
           </p:cNvPr>
@@ -16700,7 +16700,7 @@
           <p:cNvPr id="5" name="TRIAL-005A/B · 읽기 전용 Task의 질문을 재구성">
             <a:extLst xmlns:a="http://schemas.openxmlformats.org/drawingml/2006/main">
               <a:ext uri="{FF2B5EF4-FFF2-40B4-BE49-F238E27FC236}">
-                <a16:creationId xmlns:a16="http://schemas.microsoft.com/office/drawing/2014/main" id="{967BCFFA-8C42-4149-890D-C313E0A38A54}"/>
+                <a16:creationId xmlns:a16="http://schemas.microsoft.com/office/drawing/2014/main" id="{E1F675C6-4D55-4519-B783-C6853E892504}"/>
               </a:ext>
             </a:extLst>
           </p:cNvPr>
@@ -16858,7 +16858,7 @@
           <p:cNvPr id="6" name="어떤 상세 문서를 읽을지는 실제 접근 기록으로 확인한다">
             <a:extLst xmlns:a="http://schemas.openxmlformats.org/drawingml/2006/main">
               <a:ext uri="{FF2B5EF4-FFF2-40B4-BE49-F238E27FC236}">
-                <a16:creationId xmlns:a16="http://schemas.microsoft.com/office/drawing/2014/main" id="{A8946A90-EE9D-4384-8545-F8FC37236412}"/>
+                <a16:creationId xmlns:a16="http://schemas.microsoft.com/office/drawing/2014/main" id="{61F23037-9A98-4775-B971-8DE661C4D202}"/>
               </a:ext>
             </a:extLst>
           </p:cNvPr>
@@ -17016,7 +17016,7 @@
           <p:cNvPr id="7" name="Task A">
             <a:extLst xmlns:a="http://schemas.openxmlformats.org/drawingml/2006/main">
               <a:ext uri="{FF2B5EF4-FFF2-40B4-BE49-F238E27FC236}">
-                <a16:creationId xmlns:a16="http://schemas.microsoft.com/office/drawing/2014/main" id="{9C17FACC-C644-46AC-B655-6DC7F633B7F7}"/>
+                <a16:creationId xmlns:a16="http://schemas.microsoft.com/office/drawing/2014/main" id="{1F524A42-FAE2-4F19-A669-BD49A8BFCDFF}"/>
               </a:ext>
             </a:extLst>
           </p:cNvPr>
@@ -17174,7 +17174,7 @@
           <p:cNvPr id="8" name="Task B">
             <a:extLst xmlns:a="http://schemas.openxmlformats.org/drawingml/2006/main">
               <a:ext uri="{FF2B5EF4-FFF2-40B4-BE49-F238E27FC236}">
-                <a16:creationId xmlns:a16="http://schemas.microsoft.com/office/drawing/2014/main" id="{A8553834-12E9-4316-89F2-064DCB12F0DC}"/>
+                <a16:creationId xmlns:a16="http://schemas.microsoft.com/office/drawing/2014/main" id="{DB318CD6-BEA2-43D8-8E6E-885BAC1AA46F}"/>
               </a:ext>
             </a:extLst>
           </p:cNvPr>
@@ -17332,7 +17332,7 @@
           <p:cNvPr id="9" name="">
             <a:extLst xmlns:a="http://schemas.openxmlformats.org/drawingml/2006/main">
               <a:ext uri="{FF2B5EF4-FFF2-40B4-BE49-F238E27FC236}">
-                <a16:creationId xmlns:a16="http://schemas.microsoft.com/office/drawing/2014/main" id="{99AF6A44-68C4-45BD-9948-1C3D5C6120C5}"/>
+                <a16:creationId xmlns:a16="http://schemas.microsoft.com/office/drawing/2014/main" id="{771F8D7C-889D-4813-8350-A19A9E72DEED}"/>
               </a:ext>
             </a:extLst>
           </p:cNvPr>
@@ -17363,7 +17363,7 @@
           <p:cNvPr id="10" name="">
             <a:extLst xmlns:a="http://schemas.openxmlformats.org/drawingml/2006/main">
               <a:ext uri="{FF2B5EF4-FFF2-40B4-BE49-F238E27FC236}">
-                <a16:creationId xmlns:a16="http://schemas.microsoft.com/office/drawing/2014/main" id="{3D30A006-4B12-4921-A45A-DC9988D3BCE1}"/>
+                <a16:creationId xmlns:a16="http://schemas.microsoft.com/office/drawing/2014/main" id="{82FE8741-B596-40F6-BB1A-5D28EF4E370F}"/>
               </a:ext>
             </a:extLst>
           </p:cNvPr>
@@ -17394,7 +17394,7 @@
           <p:cNvPr id="11" name="crop 1 3은&#10;어떤 source column을&#10;포함하는가?">
             <a:extLst xmlns:a="http://schemas.openxmlformats.org/drawingml/2006/main">
               <a:ext uri="{FF2B5EF4-FFF2-40B4-BE49-F238E27FC236}">
-                <a16:creationId xmlns:a16="http://schemas.microsoft.com/office/drawing/2014/main" id="{E4932F89-EC71-44E9-9E74-9C0AC131B964}"/>
+                <a16:creationId xmlns:a16="http://schemas.microsoft.com/office/drawing/2014/main" id="{2F85E9B8-4C20-489F-916A-EF7B7358E99F}"/>
               </a:ext>
             </a:extLst>
           </p:cNvPr>
@@ -17598,7 +17598,7 @@
           <p:cNvPr id="12" name="이 Project에&#10;runtime dependency가&#10;있는가?">
             <a:extLst xmlns:a="http://schemas.openxmlformats.org/drawingml/2006/main">
               <a:ext uri="{FF2B5EF4-FFF2-40B4-BE49-F238E27FC236}">
-                <a16:creationId xmlns:a16="http://schemas.microsoft.com/office/drawing/2014/main" id="{EC9A7992-87C9-4681-A80D-F14FA2DEE7D0}"/>
+                <a16:creationId xmlns:a16="http://schemas.microsoft.com/office/drawing/2014/main" id="{C2DB9346-DD7D-4E58-BC16-BC3F4CEA7F2A}"/>
               </a:ext>
             </a:extLst>
           </p:cNvPr>
@@ -17802,7 +17802,7 @@
           <p:cNvPr id="13" name="두 Task에서 같은 상세 문서를 읽을까?">
             <a:extLst xmlns:a="http://schemas.openxmlformats.org/drawingml/2006/main">
               <a:ext uri="{FF2B5EF4-FFF2-40B4-BE49-F238E27FC236}">
-                <a16:creationId xmlns:a16="http://schemas.microsoft.com/office/drawing/2014/main" id="{C6070B1B-B787-437D-A70D-B0CB8F61772F}"/>
+                <a16:creationId xmlns:a16="http://schemas.microsoft.com/office/drawing/2014/main" id="{9498B67D-DED8-41B0-BEF9-DDEEC9F409E9}"/>
               </a:ext>
             </a:extLst>
           </p:cNvPr>
@@ -17960,7 +17960,7 @@
           <p:cNvPr id="14" name="Legacy module connection">
             <a:extLst xmlns:a="http://schemas.openxmlformats.org/drawingml/2006/main">
               <a:ext uri="{FF2B5EF4-FFF2-40B4-BE49-F238E27FC236}">
-                <a16:creationId xmlns:a16="http://schemas.microsoft.com/office/drawing/2014/main" id="{C7DABF67-F294-455F-98EC-31A27434655F}"/>
+                <a16:creationId xmlns:a16="http://schemas.microsoft.com/office/drawing/2014/main" id="{13971672-6000-45C8-85C0-8672A22C032A}"/>
               </a:ext>
             </a:extLst>
           </p:cNvPr>
@@ -18116,7 +18116,7 @@
     </p:spTree>
     <p:extLst>
       <p:ext uri="{BB962C8B-B14F-4D97-AF65-F5344CB8AC3E}">
-        <p14:creationId xmlns:p14="http://schemas.microsoft.com/office/powerpoint/2010/main" val="1805514392"/>
+        <p14:creationId xmlns:p14="http://schemas.microsoft.com/office/powerpoint/2010/main" val="1139166884"/>
       </p:ext>
     </p:extLst>
   </p:cSld>
@@ -18147,7 +18147,7 @@
           <p:cNvPr id="25" name="ACT 2 · 질문과 근거를 연결하기">
             <a:extLst xmlns:a="http://schemas.openxmlformats.org/drawingml/2006/main">
               <a:ext uri="{FF2B5EF4-FFF2-40B4-BE49-F238E27FC236}">
-                <a16:creationId xmlns:a16="http://schemas.microsoft.com/office/drawing/2014/main" id="{DE628AB9-7F53-489E-A3F3-FE1368E548D9}"/>
+                <a16:creationId xmlns:a16="http://schemas.microsoft.com/office/drawing/2014/main" id="{EA7B2933-2A05-46FD-B5E5-ADC2B392E334}"/>
               </a:ext>
             </a:extLst>
           </p:cNvPr>
@@ -18302,10 +18302,10 @@
       </p:sp>
       <p:sp>
         <p:nvSpPr>
-          <p:cNvPr id="2" name="S36">
+          <p:cNvPr id="2" name="S44">
             <a:extLst xmlns:a="http://schemas.openxmlformats.org/drawingml/2006/main">
               <a:ext uri="{FF2B5EF4-FFF2-40B4-BE49-F238E27FC236}">
-                <a16:creationId xmlns:a16="http://schemas.microsoft.com/office/drawing/2014/main" id="{9E552FFC-E12D-41CB-BAAC-7CCF0356746E}"/>
+                <a16:creationId xmlns:a16="http://schemas.microsoft.com/office/drawing/2014/main" id="{899A0EF5-0A9A-41C8-B22A-126B1ECB08DF}"/>
               </a:ext>
             </a:extLst>
           </p:cNvPr>
@@ -18453,7 +18453,7 @@
                 <a:ea typeface="Malgun Gothic"/>
                 <a:cs typeface="Malgun Gothic"/>
               </a:rPr>
-              <a:t>S36</a:t>
+              <a:t>S44</a:t>
             </a:r>
           </a:p>
         </p:txBody>
@@ -18463,7 +18463,7 @@
           <p:cNvPr id="3" name="Crop Task에서 관찰한 접근">
             <a:extLst xmlns:a="http://schemas.openxmlformats.org/drawingml/2006/main">
               <a:ext uri="{FF2B5EF4-FFF2-40B4-BE49-F238E27FC236}">
-                <a16:creationId xmlns:a16="http://schemas.microsoft.com/office/drawing/2014/main" id="{BBA18BFE-0524-49C2-9D60-246F4F667229}"/>
+                <a16:creationId xmlns:a16="http://schemas.microsoft.com/office/drawing/2014/main" id="{05C1FFB3-C986-4DC4-BC16-95F5FAD20BFD}"/>
               </a:ext>
             </a:extLst>
           </p:cNvPr>
@@ -18621,7 +18621,7 @@
           <p:cNvPr id="4" name="">
             <a:extLst xmlns:a="http://schemas.openxmlformats.org/drawingml/2006/main">
               <a:ext uri="{FF2B5EF4-FFF2-40B4-BE49-F238E27FC236}">
-                <a16:creationId xmlns:a16="http://schemas.microsoft.com/office/drawing/2014/main" id="{C9E29B7C-49C1-424E-BB32-E3962B3FD84F}"/>
+                <a16:creationId xmlns:a16="http://schemas.microsoft.com/office/drawing/2014/main" id="{3F0DE139-7371-46A2-9FFD-CB0339A64613}"/>
               </a:ext>
             </a:extLst>
           </p:cNvPr>
@@ -18652,7 +18652,7 @@
           <p:cNvPr id="5" name="TRIAL-005A · 최종 실행의 접근과 답을 기록에서 재구성">
             <a:extLst xmlns:a="http://schemas.openxmlformats.org/drawingml/2006/main">
               <a:ext uri="{FF2B5EF4-FFF2-40B4-BE49-F238E27FC236}">
-                <a16:creationId xmlns:a16="http://schemas.microsoft.com/office/drawing/2014/main" id="{E49C2A36-C0EA-4346-84FC-6DC5B2EBDD4A}"/>
+                <a16:creationId xmlns:a16="http://schemas.microsoft.com/office/drawing/2014/main" id="{D1892A36-CCD1-4DA4-BA39-E912087FFF6A}"/>
               </a:ext>
             </a:extLst>
           </p:cNvPr>
@@ -18810,7 +18810,7 @@
           <p:cNvPr id="6" name="architecture 등 넓은 Context도 접근 · testing.md는 최종 실행에서 관찰, 반복 간">
             <a:extLst xmlns:a="http://schemas.openxmlformats.org/drawingml/2006/main">
               <a:ext uri="{FF2B5EF4-FFF2-40B4-BE49-F238E27FC236}">
-                <a16:creationId xmlns:a16="http://schemas.microsoft.com/office/drawing/2014/main" id="{D9AB5C2B-69EE-4CA2-87B2-06E5BDC518B4}"/>
+                <a16:creationId xmlns:a16="http://schemas.microsoft.com/office/drawing/2014/main" id="{305C54B9-C2EB-4A27-9198-0ADA9AACDBCA}"/>
               </a:ext>
             </a:extLst>
           </p:cNvPr>
@@ -18968,7 +18968,7 @@
           <p:cNvPr id="7" name="접근한 계약 문서">
             <a:extLst xmlns:a="http://schemas.openxmlformats.org/drawingml/2006/main">
               <a:ext uri="{FF2B5EF4-FFF2-40B4-BE49-F238E27FC236}">
-                <a16:creationId xmlns:a16="http://schemas.microsoft.com/office/drawing/2014/main" id="{A6972D9A-6E37-460A-B547-23CC13085C51}"/>
+                <a16:creationId xmlns:a16="http://schemas.microsoft.com/office/drawing/2014/main" id="{096ADA4A-001A-4C3F-B0F7-0C4693412F5A}"/>
               </a:ext>
             </a:extLst>
           </p:cNvPr>
@@ -19126,7 +19126,7 @@
           <p:cNvPr id="8" name="image-contracts.md">
             <a:extLst xmlns:a="http://schemas.openxmlformats.org/drawingml/2006/main">
               <a:ext uri="{FF2B5EF4-FFF2-40B4-BE49-F238E27FC236}">
-                <a16:creationId xmlns:a16="http://schemas.microsoft.com/office/drawing/2014/main" id="{720F8481-3546-465B-A183-05786D734C4E}"/>
+                <a16:creationId xmlns:a16="http://schemas.microsoft.com/office/drawing/2014/main" id="{88A12559-52D8-41ED-85EA-06FE30CCA5FB}"/>
               </a:ext>
             </a:extLst>
           </p:cNvPr>
@@ -19284,7 +19284,7 @@
           <p:cNvPr id="9" name="">
             <a:extLst xmlns:a="http://schemas.openxmlformats.org/drawingml/2006/main">
               <a:ext uri="{FF2B5EF4-FFF2-40B4-BE49-F238E27FC236}">
-                <a16:creationId xmlns:a16="http://schemas.microsoft.com/office/drawing/2014/main" id="{5C60A8BA-A06F-43D6-BB22-DA4B9A304955}"/>
+                <a16:creationId xmlns:a16="http://schemas.microsoft.com/office/drawing/2014/main" id="{A5E967C4-B4BE-4472-BE2F-527BC4E5D053}"/>
               </a:ext>
             </a:extLst>
           </p:cNvPr>
@@ -19315,7 +19315,7 @@
           <p:cNvPr id="10" name="[x_start, x_end)">
             <a:extLst xmlns:a="http://schemas.openxmlformats.org/drawingml/2006/main">
               <a:ext uri="{FF2B5EF4-FFF2-40B4-BE49-F238E27FC236}">
-                <a16:creationId xmlns:a16="http://schemas.microsoft.com/office/drawing/2014/main" id="{63E26A71-FCB1-48A3-AA96-FD794F653375}"/>
+                <a16:creationId xmlns:a16="http://schemas.microsoft.com/office/drawing/2014/main" id="{E733ABF8-408A-4EDF-98DF-85A9534E1FF1}"/>
               </a:ext>
             </a:extLst>
           </p:cNvPr>
@@ -19473,7 +19473,7 @@
           <p:cNvPr id="11" name="시작 열 포함 · 끝 좌표 제외">
             <a:extLst xmlns:a="http://schemas.openxmlformats.org/drawingml/2006/main">
               <a:ext uri="{FF2B5EF4-FFF2-40B4-BE49-F238E27FC236}">
-                <a16:creationId xmlns:a16="http://schemas.microsoft.com/office/drawing/2014/main" id="{94BEFA3D-74B1-42D0-8769-CF94E7450E10}"/>
+                <a16:creationId xmlns:a16="http://schemas.microsoft.com/office/drawing/2014/main" id="{40F61E7E-1D99-4CA4-8B70-C624BC26EC10}"/>
               </a:ext>
             </a:extLst>
           </p:cNvPr>
@@ -19631,7 +19631,7 @@
           <p:cNvPr id="12" name="기록된 답">
             <a:extLst xmlns:a="http://schemas.openxmlformats.org/drawingml/2006/main">
               <a:ext uri="{FF2B5EF4-FFF2-40B4-BE49-F238E27FC236}">
-                <a16:creationId xmlns:a16="http://schemas.microsoft.com/office/drawing/2014/main" id="{6654A380-E6D8-4D9C-8034-DBCE91680510}"/>
+                <a16:creationId xmlns:a16="http://schemas.microsoft.com/office/drawing/2014/main" id="{36D102E0-F84D-4CCB-BC6C-5A9127EAE932}"/>
               </a:ext>
             </a:extLst>
           </p:cNvPr>
@@ -19789,7 +19789,7 @@
           <p:cNvPr id="13" name="crop 1 3">
             <a:extLst xmlns:a="http://schemas.openxmlformats.org/drawingml/2006/main">
               <a:ext uri="{FF2B5EF4-FFF2-40B4-BE49-F238E27FC236}">
-                <a16:creationId xmlns:a16="http://schemas.microsoft.com/office/drawing/2014/main" id="{2E993104-471E-4F7E-8061-6AA1B0DC3514}"/>
+                <a16:creationId xmlns:a16="http://schemas.microsoft.com/office/drawing/2014/main" id="{BE927560-F695-4A3E-81F9-586871A15CD9}"/>
               </a:ext>
             </a:extLst>
           </p:cNvPr>
@@ -19947,7 +19947,7 @@
           <p:cNvPr id="14" name="">
             <a:extLst xmlns:a="http://schemas.openxmlformats.org/drawingml/2006/main">
               <a:ext uri="{FF2B5EF4-FFF2-40B4-BE49-F238E27FC236}">
-                <a16:creationId xmlns:a16="http://schemas.microsoft.com/office/drawing/2014/main" id="{0475738D-3BE7-4C90-A19F-8F02DD38D3FF}"/>
+                <a16:creationId xmlns:a16="http://schemas.microsoft.com/office/drawing/2014/main" id="{3C4EFC32-5701-4F83-BDB6-12B50280BF14}"/>
               </a:ext>
             </a:extLst>
           </p:cNvPr>
@@ -19980,7 +19980,7 @@
           <p:cNvPr id="15" name="0">
             <a:extLst xmlns:a="http://schemas.openxmlformats.org/drawingml/2006/main">
               <a:ext uri="{FF2B5EF4-FFF2-40B4-BE49-F238E27FC236}">
-                <a16:creationId xmlns:a16="http://schemas.microsoft.com/office/drawing/2014/main" id="{994359DD-5EC6-409B-A8BE-C2B088A8D5B4}"/>
+                <a16:creationId xmlns:a16="http://schemas.microsoft.com/office/drawing/2014/main" id="{02928CCD-0E87-43AB-9317-E17972609FB2}"/>
               </a:ext>
             </a:extLst>
           </p:cNvPr>
@@ -20138,7 +20138,7 @@
           <p:cNvPr id="16" name="">
             <a:extLst xmlns:a="http://schemas.openxmlformats.org/drawingml/2006/main">
               <a:ext uri="{FF2B5EF4-FFF2-40B4-BE49-F238E27FC236}">
-                <a16:creationId xmlns:a16="http://schemas.microsoft.com/office/drawing/2014/main" id="{73CCEAC3-2A6C-4A80-9D70-638AA35E77C5}"/>
+                <a16:creationId xmlns:a16="http://schemas.microsoft.com/office/drawing/2014/main" id="{779DFA37-65BD-49CB-8D3B-8E735D641312}"/>
               </a:ext>
             </a:extLst>
           </p:cNvPr>
@@ -20171,7 +20171,7 @@
           <p:cNvPr id="17" name="1">
             <a:extLst xmlns:a="http://schemas.openxmlformats.org/drawingml/2006/main">
               <a:ext uri="{FF2B5EF4-FFF2-40B4-BE49-F238E27FC236}">
-                <a16:creationId xmlns:a16="http://schemas.microsoft.com/office/drawing/2014/main" id="{D7AAC234-B950-417E-9574-FFDC98097E80}"/>
+                <a16:creationId xmlns:a16="http://schemas.microsoft.com/office/drawing/2014/main" id="{58809225-D579-4FAA-9EBD-8C2EBDBA60BF}"/>
               </a:ext>
             </a:extLst>
           </p:cNvPr>
@@ -20329,7 +20329,7 @@
           <p:cNvPr id="18" name="">
             <a:extLst xmlns:a="http://schemas.openxmlformats.org/drawingml/2006/main">
               <a:ext uri="{FF2B5EF4-FFF2-40B4-BE49-F238E27FC236}">
-                <a16:creationId xmlns:a16="http://schemas.microsoft.com/office/drawing/2014/main" id="{A7E8071A-B9D3-4BDD-BEE3-09DD8B34DCEA}"/>
+                <a16:creationId xmlns:a16="http://schemas.microsoft.com/office/drawing/2014/main" id="{5BD7CF9D-5515-47D5-8BCD-694CBE3C8FC9}"/>
               </a:ext>
             </a:extLst>
           </p:cNvPr>
@@ -20362,7 +20362,7 @@
           <p:cNvPr id="19" name="2">
             <a:extLst xmlns:a="http://schemas.openxmlformats.org/drawingml/2006/main">
               <a:ext uri="{FF2B5EF4-FFF2-40B4-BE49-F238E27FC236}">
-                <a16:creationId xmlns:a16="http://schemas.microsoft.com/office/drawing/2014/main" id="{2E1E0DA1-85CC-46D3-AF2F-E27CF3C95A3E}"/>
+                <a16:creationId xmlns:a16="http://schemas.microsoft.com/office/drawing/2014/main" id="{1CBA6E19-6476-4575-9B20-B4EF150D7B01}"/>
               </a:ext>
             </a:extLst>
           </p:cNvPr>
@@ -20520,7 +20520,7 @@
           <p:cNvPr id="20" name="">
             <a:extLst xmlns:a="http://schemas.openxmlformats.org/drawingml/2006/main">
               <a:ext uri="{FF2B5EF4-FFF2-40B4-BE49-F238E27FC236}">
-                <a16:creationId xmlns:a16="http://schemas.microsoft.com/office/drawing/2014/main" id="{254F5A02-0F6B-4717-8BEF-323BB441AD4A}"/>
+                <a16:creationId xmlns:a16="http://schemas.microsoft.com/office/drawing/2014/main" id="{0B0AC74D-520A-4931-A751-F8D271F91AD6}"/>
               </a:ext>
             </a:extLst>
           </p:cNvPr>
@@ -20553,7 +20553,7 @@
           <p:cNvPr id="21" name="3">
             <a:extLst xmlns:a="http://schemas.openxmlformats.org/drawingml/2006/main">
               <a:ext uri="{FF2B5EF4-FFF2-40B4-BE49-F238E27FC236}">
-                <a16:creationId xmlns:a16="http://schemas.microsoft.com/office/drawing/2014/main" id="{C6602D89-1B2E-492B-8B17-F8D60645848A}"/>
+                <a16:creationId xmlns:a16="http://schemas.microsoft.com/office/drawing/2014/main" id="{CACDA20A-173C-4372-89AF-D13B7E897C63}"/>
               </a:ext>
             </a:extLst>
           </p:cNvPr>
@@ -20711,7 +20711,7 @@
           <p:cNvPr id="22" name="포함 열: 1, 2&#10;출력 폭: 2">
             <a:extLst xmlns:a="http://schemas.openxmlformats.org/drawingml/2006/main">
               <a:ext uri="{FF2B5EF4-FFF2-40B4-BE49-F238E27FC236}">
-                <a16:creationId xmlns:a16="http://schemas.microsoft.com/office/drawing/2014/main" id="{B6DEADCF-64D0-415B-B2E3-731BBB668244}"/>
+                <a16:creationId xmlns:a16="http://schemas.microsoft.com/office/drawing/2014/main" id="{CF80D5F1-23F2-4F24-A0B9-2F0A40B3225C}"/>
               </a:ext>
             </a:extLst>
           </p:cNvPr>
@@ -20892,7 +20892,7 @@
           <p:cNvPr id="23" name="답을 파일의 계약과 연결해 확인했다">
             <a:extLst xmlns:a="http://schemas.openxmlformats.org/drawingml/2006/main">
               <a:ext uri="{FF2B5EF4-FFF2-40B4-BE49-F238E27FC236}">
-                <a16:creationId xmlns:a16="http://schemas.microsoft.com/office/drawing/2014/main" id="{127815BD-A9CC-4617-AC74-9FB34CA7D9BC}"/>
+                <a16:creationId xmlns:a16="http://schemas.microsoft.com/office/drawing/2014/main" id="{F48903B5-211A-4A40-BD98-E5F2D6B73C84}"/>
               </a:ext>
             </a:extLst>
           </p:cNvPr>
@@ -21050,7 +21050,7 @@
           <p:cNvPr id="24" name="Legacy module connection">
             <a:extLst xmlns:a="http://schemas.openxmlformats.org/drawingml/2006/main">
               <a:ext uri="{FF2B5EF4-FFF2-40B4-BE49-F238E27FC236}">
-                <a16:creationId xmlns:a16="http://schemas.microsoft.com/office/drawing/2014/main" id="{BD0047D5-33A6-493D-8746-27C0C46A2A79}"/>
+                <a16:creationId xmlns:a16="http://schemas.microsoft.com/office/drawing/2014/main" id="{89B6CAF5-C829-4121-BCB6-7B71E438B6F9}"/>
               </a:ext>
             </a:extLst>
           </p:cNvPr>
@@ -21206,7 +21206,7 @@
     </p:spTree>
     <p:extLst>
       <p:ext uri="{BB962C8B-B14F-4D97-AF65-F5344CB8AC3E}">
-        <p14:creationId xmlns:p14="http://schemas.microsoft.com/office/powerpoint/2010/main" val="2003350271"/>
+        <p14:creationId xmlns:p14="http://schemas.microsoft.com/office/powerpoint/2010/main" val="2122750341"/>
       </p:ext>
     </p:extLst>
   </p:cSld>
@@ -21237,7 +21237,7 @@
           <p:cNvPr id="25" name="ACT 2 · 두 Task의 문서 접근 비교">
             <a:extLst xmlns:a="http://schemas.openxmlformats.org/drawingml/2006/main">
               <a:ext uri="{FF2B5EF4-FFF2-40B4-BE49-F238E27FC236}">
-                <a16:creationId xmlns:a16="http://schemas.microsoft.com/office/drawing/2014/main" id="{793CBDF5-15FA-46B0-AE76-4345D8B8219C}"/>
+                <a16:creationId xmlns:a16="http://schemas.microsoft.com/office/drawing/2014/main" id="{CD3F34D0-B4CA-46AF-B6D1-4EDC9C3D1C1F}"/>
               </a:ext>
             </a:extLst>
           </p:cNvPr>
@@ -21392,10 +21392,10 @@
       </p:sp>
       <p:sp>
         <p:nvSpPr>
-          <p:cNvPr id="2" name="S37">
+          <p:cNvPr id="2" name="S45">
             <a:extLst xmlns:a="http://schemas.openxmlformats.org/drawingml/2006/main">
               <a:ext uri="{FF2B5EF4-FFF2-40B4-BE49-F238E27FC236}">
-                <a16:creationId xmlns:a16="http://schemas.microsoft.com/office/drawing/2014/main" id="{D3E00EC0-CE38-494D-B750-13E3489AAA76}"/>
+                <a16:creationId xmlns:a16="http://schemas.microsoft.com/office/drawing/2014/main" id="{DDEE0625-F634-4B82-A0CA-AC9C2E94DEF8}"/>
               </a:ext>
             </a:extLst>
           </p:cNvPr>
@@ -21543,7 +21543,7 @@
                 <a:ea typeface="Malgun Gothic"/>
                 <a:cs typeface="Malgun Gothic"/>
               </a:rPr>
-              <a:t>S37</a:t>
+              <a:t>S45</a:t>
             </a:r>
           </a:p>
         </p:txBody>
@@ -21553,7 +21553,7 @@
           <p:cNvPr id="3" name="Task별 접근은 달랐지만 완벽하지는 않다">
             <a:extLst xmlns:a="http://schemas.openxmlformats.org/drawingml/2006/main">
               <a:ext uri="{FF2B5EF4-FFF2-40B4-BE49-F238E27FC236}">
-                <a16:creationId xmlns:a16="http://schemas.microsoft.com/office/drawing/2014/main" id="{DAD21BAC-8852-4E1A-91D1-736A7FD45077}"/>
+                <a16:creationId xmlns:a16="http://schemas.microsoft.com/office/drawing/2014/main" id="{B037C8CE-4BDE-47C6-A1B9-D35CCC20A042}"/>
               </a:ext>
             </a:extLst>
           </p:cNvPr>
@@ -21711,7 +21711,7 @@
           <p:cNvPr id="4" name="">
             <a:extLst xmlns:a="http://schemas.openxmlformats.org/drawingml/2006/main">
               <a:ext uri="{FF2B5EF4-FFF2-40B4-BE49-F238E27FC236}">
-                <a16:creationId xmlns:a16="http://schemas.microsoft.com/office/drawing/2014/main" id="{F81E8DE2-2DE9-4532-AAF0-FF2A9349FC2C}"/>
+                <a16:creationId xmlns:a16="http://schemas.microsoft.com/office/drawing/2014/main" id="{E6BF2874-C338-48B2-B14A-7E4D8AA09E9D}"/>
               </a:ext>
             </a:extLst>
           </p:cNvPr>
@@ -21742,7 +21742,7 @@
           <p:cNvPr id="5" name="TRIAL-005A/B · 실제 접근 기록을 요약한 비교">
             <a:extLst xmlns:a="http://schemas.openxmlformats.org/drawingml/2006/main">
               <a:ext uri="{FF2B5EF4-FFF2-40B4-BE49-F238E27FC236}">
-                <a16:creationId xmlns:a16="http://schemas.microsoft.com/office/drawing/2014/main" id="{255900DB-965F-4EC9-8673-F4172294C329}"/>
+                <a16:creationId xmlns:a16="http://schemas.microsoft.com/office/drawing/2014/main" id="{9337D07F-AAAB-48FD-8498-711866938599}"/>
               </a:ext>
             </a:extLst>
           </p:cNvPr>
@@ -21900,7 +21900,7 @@
           <p:cNvPr id="6" name="완벽한 Routing 미입증 · 토큰 절약·성능 개선 미측정 · 실행 간 변동 존재">
             <a:extLst xmlns:a="http://schemas.openxmlformats.org/drawingml/2006/main">
               <a:ext uri="{FF2B5EF4-FFF2-40B4-BE49-F238E27FC236}">
-                <a16:creationId xmlns:a16="http://schemas.microsoft.com/office/drawing/2014/main" id="{2090F088-FAED-4082-815C-527040932A86}"/>
+                <a16:creationId xmlns:a16="http://schemas.microsoft.com/office/drawing/2014/main" id="{C5EBD1D5-E070-4A21-B263-15682BFE6F28}"/>
               </a:ext>
             </a:extLst>
           </p:cNvPr>
@@ -22058,7 +22058,7 @@
           <p:cNvPr id="7" name="같은 Repository에서 질문이 달랐다">
             <a:extLst xmlns:a="http://schemas.openxmlformats.org/drawingml/2006/main">
               <a:ext uri="{FF2B5EF4-FFF2-40B4-BE49-F238E27FC236}">
-                <a16:creationId xmlns:a16="http://schemas.microsoft.com/office/drawing/2014/main" id="{AD2FA958-55FE-4CEF-BBFB-C7E4830BE721}"/>
+                <a16:creationId xmlns:a16="http://schemas.microsoft.com/office/drawing/2014/main" id="{6C72B2FF-C34F-4843-AE3A-FBD6C85415E7}"/>
               </a:ext>
             </a:extLst>
           </p:cNvPr>
@@ -22216,7 +22216,7 @@
           <p:cNvPr id="8" name="문서">
             <a:extLst xmlns:a="http://schemas.openxmlformats.org/drawingml/2006/main">
               <a:ext uri="{FF2B5EF4-FFF2-40B4-BE49-F238E27FC236}">
-                <a16:creationId xmlns:a16="http://schemas.microsoft.com/office/drawing/2014/main" id="{8352376E-43DA-452E-B9B7-B7EC144B1C54}"/>
+                <a16:creationId xmlns:a16="http://schemas.microsoft.com/office/drawing/2014/main" id="{0856ADD7-AFD4-433C-A9E1-89009A1DF44F}"/>
               </a:ext>
             </a:extLst>
           </p:cNvPr>
@@ -22374,7 +22374,7 @@
           <p:cNvPr id="9" name="A · crop 계약">
             <a:extLst xmlns:a="http://schemas.openxmlformats.org/drawingml/2006/main">
               <a:ext uri="{FF2B5EF4-FFF2-40B4-BE49-F238E27FC236}">
-                <a16:creationId xmlns:a16="http://schemas.microsoft.com/office/drawing/2014/main" id="{45D4E11F-41AA-4286-8BCB-C8713DEFF9EE}"/>
+                <a16:creationId xmlns:a16="http://schemas.microsoft.com/office/drawing/2014/main" id="{F5F8AA10-A690-403D-A15D-B27025D123E6}"/>
               </a:ext>
             </a:extLst>
           </p:cNvPr>
@@ -22532,7 +22532,7 @@
           <p:cNvPr id="10" name="B · 실행 의존성">
             <a:extLst xmlns:a="http://schemas.openxmlformats.org/drawingml/2006/main">
               <a:ext uri="{FF2B5EF4-FFF2-40B4-BE49-F238E27FC236}">
-                <a16:creationId xmlns:a16="http://schemas.microsoft.com/office/drawing/2014/main" id="{4A1B3610-47BB-4CFF-B48C-9CFF2E1484A9}"/>
+                <a16:creationId xmlns:a16="http://schemas.microsoft.com/office/drawing/2014/main" id="{4B1D64F5-DC8F-4B05-ABCE-EFBB36B91630}"/>
               </a:ext>
             </a:extLst>
           </p:cNvPr>
@@ -22690,7 +22690,7 @@
           <p:cNvPr id="11" name="">
             <a:extLst xmlns:a="http://schemas.openxmlformats.org/drawingml/2006/main">
               <a:ext uri="{FF2B5EF4-FFF2-40B4-BE49-F238E27FC236}">
-                <a16:creationId xmlns:a16="http://schemas.microsoft.com/office/drawing/2014/main" id="{4B95CC5A-5C7E-4101-8FDD-AE8AF5D9BF5D}"/>
+                <a16:creationId xmlns:a16="http://schemas.microsoft.com/office/drawing/2014/main" id="{4C2B0E09-6E28-455F-8C01-8D5868ED091A}"/>
               </a:ext>
             </a:extLst>
           </p:cNvPr>
@@ -22721,7 +22721,7 @@
           <p:cNvPr id="12" name="image-contracts.md">
             <a:extLst xmlns:a="http://schemas.openxmlformats.org/drawingml/2006/main">
               <a:ext uri="{FF2B5EF4-FFF2-40B4-BE49-F238E27FC236}">
-                <a16:creationId xmlns:a16="http://schemas.microsoft.com/office/drawing/2014/main" id="{60DD992B-3694-483C-8F13-6DD2566435F1}"/>
+                <a16:creationId xmlns:a16="http://schemas.microsoft.com/office/drawing/2014/main" id="{0BE29909-2443-4399-9146-46A774833577}"/>
               </a:ext>
             </a:extLst>
           </p:cNvPr>
@@ -22879,7 +22879,7 @@
           <p:cNvPr id="13" name="읽음">
             <a:extLst xmlns:a="http://schemas.openxmlformats.org/drawingml/2006/main">
               <a:ext uri="{FF2B5EF4-FFF2-40B4-BE49-F238E27FC236}">
-                <a16:creationId xmlns:a16="http://schemas.microsoft.com/office/drawing/2014/main" id="{892848F4-FF14-44F7-AFDA-80570F351933}"/>
+                <a16:creationId xmlns:a16="http://schemas.microsoft.com/office/drawing/2014/main" id="{F0D31294-9BBC-4462-8DB4-F3957312DE70}"/>
               </a:ext>
             </a:extLst>
           </p:cNvPr>
@@ -23037,7 +23037,7 @@
           <p:cNvPr id="14" name="읽지 않음">
             <a:extLst xmlns:a="http://schemas.openxmlformats.org/drawingml/2006/main">
               <a:ext uri="{FF2B5EF4-FFF2-40B4-BE49-F238E27FC236}">
-                <a16:creationId xmlns:a16="http://schemas.microsoft.com/office/drawing/2014/main" id="{DB0C7DDB-6ABA-4699-A51E-6F7C16E7E92D}"/>
+                <a16:creationId xmlns:a16="http://schemas.microsoft.com/office/drawing/2014/main" id="{33F166E5-EEDA-4D8D-9F40-5694832A75C9}"/>
               </a:ext>
             </a:extLst>
           </p:cNvPr>
@@ -23195,7 +23195,7 @@
           <p:cNvPr id="15" name="">
             <a:extLst xmlns:a="http://schemas.openxmlformats.org/drawingml/2006/main">
               <a:ext uri="{FF2B5EF4-FFF2-40B4-BE49-F238E27FC236}">
-                <a16:creationId xmlns:a16="http://schemas.microsoft.com/office/drawing/2014/main" id="{2CE15A9A-6993-48C2-B8D6-2EE369DD4B8D}"/>
+                <a16:creationId xmlns:a16="http://schemas.microsoft.com/office/drawing/2014/main" id="{2B98DB04-2015-43AF-8AEB-5CD6AF934EFB}"/>
               </a:ext>
             </a:extLst>
           </p:cNvPr>
@@ -23226,7 +23226,7 @@
           <p:cNvPr id="16" name="architecture.md">
             <a:extLst xmlns:a="http://schemas.openxmlformats.org/drawingml/2006/main">
               <a:ext uri="{FF2B5EF4-FFF2-40B4-BE49-F238E27FC236}">
-                <a16:creationId xmlns:a16="http://schemas.microsoft.com/office/drawing/2014/main" id="{AAB4FA31-84BB-452C-90BA-850FDF723435}"/>
+                <a16:creationId xmlns:a16="http://schemas.microsoft.com/office/drawing/2014/main" id="{C75C48EC-8575-4633-BDFE-41598AA7E10A}"/>
               </a:ext>
             </a:extLst>
           </p:cNvPr>
@@ -23384,7 +23384,7 @@
           <p:cNvPr id="17" name="읽음">
             <a:extLst xmlns:a="http://schemas.openxmlformats.org/drawingml/2006/main">
               <a:ext uri="{FF2B5EF4-FFF2-40B4-BE49-F238E27FC236}">
-                <a16:creationId xmlns:a16="http://schemas.microsoft.com/office/drawing/2014/main" id="{E9728C91-2B3B-44FA-94AF-858C42CB5C29}"/>
+                <a16:creationId xmlns:a16="http://schemas.microsoft.com/office/drawing/2014/main" id="{4C38ADF4-1BC5-4612-A4B6-CF1315BD6338}"/>
               </a:ext>
             </a:extLst>
           </p:cNvPr>
@@ -23542,7 +23542,7 @@
           <p:cNvPr id="18" name="읽음">
             <a:extLst xmlns:a="http://schemas.openxmlformats.org/drawingml/2006/main">
               <a:ext uri="{FF2B5EF4-FFF2-40B4-BE49-F238E27FC236}">
-                <a16:creationId xmlns:a16="http://schemas.microsoft.com/office/drawing/2014/main" id="{83B45993-FCB1-49C6-99BA-F7B22538930D}"/>
+                <a16:creationId xmlns:a16="http://schemas.microsoft.com/office/drawing/2014/main" id="{B0CBE9A0-42DC-473D-A90B-5D4DCE795D7B}"/>
               </a:ext>
             </a:extLst>
           </p:cNvPr>
@@ -23700,7 +23700,7 @@
           <p:cNvPr id="19" name="">
             <a:extLst xmlns:a="http://schemas.openxmlformats.org/drawingml/2006/main">
               <a:ext uri="{FF2B5EF4-FFF2-40B4-BE49-F238E27FC236}">
-                <a16:creationId xmlns:a16="http://schemas.microsoft.com/office/drawing/2014/main" id="{38F6034A-59C1-45CD-B77E-8D8FCA62DFEF}"/>
+                <a16:creationId xmlns:a16="http://schemas.microsoft.com/office/drawing/2014/main" id="{77FC11CD-67E2-48EB-AE6C-792220B55167}"/>
               </a:ext>
             </a:extLst>
           </p:cNvPr>
@@ -23731,7 +23731,7 @@
           <p:cNvPr id="20" name="testing.md">
             <a:extLst xmlns:a="http://schemas.openxmlformats.org/drawingml/2006/main">
               <a:ext uri="{FF2B5EF4-FFF2-40B4-BE49-F238E27FC236}">
-                <a16:creationId xmlns:a16="http://schemas.microsoft.com/office/drawing/2014/main" id="{75DAD287-871B-4CB4-82DD-07EE63F75171}"/>
+                <a16:creationId xmlns:a16="http://schemas.microsoft.com/office/drawing/2014/main" id="{7C2840AA-F514-4407-8C4E-6A3E0FA50580}"/>
               </a:ext>
             </a:extLst>
           </p:cNvPr>
@@ -23889,7 +23889,7 @@
           <p:cNvPr id="21" name="최종 실행에서 읽음">
             <a:extLst xmlns:a="http://schemas.openxmlformats.org/drawingml/2006/main">
               <a:ext uri="{FF2B5EF4-FFF2-40B4-BE49-F238E27FC236}">
-                <a16:creationId xmlns:a16="http://schemas.microsoft.com/office/drawing/2014/main" id="{C461EFEF-7848-4854-B4C5-D20DB4217727}"/>
+                <a16:creationId xmlns:a16="http://schemas.microsoft.com/office/drawing/2014/main" id="{F0C425D9-6B4D-45C3-87B0-3C4959CB7B2C}"/>
               </a:ext>
             </a:extLst>
           </p:cNvPr>
@@ -24047,7 +24047,7 @@
           <p:cNvPr id="22" name="읽지 않음">
             <a:extLst xmlns:a="http://schemas.openxmlformats.org/drawingml/2006/main">
               <a:ext uri="{FF2B5EF4-FFF2-40B4-BE49-F238E27FC236}">
-                <a16:creationId xmlns:a16="http://schemas.microsoft.com/office/drawing/2014/main" id="{E09E663C-F7B0-445A-9B59-980E1091F93B}"/>
+                <a16:creationId xmlns:a16="http://schemas.microsoft.com/office/drawing/2014/main" id="{E2F83B06-B930-453A-9759-20FEF39C59B1}"/>
               </a:ext>
             </a:extLst>
           </p:cNvPr>
@@ -24205,7 +24205,7 @@
           <p:cNvPr id="23" name="A에는 더 넓은 읽기도 존재 · B는 설정·README·source도 확인">
             <a:extLst xmlns:a="http://schemas.openxmlformats.org/drawingml/2006/main">
               <a:ext uri="{FF2B5EF4-FFF2-40B4-BE49-F238E27FC236}">
-                <a16:creationId xmlns:a16="http://schemas.microsoft.com/office/drawing/2014/main" id="{DFFF32B3-E9E2-4BEB-970B-A46CEFF3BFD1}"/>
+                <a16:creationId xmlns:a16="http://schemas.microsoft.com/office/drawing/2014/main" id="{28EC7615-6EAB-4072-ADFE-C8F025930335}"/>
               </a:ext>
             </a:extLst>
           </p:cNvPr>
@@ -24363,7 +24363,7 @@
           <p:cNvPr id="24" name="Legacy module connection">
             <a:extLst xmlns:a="http://schemas.openxmlformats.org/drawingml/2006/main">
               <a:ext uri="{FF2B5EF4-FFF2-40B4-BE49-F238E27FC236}">
-                <a16:creationId xmlns:a16="http://schemas.microsoft.com/office/drawing/2014/main" id="{C1AA4D3C-4EAD-4A79-B439-E66CE52BC9C3}"/>
+                <a16:creationId xmlns:a16="http://schemas.microsoft.com/office/drawing/2014/main" id="{251F5933-9A8F-4226-9295-E24BB9CCCE46}"/>
               </a:ext>
             </a:extLst>
           </p:cNvPr>
@@ -24519,7 +24519,7 @@
     </p:spTree>
     <p:extLst>
       <p:ext uri="{BB962C8B-B14F-4D97-AF65-F5344CB8AC3E}">
-        <p14:creationId xmlns:p14="http://schemas.microsoft.com/office/powerpoint/2010/main" val="977044045"/>
+        <p14:creationId xmlns:p14="http://schemas.microsoft.com/office/powerpoint/2010/main" val="1247628781"/>
       </p:ext>
     </p:extLst>
   </p:cSld>
@@ -24550,7 +24550,7 @@
           <p:cNvPr id="15" name="ACT 2 · 다음 문제로 넘어가기">
             <a:extLst xmlns:a="http://schemas.openxmlformats.org/drawingml/2006/main">
               <a:ext uri="{FF2B5EF4-FFF2-40B4-BE49-F238E27FC236}">
-                <a16:creationId xmlns:a16="http://schemas.microsoft.com/office/drawing/2014/main" id="{F2F59B86-25DA-46F3-A351-54D55D037A66}"/>
+                <a16:creationId xmlns:a16="http://schemas.microsoft.com/office/drawing/2014/main" id="{D2074795-EC50-4C00-8A2A-05D598C4C641}"/>
               </a:ext>
             </a:extLst>
           </p:cNvPr>
@@ -24705,10 +24705,10 @@
       </p:sp>
       <p:sp>
         <p:nvSpPr>
-          <p:cNvPr id="2" name="S38">
+          <p:cNvPr id="2" name="S46">
             <a:extLst xmlns:a="http://schemas.openxmlformats.org/drawingml/2006/main">
               <a:ext uri="{FF2B5EF4-FFF2-40B4-BE49-F238E27FC236}">
-                <a16:creationId xmlns:a16="http://schemas.microsoft.com/office/drawing/2014/main" id="{1D0091E2-F529-45FE-91DD-9E40362208CA}"/>
+                <a16:creationId xmlns:a16="http://schemas.microsoft.com/office/drawing/2014/main" id="{3B3F5327-DE06-4000-8543-C90B3BB0A767}"/>
               </a:ext>
             </a:extLst>
           </p:cNvPr>
@@ -24856,7 +24856,7 @@
                 <a:ea typeface="Malgun Gothic"/>
                 <a:cs typeface="Malgun Gothic"/>
               </a:rPr>
-              <a:t>S38</a:t>
+              <a:t>S46</a:t>
             </a:r>
           </a:p>
         </p:txBody>
@@ -24866,7 +24866,7 @@
           <p:cNvPr id="3" name="지식은 정리됐지만 절차는 반복된다">
             <a:extLst xmlns:a="http://schemas.openxmlformats.org/drawingml/2006/main">
               <a:ext uri="{FF2B5EF4-FFF2-40B4-BE49-F238E27FC236}">
-                <a16:creationId xmlns:a16="http://schemas.microsoft.com/office/drawing/2014/main" id="{AB1EC7B7-316B-4338-BF80-88A92D253F2A}"/>
+                <a16:creationId xmlns:a16="http://schemas.microsoft.com/office/drawing/2014/main" id="{9DB6241A-ED1A-4B90-BED4-7028FCB66EDE}"/>
               </a:ext>
             </a:extLst>
           </p:cNvPr>
@@ -25024,7 +25024,7 @@
           <p:cNvPr id="4" name="">
             <a:extLst xmlns:a="http://schemas.openxmlformats.org/drawingml/2006/main">
               <a:ext uri="{FF2B5EF4-FFF2-40B4-BE49-F238E27FC236}">
-                <a16:creationId xmlns:a16="http://schemas.microsoft.com/office/drawing/2014/main" id="{2272D1AF-0C06-418D-9990-A4D4B2FCEFFF}"/>
+                <a16:creationId xmlns:a16="http://schemas.microsoft.com/office/drawing/2014/main" id="{97C228F2-E776-4BB8-9213-BD3DEB4581EA}"/>
               </a:ext>
             </a:extLst>
           </p:cNvPr>
@@ -25055,7 +25055,7 @@
           <p:cNvPr id="5" name="Project Context 정리 + TRIAL-006/007의 반복 절차 · 기록 요약과 교육용 해석">
             <a:extLst xmlns:a="http://schemas.openxmlformats.org/drawingml/2006/main">
               <a:ext uri="{FF2B5EF4-FFF2-40B4-BE49-F238E27FC236}">
-                <a16:creationId xmlns:a16="http://schemas.microsoft.com/office/drawing/2014/main" id="{DDBC6394-132B-4EF0-9626-E1686EC64729}"/>
+                <a16:creationId xmlns:a16="http://schemas.microsoft.com/office/drawing/2014/main" id="{BBA2F423-1DFD-4ED2-8639-343BBA787C2C}"/>
               </a:ext>
             </a:extLst>
           </p:cNvPr>
@@ -25213,7 +25213,7 @@
           <p:cNvPr id="6" name="절차가 반복된 원인을 Prompt만으로 분리하지 않음">
             <a:extLst xmlns:a="http://schemas.openxmlformats.org/drawingml/2006/main">
               <a:ext uri="{FF2B5EF4-FFF2-40B4-BE49-F238E27FC236}">
-                <a16:creationId xmlns:a16="http://schemas.microsoft.com/office/drawing/2014/main" id="{393946CD-5EE2-4C34-898C-8D83C48A9330}"/>
+                <a16:creationId xmlns:a16="http://schemas.microsoft.com/office/drawing/2014/main" id="{CCEF938C-0398-4001-AC1C-412A9E3DB132}"/>
               </a:ext>
             </a:extLst>
           </p:cNvPr>
@@ -25371,7 +25371,7 @@
           <p:cNvPr id="7" name="정리한 것">
             <a:extLst xmlns:a="http://schemas.openxmlformats.org/drawingml/2006/main">
               <a:ext uri="{FF2B5EF4-FFF2-40B4-BE49-F238E27FC236}">
-                <a16:creationId xmlns:a16="http://schemas.microsoft.com/office/drawing/2014/main" id="{EF6CA940-CEE3-43A4-9243-71208E2ACE89}"/>
+                <a16:creationId xmlns:a16="http://schemas.microsoft.com/office/drawing/2014/main" id="{B027F458-54E3-4BD9-BDD1-1E2812B9BDE6}"/>
               </a:ext>
             </a:extLst>
           </p:cNvPr>
@@ -25529,7 +25529,7 @@
           <p:cNvPr id="8" name="아직 반복되는 것">
             <a:extLst xmlns:a="http://schemas.openxmlformats.org/drawingml/2006/main">
               <a:ext uri="{FF2B5EF4-FFF2-40B4-BE49-F238E27FC236}">
-                <a16:creationId xmlns:a16="http://schemas.microsoft.com/office/drawing/2014/main" id="{EBCBB723-29BC-4BA2-ACF3-CCAF77E3C2EF}"/>
+                <a16:creationId xmlns:a16="http://schemas.microsoft.com/office/drawing/2014/main" id="{698707A9-FC5C-4CBF-899D-FE4E6DEB24C7}"/>
               </a:ext>
             </a:extLst>
           </p:cNvPr>
@@ -25687,7 +25687,7 @@
           <p:cNvPr id="9" name="">
             <a:extLst xmlns:a="http://schemas.openxmlformats.org/drawingml/2006/main">
               <a:ext uri="{FF2B5EF4-FFF2-40B4-BE49-F238E27FC236}">
-                <a16:creationId xmlns:a16="http://schemas.microsoft.com/office/drawing/2014/main" id="{346F96E6-26B2-4773-98B1-831B29A3615E}"/>
+                <a16:creationId xmlns:a16="http://schemas.microsoft.com/office/drawing/2014/main" id="{632D5674-816C-4A98-B8EF-8FED9AEF89A6}"/>
               </a:ext>
             </a:extLst>
           </p:cNvPr>
@@ -25718,7 +25718,7 @@
           <p:cNvPr id="10" name="">
             <a:extLst xmlns:a="http://schemas.openxmlformats.org/drawingml/2006/main">
               <a:ext uri="{FF2B5EF4-FFF2-40B4-BE49-F238E27FC236}">
-                <a16:creationId xmlns:a16="http://schemas.microsoft.com/office/drawing/2014/main" id="{A3A0A84A-26F5-46DB-B12E-F414D7469476}"/>
+                <a16:creationId xmlns:a16="http://schemas.microsoft.com/office/drawing/2014/main" id="{3DC5FC71-FA40-49D8-B95D-52F7BBFC81A7}"/>
               </a:ext>
             </a:extLst>
           </p:cNvPr>
@@ -25749,7 +25749,7 @@
           <p:cNvPr id="11" name="현재 목표는 Prompt에&#10;공통 사실은 Project Context에&#10;상세 정보는 Routing으로">
             <a:extLst xmlns:a="http://schemas.openxmlformats.org/drawingml/2006/main">
               <a:ext uri="{FF2B5EF4-FFF2-40B4-BE49-F238E27FC236}">
-                <a16:creationId xmlns:a16="http://schemas.microsoft.com/office/drawing/2014/main" id="{FB457EF7-BBA0-4F93-B996-8346A712C989}"/>
+                <a16:creationId xmlns:a16="http://schemas.microsoft.com/office/drawing/2014/main" id="{ACC831F5-A271-4273-8D6F-8604B1C5D18A}"/>
               </a:ext>
             </a:extLst>
           </p:cNvPr>
@@ -25953,7 +25953,7 @@
           <p:cNvPr id="12" name="먼저 측정하고&#10;조사한 뒤 변경하고&#10;같은 조건으로 확인해줘">
             <a:extLst xmlns:a="http://schemas.openxmlformats.org/drawingml/2006/main">
               <a:ext uri="{FF2B5EF4-FFF2-40B4-BE49-F238E27FC236}">
-                <a16:creationId xmlns:a16="http://schemas.microsoft.com/office/drawing/2014/main" id="{006EDA5A-516F-40EA-A686-FC290C249F90}"/>
+                <a16:creationId xmlns:a16="http://schemas.microsoft.com/office/drawing/2014/main" id="{A3DD0C4A-40C6-487F-B47C-F7935BFB16ED}"/>
               </a:ext>
             </a:extLst>
           </p:cNvPr>
@@ -26157,7 +26157,7 @@
           <p:cNvPr id="13" name="같은 작업 절차도 다시 써야 할까?">
             <a:extLst xmlns:a="http://schemas.openxmlformats.org/drawingml/2006/main">
               <a:ext uri="{FF2B5EF4-FFF2-40B4-BE49-F238E27FC236}">
-                <a16:creationId xmlns:a16="http://schemas.microsoft.com/office/drawing/2014/main" id="{91FD492B-DF20-46AE-BDC3-F23BAF883C75}"/>
+                <a16:creationId xmlns:a16="http://schemas.microsoft.com/office/drawing/2014/main" id="{4772B232-DD05-4D02-9BB9-F70367FE68F1}"/>
               </a:ext>
             </a:extLst>
           </p:cNvPr>
@@ -26315,7 +26315,7 @@
           <p:cNvPr id="14" name="Legacy module connection">
             <a:extLst xmlns:a="http://schemas.openxmlformats.org/drawingml/2006/main">
               <a:ext uri="{FF2B5EF4-FFF2-40B4-BE49-F238E27FC236}">
-                <a16:creationId xmlns:a16="http://schemas.microsoft.com/office/drawing/2014/main" id="{B7292C99-5DC7-48AB-99CC-64A1391B27DB}"/>
+                <a16:creationId xmlns:a16="http://schemas.microsoft.com/office/drawing/2014/main" id="{AD459938-2815-4A57-8BAC-6772D4E327E9}"/>
               </a:ext>
             </a:extLst>
           </p:cNvPr>
@@ -26471,7 +26471,7 @@
     </p:spTree>
     <p:extLst>
       <p:ext uri="{BB962C8B-B14F-4D97-AF65-F5344CB8AC3E}">
-        <p14:creationId xmlns:p14="http://schemas.microsoft.com/office/powerpoint/2010/main" val="70205586"/>
+        <p14:creationId xmlns:p14="http://schemas.microsoft.com/office/powerpoint/2010/main" val="1813346992"/>
       </p:ext>
     </p:extLst>
   </p:cSld>
@@ -26502,7 +26502,7 @@
           <p:cNvPr id="27" name="ACT 2  ·  Project Context">
             <a:extLst xmlns:a="http://schemas.openxmlformats.org/drawingml/2006/main">
               <a:ext uri="{FF2B5EF4-FFF2-40B4-BE49-F238E27FC236}">
-                <a16:creationId xmlns:a16="http://schemas.microsoft.com/office/drawing/2014/main" id="{5EA525EC-3102-4308-B12A-FF7DCA771532}"/>
+                <a16:creationId xmlns:a16="http://schemas.microsoft.com/office/drawing/2014/main" id="{B151911A-29E0-4AE4-A662-A06F938A0CDB}"/>
               </a:ext>
             </a:extLst>
           </p:cNvPr>
@@ -26657,10 +26657,10 @@
       </p:sp>
       <p:sp>
         <p:nvSpPr>
-          <p:cNvPr id="2" name="S25">
+          <p:cNvPr id="2" name="S33">
             <a:extLst xmlns:a="http://schemas.openxmlformats.org/drawingml/2006/main">
               <a:ext uri="{FF2B5EF4-FFF2-40B4-BE49-F238E27FC236}">
-                <a16:creationId xmlns:a16="http://schemas.microsoft.com/office/drawing/2014/main" id="{8A020322-D3A4-4D7E-A1A7-94B1B6C5FF90}"/>
+                <a16:creationId xmlns:a16="http://schemas.microsoft.com/office/drawing/2014/main" id="{26C4688C-44FF-47DF-B058-8EFEBAD293E8}"/>
               </a:ext>
             </a:extLst>
           </p:cNvPr>
@@ -26808,7 +26808,7 @@
                 <a:ea typeface="Malgun Gothic"/>
                 <a:cs typeface="Malgun Gothic"/>
               </a:rPr>
-              <a:t>S25</a:t>
+              <a:t>S33</a:t>
             </a:r>
           </a:p>
         </p:txBody>
@@ -26818,7 +26818,7 @@
           <p:cNvPr id="3" name="작은 Project Context의 첫 기록">
             <a:extLst xmlns:a="http://schemas.openxmlformats.org/drawingml/2006/main">
               <a:ext uri="{FF2B5EF4-FFF2-40B4-BE49-F238E27FC236}">
-                <a16:creationId xmlns:a16="http://schemas.microsoft.com/office/drawing/2014/main" id="{2AF56E88-9176-416D-BB44-E60AD4DA5933}"/>
+                <a16:creationId xmlns:a16="http://schemas.microsoft.com/office/drawing/2014/main" id="{0247EA3D-A134-4D35-809C-1C1FD1FADEE0}"/>
               </a:ext>
             </a:extLst>
           </p:cNvPr>
@@ -26976,7 +26976,7 @@
           <p:cNvPr id="4" name="">
             <a:extLst xmlns:a="http://schemas.openxmlformats.org/drawingml/2006/main">
               <a:ext uri="{FF2B5EF4-FFF2-40B4-BE49-F238E27FC236}">
-                <a16:creationId xmlns:a16="http://schemas.microsoft.com/office/drawing/2014/main" id="{C8D6C66F-53A2-4207-B823-A18ADC0D02CA}"/>
+                <a16:creationId xmlns:a16="http://schemas.microsoft.com/office/drawing/2014/main" id="{B5800E12-2DDC-4847-83FC-5FB247C13F32}"/>
               </a:ext>
             </a:extLst>
           </p:cNvPr>
@@ -27007,7 +27007,7 @@
           <p:cNvPr id="5" name="OBSERVED PRODUCT  |  STATE-01 · AGENTS.md 실제 원문 발췌">
             <a:extLst xmlns:a="http://schemas.openxmlformats.org/drawingml/2006/main">
               <a:ext uri="{FF2B5EF4-FFF2-40B4-BE49-F238E27FC236}">
-                <a16:creationId xmlns:a16="http://schemas.microsoft.com/office/drawing/2014/main" id="{AB30341F-4C1A-423A-874E-32B4E498442F}"/>
+                <a16:creationId xmlns:a16="http://schemas.microsoft.com/office/drawing/2014/main" id="{4DFA1924-D945-4092-B1D3-61A59B8F054D}"/>
               </a:ext>
             </a:extLst>
           </p:cNvPr>
@@ -27165,7 +27165,7 @@
           <p:cNvPr id="6" name="파일의 내용과 기록 위치를 보여주는 장 · Agent의 활용 관찰은 다음 장에서 확인">
             <a:extLst xmlns:a="http://schemas.openxmlformats.org/drawingml/2006/main">
               <a:ext uri="{FF2B5EF4-FFF2-40B4-BE49-F238E27FC236}">
-                <a16:creationId xmlns:a16="http://schemas.microsoft.com/office/drawing/2014/main" id="{C2035953-989D-465A-A1D4-B18FC3F24B2D}"/>
+                <a16:creationId xmlns:a16="http://schemas.microsoft.com/office/drawing/2014/main" id="{996CC426-F1C8-411C-818E-7488C11270CD}"/>
               </a:ext>
             </a:extLst>
           </p:cNvPr>
@@ -27323,7 +27323,7 @@
           <p:cNvPr id="7" name="반복해서 설명하던 내용을 저장소에 남겼다">
             <a:extLst xmlns:a="http://schemas.openxmlformats.org/drawingml/2006/main">
               <a:ext uri="{FF2B5EF4-FFF2-40B4-BE49-F238E27FC236}">
-                <a16:creationId xmlns:a16="http://schemas.microsoft.com/office/drawing/2014/main" id="{52D8D9EE-7919-4948-9DE4-D5254778CBB1}"/>
+                <a16:creationId xmlns:a16="http://schemas.microsoft.com/office/drawing/2014/main" id="{68C8C39C-9C70-4342-86B4-8537BC4EAF82}"/>
               </a:ext>
             </a:extLst>
           </p:cNvPr>
@@ -27481,7 +27481,7 @@
           <p:cNvPr id="8" name="AGENTS.md">
             <a:extLst xmlns:a="http://schemas.openxmlformats.org/drawingml/2006/main">
               <a:ext uri="{FF2B5EF4-FFF2-40B4-BE49-F238E27FC236}">
-                <a16:creationId xmlns:a16="http://schemas.microsoft.com/office/drawing/2014/main" id="{E76EDB8E-F916-492A-9DA3-BA11A0883D59}"/>
+                <a16:creationId xmlns:a16="http://schemas.microsoft.com/office/drawing/2014/main" id="{0D15D344-8B8D-4EF5-A22B-3508278EDAC6}"/>
               </a:ext>
             </a:extLst>
           </p:cNvPr>
@@ -27639,7 +27639,7 @@
           <p:cNvPr id="9" name="STATE-00-FIXED → STATE-01">
             <a:extLst xmlns:a="http://schemas.openxmlformats.org/drawingml/2006/main">
               <a:ext uri="{FF2B5EF4-FFF2-40B4-BE49-F238E27FC236}">
-                <a16:creationId xmlns:a16="http://schemas.microsoft.com/office/drawing/2014/main" id="{570D8D2A-35D9-467A-A070-61E2582FECBB}"/>
+                <a16:creationId xmlns:a16="http://schemas.microsoft.com/office/drawing/2014/main" id="{359769FA-0C24-4854-8955-48DE2BA6F013}"/>
               </a:ext>
             </a:extLst>
           </p:cNvPr>
@@ -27797,7 +27797,7 @@
           <p:cNvPr id="10" name="">
             <a:extLst xmlns:a="http://schemas.openxmlformats.org/drawingml/2006/main">
               <a:ext uri="{FF2B5EF4-FFF2-40B4-BE49-F238E27FC236}">
-                <a16:creationId xmlns:a16="http://schemas.microsoft.com/office/drawing/2014/main" id="{D44B208C-BA99-4DA9-A154-523D566D0CBD}"/>
+                <a16:creationId xmlns:a16="http://schemas.microsoft.com/office/drawing/2014/main" id="{6D43D2A3-FA1B-4F37-A2C2-BCA67912F646}"/>
               </a:ext>
             </a:extLst>
           </p:cNvPr>
@@ -27828,7 +27828,7 @@
           <p:cNvPr id="11" name="프로젝트 목적">
             <a:extLst xmlns:a="http://schemas.openxmlformats.org/drawingml/2006/main">
               <a:ext uri="{FF2B5EF4-FFF2-40B4-BE49-F238E27FC236}">
-                <a16:creationId xmlns:a16="http://schemas.microsoft.com/office/drawing/2014/main" id="{99FE8E53-F31F-4261-BD05-5CF3FB12AE92}"/>
+                <a16:creationId xmlns:a16="http://schemas.microsoft.com/office/drawing/2014/main" id="{18DA471A-573C-49FF-BFEB-1D5C0DADE4F9}"/>
               </a:ext>
             </a:extLst>
           </p:cNvPr>
@@ -27986,7 +27986,7 @@
           <p:cNvPr id="12" name="Local grayscale image-processing CLI using synthetic ASCII P">
             <a:extLst xmlns:a="http://schemas.openxmlformats.org/drawingml/2006/main">
               <a:ext uri="{FF2B5EF4-FFF2-40B4-BE49-F238E27FC236}">
-                <a16:creationId xmlns:a16="http://schemas.microsoft.com/office/drawing/2014/main" id="{654B969D-3CE6-49D8-A9AB-030343568C11}"/>
+                <a16:creationId xmlns:a16="http://schemas.microsoft.com/office/drawing/2014/main" id="{2894C121-0D64-47F7-858C-A48FA5D556A4}"/>
               </a:ext>
             </a:extLst>
           </p:cNvPr>
@@ -28166,7 +28166,7 @@
           <p:cNvPr id="13" name="로컬 합성 이미지로 동작하는 흑백 처리 CLI">
             <a:extLst xmlns:a="http://schemas.openxmlformats.org/drawingml/2006/main">
               <a:ext uri="{FF2B5EF4-FFF2-40B4-BE49-F238E27FC236}">
-                <a16:creationId xmlns:a16="http://schemas.microsoft.com/office/drawing/2014/main" id="{C549EF8A-0ABC-4549-B806-CEA9422181D5}"/>
+                <a16:creationId xmlns:a16="http://schemas.microsoft.com/office/drawing/2014/main" id="{73E66AD6-164F-4776-9F6B-DC47D5FC6B38}"/>
               </a:ext>
             </a:extLst>
           </p:cNvPr>
@@ -28324,7 +28324,7 @@
           <p:cNvPr id="14" name="">
             <a:extLst xmlns:a="http://schemas.openxmlformats.org/drawingml/2006/main">
               <a:ext uri="{FF2B5EF4-FFF2-40B4-BE49-F238E27FC236}">
-                <a16:creationId xmlns:a16="http://schemas.microsoft.com/office/drawing/2014/main" id="{8CFF0CF9-8264-45F4-AA14-39FDC36325F4}"/>
+                <a16:creationId xmlns:a16="http://schemas.microsoft.com/office/drawing/2014/main" id="{785D22AA-9D40-4FC5-99C7-E33AE058E70F}"/>
               </a:ext>
             </a:extLst>
           </p:cNvPr>
@@ -28355,7 +28355,7 @@
           <p:cNvPr id="15" name="실행 방법">
             <a:extLst xmlns:a="http://schemas.openxmlformats.org/drawingml/2006/main">
               <a:ext uri="{FF2B5EF4-FFF2-40B4-BE49-F238E27FC236}">
-                <a16:creationId xmlns:a16="http://schemas.microsoft.com/office/drawing/2014/main" id="{268491DD-CC6F-4491-B16C-D999782934F1}"/>
+                <a16:creationId xmlns:a16="http://schemas.microsoft.com/office/drawing/2014/main" id="{AE62AEE4-6328-4ECC-9F05-41B4D2AE27FC}"/>
               </a:ext>
             </a:extLst>
           </p:cNvPr>
@@ -28513,7 +28513,7 @@
           <p:cNvPr id="16" name="Use the prepared build and CLI commands documented in `READM">
             <a:extLst xmlns:a="http://schemas.openxmlformats.org/drawingml/2006/main">
               <a:ext uri="{FF2B5EF4-FFF2-40B4-BE49-F238E27FC236}">
-                <a16:creationId xmlns:a16="http://schemas.microsoft.com/office/drawing/2014/main" id="{96F0DDF4-AD7A-4B2D-8CC0-FBF1A6B3290D}"/>
+                <a16:creationId xmlns:a16="http://schemas.microsoft.com/office/drawing/2014/main" id="{AEE73BC0-A114-4241-9602-2919F548EAD9}"/>
               </a:ext>
             </a:extLst>
           </p:cNvPr>
@@ -28693,7 +28693,7 @@
           <p:cNvPr id="17" name="실행 방법은 README에서 확인">
             <a:extLst xmlns:a="http://schemas.openxmlformats.org/drawingml/2006/main">
               <a:ext uri="{FF2B5EF4-FFF2-40B4-BE49-F238E27FC236}">
-                <a16:creationId xmlns:a16="http://schemas.microsoft.com/office/drawing/2014/main" id="{2DA3F826-9F61-45AF-8E0F-FDE9B55D024F}"/>
+                <a16:creationId xmlns:a16="http://schemas.microsoft.com/office/drawing/2014/main" id="{41B4B794-E4C4-42CE-8541-AE527A026DDE}"/>
               </a:ext>
             </a:extLst>
           </p:cNvPr>
@@ -28851,7 +28851,7 @@
           <p:cNvPr id="18" name="">
             <a:extLst xmlns:a="http://schemas.openxmlformats.org/drawingml/2006/main">
               <a:ext uri="{FF2B5EF4-FFF2-40B4-BE49-F238E27FC236}">
-                <a16:creationId xmlns:a16="http://schemas.microsoft.com/office/drawing/2014/main" id="{8EF27CE2-BC28-45DB-91AE-A1D6A2D43FFB}"/>
+                <a16:creationId xmlns:a16="http://schemas.microsoft.com/office/drawing/2014/main" id="{3894BC0C-25F9-4B30-9975-E719A2025CA9}"/>
               </a:ext>
             </a:extLst>
           </p:cNvPr>
@@ -28882,7 +28882,7 @@
           <p:cNvPr id="19" name="테스트 명령">
             <a:extLst xmlns:a="http://schemas.openxmlformats.org/drawingml/2006/main">
               <a:ext uri="{FF2B5EF4-FFF2-40B4-BE49-F238E27FC236}">
-                <a16:creationId xmlns:a16="http://schemas.microsoft.com/office/drawing/2014/main" id="{B351ADAA-A0CA-4E03-BC27-AEEEBFA5C675}"/>
+                <a16:creationId xmlns:a16="http://schemas.microsoft.com/office/drawing/2014/main" id="{4BE4D2C4-C558-4282-9D95-8EAD07FDE798}"/>
               </a:ext>
             </a:extLst>
           </p:cNvPr>
@@ -29040,7 +29040,7 @@
           <p:cNvPr id="20" name="PYTHONPATH=src python3 -m unittest discover -s tests -v">
             <a:extLst xmlns:a="http://schemas.openxmlformats.org/drawingml/2006/main">
               <a:ext uri="{FF2B5EF4-FFF2-40B4-BE49-F238E27FC236}">
-                <a16:creationId xmlns:a16="http://schemas.microsoft.com/office/drawing/2014/main" id="{1FBB4BA4-3D15-46C8-B025-D0C7B0210B99}"/>
+                <a16:creationId xmlns:a16="http://schemas.microsoft.com/office/drawing/2014/main" id="{BC423AA7-FDF4-48C3-8B91-2960D69C31C8}"/>
               </a:ext>
             </a:extLst>
           </p:cNvPr>
@@ -29198,7 +29198,7 @@
           <p:cNvPr id="21" name="반복해서 쓸 테스트 명령">
             <a:extLst xmlns:a="http://schemas.openxmlformats.org/drawingml/2006/main">
               <a:ext uri="{FF2B5EF4-FFF2-40B4-BE49-F238E27FC236}">
-                <a16:creationId xmlns:a16="http://schemas.microsoft.com/office/drawing/2014/main" id="{0C3327A6-9CC1-4AFC-9246-54C5C3A696CB}"/>
+                <a16:creationId xmlns:a16="http://schemas.microsoft.com/office/drawing/2014/main" id="{8DAADDBD-BA14-4AFA-8A30-BE6400C2FBEE}"/>
               </a:ext>
             </a:extLst>
           </p:cNvPr>
@@ -29356,7 +29356,7 @@
           <p:cNvPr id="22" name="">
             <a:extLst xmlns:a="http://schemas.openxmlformats.org/drawingml/2006/main">
               <a:ext uri="{FF2B5EF4-FFF2-40B4-BE49-F238E27FC236}">
-                <a16:creationId xmlns:a16="http://schemas.microsoft.com/office/drawing/2014/main" id="{676D1D36-0E7C-4288-B764-5D6BC26BA802}"/>
+                <a16:creationId xmlns:a16="http://schemas.microsoft.com/office/drawing/2014/main" id="{DE8CD8EE-99A6-4113-A14D-B19EB35C1B0C}"/>
               </a:ext>
             </a:extLst>
           </p:cNvPr>
@@ -29387,7 +29387,7 @@
           <p:cNvPr id="23" name="기본 제약">
             <a:extLst xmlns:a="http://schemas.openxmlformats.org/drawingml/2006/main">
               <a:ext uri="{FF2B5EF4-FFF2-40B4-BE49-F238E27FC236}">
-                <a16:creationId xmlns:a16="http://schemas.microsoft.com/office/drawing/2014/main" id="{8DBF654B-0266-48A3-827E-FEF961A85E55}"/>
+                <a16:creationId xmlns:a16="http://schemas.microsoft.com/office/drawing/2014/main" id="{79999889-D779-4790-B921-149B148BA2C2}"/>
               </a:ext>
             </a:extLst>
           </p:cNvPr>
@@ -29545,7 +29545,7 @@
           <p:cNvPr id="24" name="Keep changes scoped and verify relevant behavior.">
             <a:extLst xmlns:a="http://schemas.openxmlformats.org/drawingml/2006/main">
               <a:ext uri="{FF2B5EF4-FFF2-40B4-BE49-F238E27FC236}">
-                <a16:creationId xmlns:a16="http://schemas.microsoft.com/office/drawing/2014/main" id="{6D05210F-EC13-4142-BF5A-BBEABABD10AC}"/>
+                <a16:creationId xmlns:a16="http://schemas.microsoft.com/office/drawing/2014/main" id="{3FA66A92-4679-4D31-A6D1-AA4253A4C650}"/>
               </a:ext>
             </a:extLst>
           </p:cNvPr>
@@ -29725,7 +29725,7 @@
           <p:cNvPr id="25" name="범위를 지키고 관련 동작을 검증">
             <a:extLst xmlns:a="http://schemas.openxmlformats.org/drawingml/2006/main">
               <a:ext uri="{FF2B5EF4-FFF2-40B4-BE49-F238E27FC236}">
-                <a16:creationId xmlns:a16="http://schemas.microsoft.com/office/drawing/2014/main" id="{6F40A8AD-75E7-455D-80DC-65D0568DB70B}"/>
+                <a16:creationId xmlns:a16="http://schemas.microsoft.com/office/drawing/2014/main" id="{B4684E36-7BF3-4783-B48A-7A4916F0F156}"/>
               </a:ext>
             </a:extLst>
           </p:cNvPr>
@@ -29883,7 +29883,7 @@
           <p:cNvPr id="26" name="Legacy module connection">
             <a:extLst xmlns:a="http://schemas.openxmlformats.org/drawingml/2006/main">
               <a:ext uri="{FF2B5EF4-FFF2-40B4-BE49-F238E27FC236}">
-                <a16:creationId xmlns:a16="http://schemas.microsoft.com/office/drawing/2014/main" id="{7D1D38B8-D1E0-4986-990C-BC141E7F7609}"/>
+                <a16:creationId xmlns:a16="http://schemas.microsoft.com/office/drawing/2014/main" id="{AA7293DD-EC92-435E-950D-0A1CC39053D8}"/>
               </a:ext>
             </a:extLst>
           </p:cNvPr>
@@ -30039,7 +30039,7 @@
     </p:spTree>
     <p:extLst>
       <p:ext uri="{BB962C8B-B14F-4D97-AF65-F5344CB8AC3E}">
-        <p14:creationId xmlns:p14="http://schemas.microsoft.com/office/powerpoint/2010/main" val="1728219836"/>
+        <p14:creationId xmlns:p14="http://schemas.microsoft.com/office/powerpoint/2010/main" val="1043602072"/>
       </p:ext>
     </p:extLst>
   </p:cSld>
@@ -30070,7 +30070,7 @@
           <p:cNvPr id="24" name="ACT 2 · 지침을 활용한 관찰">
             <a:extLst xmlns:a="http://schemas.openxmlformats.org/drawingml/2006/main">
               <a:ext uri="{FF2B5EF4-FFF2-40B4-BE49-F238E27FC236}">
-                <a16:creationId xmlns:a16="http://schemas.microsoft.com/office/drawing/2014/main" id="{CB99CDCC-E303-484B-BF87-CF0995DEFA90}"/>
+                <a16:creationId xmlns:a16="http://schemas.microsoft.com/office/drawing/2014/main" id="{3A0E2348-95C0-47F7-80E4-38F194F87024}"/>
               </a:ext>
             </a:extLst>
           </p:cNvPr>
@@ -30225,10 +30225,10 @@
       </p:sp>
       <p:sp>
         <p:nvSpPr>
-          <p:cNvPr id="2" name="S26">
+          <p:cNvPr id="2" name="S34">
             <a:extLst xmlns:a="http://schemas.openxmlformats.org/drawingml/2006/main">
               <a:ext uri="{FF2B5EF4-FFF2-40B4-BE49-F238E27FC236}">
-                <a16:creationId xmlns:a16="http://schemas.microsoft.com/office/drawing/2014/main" id="{A8FDA1EC-3BCA-417F-A956-23D9A049301F}"/>
+                <a16:creationId xmlns:a16="http://schemas.microsoft.com/office/drawing/2014/main" id="{8A8B91A6-D668-45EE-BBC2-6FBF3CC814E3}"/>
               </a:ext>
             </a:extLst>
           </p:cNvPr>
@@ -30376,7 +30376,7 @@
                 <a:ea typeface="Malgun Gothic"/>
                 <a:cs typeface="Malgun Gothic"/>
               </a:rPr>
-              <a:t>S26</a:t>
+              <a:t>S34</a:t>
             </a:r>
           </a:p>
         </p:txBody>
@@ -30386,7 +30386,7 @@
           <p:cNvPr id="3" name="한 번의 사용에서 확인된 것">
             <a:extLst xmlns:a="http://schemas.openxmlformats.org/drawingml/2006/main">
               <a:ext uri="{FF2B5EF4-FFF2-40B4-BE49-F238E27FC236}">
-                <a16:creationId xmlns:a16="http://schemas.microsoft.com/office/drawing/2014/main" id="{009264A7-602D-4D0A-AA2B-854C4A627E88}"/>
+                <a16:creationId xmlns:a16="http://schemas.microsoft.com/office/drawing/2014/main" id="{6C704AED-400E-451F-8B93-50BA940F7935}"/>
               </a:ext>
             </a:extLst>
           </p:cNvPr>
@@ -30544,7 +30544,7 @@
           <p:cNvPr id="4" name="">
             <a:extLst xmlns:a="http://schemas.openxmlformats.org/drawingml/2006/main">
               <a:ext uri="{FF2B5EF4-FFF2-40B4-BE49-F238E27FC236}">
-                <a16:creationId xmlns:a16="http://schemas.microsoft.com/office/drawing/2014/main" id="{F9EE68DA-B049-450E-B579-541DCCA0B007}"/>
+                <a16:creationId xmlns:a16="http://schemas.microsoft.com/office/drawing/2014/main" id="{2EC8DA53-FF72-4373-97F1-C80B861A8E49}"/>
               </a:ext>
             </a:extLst>
           </p:cNvPr>
@@ -30575,7 +30575,7 @@
           <p:cNvPr id="5" name="TRIAL-003 · Codex CLI 기록을 재구성 · 전체 테스트 11/11 PASS">
             <a:extLst xmlns:a="http://schemas.openxmlformats.org/drawingml/2006/main">
               <a:ext uri="{FF2B5EF4-FFF2-40B4-BE49-F238E27FC236}">
-                <a16:creationId xmlns:a16="http://schemas.microsoft.com/office/drawing/2014/main" id="{8A73DE97-3F8B-4CAD-98F7-CB0FF1C820D2}"/>
+                <a16:creationId xmlns:a16="http://schemas.microsoft.com/office/drawing/2014/main" id="{00B56F22-23B9-4ABA-8773-82EDC0B23B9A}"/>
               </a:ext>
             </a:extLst>
           </p:cNvPr>
@@ -30733,7 +30733,7 @@
           <p:cNvPr id="6" name="Personal/global Skills도 실행됨 · AGENTS.md만의 독립적인 효과로 해석하지 않음">
             <a:extLst xmlns:a="http://schemas.openxmlformats.org/drawingml/2006/main">
               <a:ext uri="{FF2B5EF4-FFF2-40B4-BE49-F238E27FC236}">
-                <a16:creationId xmlns:a16="http://schemas.microsoft.com/office/drawing/2014/main" id="{CC7D92F6-E4D2-44A1-9F82-5C2539862A7F}"/>
+                <a16:creationId xmlns:a16="http://schemas.microsoft.com/office/drawing/2014/main" id="{9424DE84-B0F3-4758-A475-55051A9B6BE2}"/>
               </a:ext>
             </a:extLst>
           </p:cNvPr>
@@ -30891,7 +30891,7 @@
           <p:cNvPr id="7" name="요청">
             <a:extLst xmlns:a="http://schemas.openxmlformats.org/drawingml/2006/main">
               <a:ext uri="{FF2B5EF4-FFF2-40B4-BE49-F238E27FC236}">
-                <a16:creationId xmlns:a16="http://schemas.microsoft.com/office/drawing/2014/main" id="{A478A99F-DB61-49B2-A990-5BDD7E93C522}"/>
+                <a16:creationId xmlns:a16="http://schemas.microsoft.com/office/drawing/2014/main" id="{A294877E-36F7-4182-B6D8-91A54D7A73FB}"/>
               </a:ext>
             </a:extLst>
           </p:cNvPr>
@@ -31049,7 +31049,7 @@
           <p:cNvPr id="8" name="">
             <a:extLst xmlns:a="http://schemas.openxmlformats.org/drawingml/2006/main">
               <a:ext uri="{FF2B5EF4-FFF2-40B4-BE49-F238E27FC236}">
-                <a16:creationId xmlns:a16="http://schemas.microsoft.com/office/drawing/2014/main" id="{726EB8DC-F2D0-4BB9-9CA2-61521F363B9C}"/>
+                <a16:creationId xmlns:a16="http://schemas.microsoft.com/office/drawing/2014/main" id="{54FEBC1E-9B3B-4A67-95E3-4CCBE6244B09}"/>
               </a:ext>
             </a:extLst>
           </p:cNvPr>
@@ -31080,7 +31080,7 @@
           <p:cNvPr id="9" name="읽은 파일">
             <a:extLst xmlns:a="http://schemas.openxmlformats.org/drawingml/2006/main">
               <a:ext uri="{FF2B5EF4-FFF2-40B4-BE49-F238E27FC236}">
-                <a16:creationId xmlns:a16="http://schemas.microsoft.com/office/drawing/2014/main" id="{676F8199-ABF1-42EB-89C3-CE7CFB5736D4}"/>
+                <a16:creationId xmlns:a16="http://schemas.microsoft.com/office/drawing/2014/main" id="{3C26CDA9-7011-43A5-B320-E8992CD954AF}"/>
               </a:ext>
             </a:extLst>
           </p:cNvPr>
@@ -31238,7 +31238,7 @@
           <p:cNvPr id="10" name="">
             <a:extLst xmlns:a="http://schemas.openxmlformats.org/drawingml/2006/main">
               <a:ext uri="{FF2B5EF4-FFF2-40B4-BE49-F238E27FC236}">
-                <a16:creationId xmlns:a16="http://schemas.microsoft.com/office/drawing/2014/main" id="{1C7FC57F-0BA5-4EB7-B2EB-9BCE237ABA01}"/>
+                <a16:creationId xmlns:a16="http://schemas.microsoft.com/office/drawing/2014/main" id="{DA6F45CE-6C43-49FA-A416-7699EDB92977}"/>
               </a:ext>
             </a:extLst>
           </p:cNvPr>
@@ -31269,7 +31269,7 @@
           <p:cNvPr id="11" name="실행 기록">
             <a:extLst xmlns:a="http://schemas.openxmlformats.org/drawingml/2006/main">
               <a:ext uri="{FF2B5EF4-FFF2-40B4-BE49-F238E27FC236}">
-                <a16:creationId xmlns:a16="http://schemas.microsoft.com/office/drawing/2014/main" id="{1708ABA0-44BE-43C0-9AAF-FF3C6817F6F6}"/>
+                <a16:creationId xmlns:a16="http://schemas.microsoft.com/office/drawing/2014/main" id="{3EBFA5CD-1FA4-443B-9ABE-96A4E8AADF09}"/>
               </a:ext>
             </a:extLst>
           </p:cNvPr>
@@ -31427,7 +31427,7 @@
           <p:cNvPr id="12" name="">
             <a:extLst xmlns:a="http://schemas.openxmlformats.org/drawingml/2006/main">
               <a:ext uri="{FF2B5EF4-FFF2-40B4-BE49-F238E27FC236}">
-                <a16:creationId xmlns:a16="http://schemas.microsoft.com/office/drawing/2014/main" id="{CA09ACAF-6B78-49A6-85D0-A26BFEDD1321}"/>
+                <a16:creationId xmlns:a16="http://schemas.microsoft.com/office/drawing/2014/main" id="{B1BFCAAA-7690-465B-B265-48031FCFE4B9}"/>
               </a:ext>
             </a:extLst>
           </p:cNvPr>
@@ -31458,7 +31458,7 @@
           <p:cNvPr id="13" name="README만 수정&#10;테스트 명령은 없음">
             <a:extLst xmlns:a="http://schemas.openxmlformats.org/drawingml/2006/main">
               <a:ext uri="{FF2B5EF4-FFF2-40B4-BE49-F238E27FC236}">
-                <a16:creationId xmlns:a16="http://schemas.microsoft.com/office/drawing/2014/main" id="{12B29FE3-B576-4305-8692-3682D8DF6753}"/>
+                <a16:creationId xmlns:a16="http://schemas.microsoft.com/office/drawing/2014/main" id="{B8637B59-F576-4B62-993F-434DA4CBB43B}"/>
               </a:ext>
             </a:extLst>
           </p:cNvPr>
@@ -31639,7 +31639,7 @@
           <p:cNvPr id="14" name="AGENTS.md">
             <a:extLst xmlns:a="http://schemas.openxmlformats.org/drawingml/2006/main">
               <a:ext uri="{FF2B5EF4-FFF2-40B4-BE49-F238E27FC236}">
-                <a16:creationId xmlns:a16="http://schemas.microsoft.com/office/drawing/2014/main" id="{4A19CFDC-BDC7-4879-BBE4-FAC8B350DD3C}"/>
+                <a16:creationId xmlns:a16="http://schemas.microsoft.com/office/drawing/2014/main" id="{51CB64AD-CD91-4113-AB0D-B1FA3FA4B14E}"/>
               </a:ext>
             </a:extLst>
           </p:cNvPr>
@@ -31797,7 +31797,7 @@
           <p:cNvPr id="15" name="기록된 테스트&#10;명령을 사용">
             <a:extLst xmlns:a="http://schemas.openxmlformats.org/drawingml/2006/main">
               <a:ext uri="{FF2B5EF4-FFF2-40B4-BE49-F238E27FC236}">
-                <a16:creationId xmlns:a16="http://schemas.microsoft.com/office/drawing/2014/main" id="{E19084F2-0CD5-4D89-88ED-5CBE7ECCFDDA}"/>
+                <a16:creationId xmlns:a16="http://schemas.microsoft.com/office/drawing/2014/main" id="{D3B22B93-559F-4802-B0C0-D88BEFD228F8}"/>
               </a:ext>
             </a:extLst>
           </p:cNvPr>
@@ -31978,7 +31978,7 @@
           <p:cNvPr id="16" name="전체 테스트">
             <a:extLst xmlns:a="http://schemas.openxmlformats.org/drawingml/2006/main">
               <a:ext uri="{FF2B5EF4-FFF2-40B4-BE49-F238E27FC236}">
-                <a16:creationId xmlns:a16="http://schemas.microsoft.com/office/drawing/2014/main" id="{389E83DA-161D-4DE2-8DF9-D230FEED0822}"/>
+                <a16:creationId xmlns:a16="http://schemas.microsoft.com/office/drawing/2014/main" id="{10774065-B4F3-4FE2-9BFD-374120BC576A}"/>
               </a:ext>
             </a:extLst>
           </p:cNvPr>
@@ -32136,7 +32136,7 @@
           <p:cNvPr id="17" name="11 / 11">
             <a:extLst xmlns:a="http://schemas.openxmlformats.org/drawingml/2006/main">
               <a:ext uri="{FF2B5EF4-FFF2-40B4-BE49-F238E27FC236}">
-                <a16:creationId xmlns:a16="http://schemas.microsoft.com/office/drawing/2014/main" id="{F7ECB9CE-103B-4281-8B38-082FABE7D363}"/>
+                <a16:creationId xmlns:a16="http://schemas.microsoft.com/office/drawing/2014/main" id="{FEF88C7E-E5B1-40CE-A21B-2925908A56F8}"/>
               </a:ext>
             </a:extLst>
           </p:cNvPr>
@@ -32294,7 +32294,7 @@
           <p:cNvPr id="18" name="PASS">
             <a:extLst xmlns:a="http://schemas.openxmlformats.org/drawingml/2006/main">
               <a:ext uri="{FF2B5EF4-FFF2-40B4-BE49-F238E27FC236}">
-                <a16:creationId xmlns:a16="http://schemas.microsoft.com/office/drawing/2014/main" id="{92DE243C-4484-43D5-AB88-AAAC14EF2122}"/>
+                <a16:creationId xmlns:a16="http://schemas.microsoft.com/office/drawing/2014/main" id="{0BD00DE5-4A06-4031-823B-A0469D76793D}"/>
               </a:ext>
             </a:extLst>
           </p:cNvPr>
@@ -32452,7 +32452,7 @@
           <p:cNvPr id="19" name="">
             <a:extLst xmlns:a="http://schemas.openxmlformats.org/drawingml/2006/main">
               <a:ext uri="{FF2B5EF4-FFF2-40B4-BE49-F238E27FC236}">
-                <a16:creationId xmlns:a16="http://schemas.microsoft.com/office/drawing/2014/main" id="{81843F9B-6EFE-4291-994B-16B4B6E31FD0}"/>
+                <a16:creationId xmlns:a16="http://schemas.microsoft.com/office/drawing/2014/main" id="{B5589E61-F5CE-4437-B10D-D86D27C30830}"/>
               </a:ext>
             </a:extLst>
           </p:cNvPr>
@@ -32482,7 +32482,7 @@
           <p:cNvPr id="20" name="">
             <a:extLst xmlns:a="http://schemas.openxmlformats.org/drawingml/2006/main">
               <a:ext uri="{FF2B5EF4-FFF2-40B4-BE49-F238E27FC236}">
-                <a16:creationId xmlns:a16="http://schemas.microsoft.com/office/drawing/2014/main" id="{516111BE-A0DA-4F50-9645-0D49011C3A04}"/>
+                <a16:creationId xmlns:a16="http://schemas.microsoft.com/office/drawing/2014/main" id="{350F9F33-1B81-4F4A-80EA-58FD5A2E48E2}"/>
               </a:ext>
             </a:extLst>
           </p:cNvPr>
@@ -32512,7 +32512,7 @@
           <p:cNvPr id="21" name="">
             <a:extLst xmlns:a="http://schemas.openxmlformats.org/drawingml/2006/main">
               <a:ext uri="{FF2B5EF4-FFF2-40B4-BE49-F238E27FC236}">
-                <a16:creationId xmlns:a16="http://schemas.microsoft.com/office/drawing/2014/main" id="{62747271-9CAF-42BC-91ED-0C9BB883A7DF}"/>
+                <a16:creationId xmlns:a16="http://schemas.microsoft.com/office/drawing/2014/main" id="{5F4402A2-2BF9-45CD-B4F8-B28FA04225E9}"/>
               </a:ext>
             </a:extLst>
           </p:cNvPr>
@@ -32543,7 +32543,7 @@
           <p:cNvPr id="22" name="README-only 범위는 작업 요청에도 명시돼 있었다">
             <a:extLst xmlns:a="http://schemas.openxmlformats.org/drawingml/2006/main">
               <a:ext uri="{FF2B5EF4-FFF2-40B4-BE49-F238E27FC236}">
-                <a16:creationId xmlns:a16="http://schemas.microsoft.com/office/drawing/2014/main" id="{57DD5FD7-A2BC-4EB2-95DD-7A65B7EB6BCA}"/>
+                <a16:creationId xmlns:a16="http://schemas.microsoft.com/office/drawing/2014/main" id="{621872E9-978E-4067-BA4C-ECEC54CF9C2B}"/>
               </a:ext>
             </a:extLst>
           </p:cNvPr>
@@ -32701,7 +32701,7 @@
           <p:cNvPr id="23" name="Legacy module connection">
             <a:extLst xmlns:a="http://schemas.openxmlformats.org/drawingml/2006/main">
               <a:ext uri="{FF2B5EF4-FFF2-40B4-BE49-F238E27FC236}">
-                <a16:creationId xmlns:a16="http://schemas.microsoft.com/office/drawing/2014/main" id="{467BFE52-4DC5-42A9-9B96-E36761878EE4}"/>
+                <a16:creationId xmlns:a16="http://schemas.microsoft.com/office/drawing/2014/main" id="{5CB5503D-04B3-417D-BC86-CF0D2102AEF8}"/>
               </a:ext>
             </a:extLst>
           </p:cNvPr>
@@ -32857,7 +32857,7 @@
     </p:spTree>
     <p:extLst>
       <p:ext uri="{BB962C8B-B14F-4D97-AF65-F5344CB8AC3E}">
-        <p14:creationId xmlns:p14="http://schemas.microsoft.com/office/powerpoint/2010/main" val="823408595"/>
+        <p14:creationId xmlns:p14="http://schemas.microsoft.com/office/powerpoint/2010/main" val="944522724"/>
       </p:ext>
     </p:extLst>
   </p:cSld>
@@ -32888,7 +32888,7 @@
           <p:cNvPr id="21" name="ACT 2 · 정보의 범위와 수명">
             <a:extLst xmlns:a="http://schemas.openxmlformats.org/drawingml/2006/main">
               <a:ext uri="{FF2B5EF4-FFF2-40B4-BE49-F238E27FC236}">
-                <a16:creationId xmlns:a16="http://schemas.microsoft.com/office/drawing/2014/main" id="{DDF9F7F7-00C1-40A8-BB4E-33F6448EE06E}"/>
+                <a16:creationId xmlns:a16="http://schemas.microsoft.com/office/drawing/2014/main" id="{370B6AD8-4284-435A-B5F6-C3715655901B}"/>
               </a:ext>
             </a:extLst>
           </p:cNvPr>
@@ -33043,10 +33043,10 @@
       </p:sp>
       <p:sp>
         <p:nvSpPr>
-          <p:cNvPr id="2" name="S27">
+          <p:cNvPr id="2" name="S35">
             <a:extLst xmlns:a="http://schemas.openxmlformats.org/drawingml/2006/main">
               <a:ext uri="{FF2B5EF4-FFF2-40B4-BE49-F238E27FC236}">
-                <a16:creationId xmlns:a16="http://schemas.microsoft.com/office/drawing/2014/main" id="{19882B97-0979-46D7-B684-19A4E67CA75F}"/>
+                <a16:creationId xmlns:a16="http://schemas.microsoft.com/office/drawing/2014/main" id="{1987D40C-1B99-4171-A85B-FFE135B7CEC9}"/>
               </a:ext>
             </a:extLst>
           </p:cNvPr>
@@ -33194,7 +33194,7 @@
                 <a:ea typeface="Malgun Gothic"/>
                 <a:cs typeface="Malgun Gothic"/>
               </a:rPr>
-              <a:t>S27</a:t>
+              <a:t>S35</a:t>
             </a:r>
           </a:p>
         </p:txBody>
@@ -33204,7 +33204,7 @@
           <p:cNvPr id="3" name="Task Prompt와 Project Context">
             <a:extLst xmlns:a="http://schemas.openxmlformats.org/drawingml/2006/main">
               <a:ext uri="{FF2B5EF4-FFF2-40B4-BE49-F238E27FC236}">
-                <a16:creationId xmlns:a16="http://schemas.microsoft.com/office/drawing/2014/main" id="{727B0D5C-D876-4E28-BFBF-E389D57099DA}"/>
+                <a16:creationId xmlns:a16="http://schemas.microsoft.com/office/drawing/2014/main" id="{563A829D-EB0D-4DCA-A5ED-B2A8D621BB25}"/>
               </a:ext>
             </a:extLst>
           </p:cNvPr>
@@ -33362,7 +33362,7 @@
           <p:cNvPr id="4" name="">
             <a:extLst xmlns:a="http://schemas.openxmlformats.org/drawingml/2006/main">
               <a:ext uri="{FF2B5EF4-FFF2-40B4-BE49-F238E27FC236}">
-                <a16:creationId xmlns:a16="http://schemas.microsoft.com/office/drawing/2014/main" id="{A910BFE9-30DA-4029-8872-B904D070F88B}"/>
+                <a16:creationId xmlns:a16="http://schemas.microsoft.com/office/drawing/2014/main" id="{F41FF0BF-A9F4-4F2D-A01D-E4861139894B}"/>
               </a:ext>
             </a:extLst>
           </p:cNvPr>
@@ -33393,7 +33393,7 @@
           <p:cNvPr id="5" name="교육용 구분 · 현재 목표와 지속되는 프로젝트 사실">
             <a:extLst xmlns:a="http://schemas.openxmlformats.org/drawingml/2006/main">
               <a:ext uri="{FF2B5EF4-FFF2-40B4-BE49-F238E27FC236}">
-                <a16:creationId xmlns:a16="http://schemas.microsoft.com/office/drawing/2014/main" id="{5C2A53C1-3793-4D1F-BFA2-7286AA4B3779}"/>
+                <a16:creationId xmlns:a16="http://schemas.microsoft.com/office/drawing/2014/main" id="{52C1E52C-62F2-4F4A-B3DB-937F2216B26B}"/>
               </a:ext>
             </a:extLst>
           </p:cNvPr>
@@ -33551,7 +33551,7 @@
           <p:cNvPr id="6" name="C++에서도 프로젝트 공통 제약과 이번 알고리즘 변경 조건은 범위가 다를 수 있다">
             <a:extLst xmlns:a="http://schemas.openxmlformats.org/drawingml/2006/main">
               <a:ext uri="{FF2B5EF4-FFF2-40B4-BE49-F238E27FC236}">
-                <a16:creationId xmlns:a16="http://schemas.microsoft.com/office/drawing/2014/main" id="{776C1879-6E91-40CB-AE66-0DB0C0EAFFC9}"/>
+                <a16:creationId xmlns:a16="http://schemas.microsoft.com/office/drawing/2014/main" id="{18C55F86-C0CC-4921-98E3-6BA282383794}"/>
               </a:ext>
             </a:extLst>
           </p:cNvPr>
@@ -33709,7 +33709,7 @@
           <p:cNvPr id="7" name="방금 본 기록을 범위와 수명으로 읽어보면">
             <a:extLst xmlns:a="http://schemas.openxmlformats.org/drawingml/2006/main">
               <a:ext uri="{FF2B5EF4-FFF2-40B4-BE49-F238E27FC236}">
-                <a16:creationId xmlns:a16="http://schemas.microsoft.com/office/drawing/2014/main" id="{7CA50D52-8953-414C-996B-1121289FA705}"/>
+                <a16:creationId xmlns:a16="http://schemas.microsoft.com/office/drawing/2014/main" id="{B6E9F95F-D82F-49B6-A492-975C4E65EC7B}"/>
               </a:ext>
             </a:extLst>
           </p:cNvPr>
@@ -33867,7 +33867,7 @@
           <p:cNvPr id="8" name="Task Prompt">
             <a:extLst xmlns:a="http://schemas.openxmlformats.org/drawingml/2006/main">
               <a:ext uri="{FF2B5EF4-FFF2-40B4-BE49-F238E27FC236}">
-                <a16:creationId xmlns:a16="http://schemas.microsoft.com/office/drawing/2014/main" id="{9AF4AA50-EB37-4967-B446-79F938262BA4}"/>
+                <a16:creationId xmlns:a16="http://schemas.microsoft.com/office/drawing/2014/main" id="{8BE4CCF9-48BA-4890-BEC6-E7683D868BC7}"/>
               </a:ext>
             </a:extLst>
           </p:cNvPr>
@@ -34025,7 +34025,7 @@
           <p:cNvPr id="9" name="Project Context">
             <a:extLst xmlns:a="http://schemas.openxmlformats.org/drawingml/2006/main">
               <a:ext uri="{FF2B5EF4-FFF2-40B4-BE49-F238E27FC236}">
-                <a16:creationId xmlns:a16="http://schemas.microsoft.com/office/drawing/2014/main" id="{45FBA96C-4C6B-4378-8D96-49B08F2EC1B0}"/>
+                <a16:creationId xmlns:a16="http://schemas.microsoft.com/office/drawing/2014/main" id="{14CF9B0E-5E24-4470-BA9B-EC05FAA4009E}"/>
               </a:ext>
             </a:extLst>
           </p:cNvPr>
@@ -34183,7 +34183,7 @@
           <p:cNvPr id="10" name="">
             <a:extLst xmlns:a="http://schemas.openxmlformats.org/drawingml/2006/main">
               <a:ext uri="{FF2B5EF4-FFF2-40B4-BE49-F238E27FC236}">
-                <a16:creationId xmlns:a16="http://schemas.microsoft.com/office/drawing/2014/main" id="{20F9ED89-5982-4218-B16B-DB25BB050BE4}"/>
+                <a16:creationId xmlns:a16="http://schemas.microsoft.com/office/drawing/2014/main" id="{AE3C170F-5B7D-4286-904C-7AC2D0C355B2}"/>
               </a:ext>
             </a:extLst>
           </p:cNvPr>
@@ -34214,7 +34214,7 @@
           <p:cNvPr id="11" name="">
             <a:extLst xmlns:a="http://schemas.openxmlformats.org/drawingml/2006/main">
               <a:ext uri="{FF2B5EF4-FFF2-40B4-BE49-F238E27FC236}">
-                <a16:creationId xmlns:a16="http://schemas.microsoft.com/office/drawing/2014/main" id="{23FD16CD-1DDC-4A0F-956F-6C0D7054B1A0}"/>
+                <a16:creationId xmlns:a16="http://schemas.microsoft.com/office/drawing/2014/main" id="{A6CDF00D-3408-4062-8125-83F79117695C}"/>
               </a:ext>
             </a:extLst>
           </p:cNvPr>
@@ -34245,7 +34245,7 @@
           <p:cNvPr id="12" name="지금 원하는 결과">
             <a:extLst xmlns:a="http://schemas.openxmlformats.org/drawingml/2006/main">
               <a:ext uri="{FF2B5EF4-FFF2-40B4-BE49-F238E27FC236}">
-                <a16:creationId xmlns:a16="http://schemas.microsoft.com/office/drawing/2014/main" id="{606F025D-05A1-469E-8C15-3897978DA5D9}"/>
+                <a16:creationId xmlns:a16="http://schemas.microsoft.com/office/drawing/2014/main" id="{EBCDD3D8-3B4C-4B07-8528-028B7AEBFFEB}"/>
               </a:ext>
             </a:extLst>
           </p:cNvPr>
@@ -34403,7 +34403,7 @@
           <p:cNvPr id="13" name="계속 참이어야 할 사실">
             <a:extLst xmlns:a="http://schemas.openxmlformats.org/drawingml/2006/main">
               <a:ext uri="{FF2B5EF4-FFF2-40B4-BE49-F238E27FC236}">
-                <a16:creationId xmlns:a16="http://schemas.microsoft.com/office/drawing/2014/main" id="{0CDB6F0B-F99A-477D-9F1B-87F43B5C55A6}"/>
+                <a16:creationId xmlns:a16="http://schemas.microsoft.com/office/drawing/2014/main" id="{06C88E4F-212B-4ABA-A683-73EF6958A223}"/>
               </a:ext>
             </a:extLst>
           </p:cNvPr>
@@ -34561,7 +34561,7 @@
           <p:cNvPr id="14" name="crop 경계 버그 수정&#10;이번에는 README만 변경">
             <a:extLst xmlns:a="http://schemas.openxmlformats.org/drawingml/2006/main">
               <a:ext uri="{FF2B5EF4-FFF2-40B4-BE49-F238E27FC236}">
-                <a16:creationId xmlns:a16="http://schemas.microsoft.com/office/drawing/2014/main" id="{D71A95B9-A257-44C1-BAFA-55101ADD0D21}"/>
+                <a16:creationId xmlns:a16="http://schemas.microsoft.com/office/drawing/2014/main" id="{FF25CD2C-F479-4546-BB83-649BC88E31B5}"/>
               </a:ext>
             </a:extLst>
           </p:cNvPr>
@@ -34742,7 +34742,7 @@
           <p:cNvPr id="15" name="프로젝트의 테스트 명령&#10;의존성 추가에는 작업상 근거 필요">
             <a:extLst xmlns:a="http://schemas.openxmlformats.org/drawingml/2006/main">
               <a:ext uri="{FF2B5EF4-FFF2-40B4-BE49-F238E27FC236}">
-                <a16:creationId xmlns:a16="http://schemas.microsoft.com/office/drawing/2014/main" id="{2B3E1366-1C2E-49E9-B9B2-0A3E3DDA94C9}"/>
+                <a16:creationId xmlns:a16="http://schemas.microsoft.com/office/drawing/2014/main" id="{5A7AB845-4151-4B07-9F8F-F427F7F9472B}"/>
               </a:ext>
             </a:extLst>
           </p:cNvPr>
@@ -34923,7 +34923,7 @@
           <p:cNvPr id="16" name="">
             <a:extLst xmlns:a="http://schemas.openxmlformats.org/drawingml/2006/main">
               <a:ext uri="{FF2B5EF4-FFF2-40B4-BE49-F238E27FC236}">
-                <a16:creationId xmlns:a16="http://schemas.microsoft.com/office/drawing/2014/main" id="{E32E3AEF-BF2E-4F2B-90AC-135E420E51C9}"/>
+                <a16:creationId xmlns:a16="http://schemas.microsoft.com/office/drawing/2014/main" id="{FD4A8570-3FC8-4941-A410-BA558CAA0CEE}"/>
               </a:ext>
             </a:extLst>
           </p:cNvPr>
@@ -34956,7 +34956,7 @@
           <p:cNvPr id="17" name="">
             <a:extLst xmlns:a="http://schemas.openxmlformats.org/drawingml/2006/main">
               <a:ext uri="{FF2B5EF4-FFF2-40B4-BE49-F238E27FC236}">
-                <a16:creationId xmlns:a16="http://schemas.microsoft.com/office/drawing/2014/main" id="{9753085C-ECC0-4F65-9506-F5679E04C4FC}"/>
+                <a16:creationId xmlns:a16="http://schemas.microsoft.com/office/drawing/2014/main" id="{6F44B0CF-D6DC-4F49-AF49-3A7FF92FC9EF}"/>
               </a:ext>
             </a:extLst>
           </p:cNvPr>
@@ -34987,7 +34987,7 @@
           <p:cNvPr id="18" name="다음 작업에서는 목표가 달라짐">
             <a:extLst xmlns:a="http://schemas.openxmlformats.org/drawingml/2006/main">
               <a:ext uri="{FF2B5EF4-FFF2-40B4-BE49-F238E27FC236}">
-                <a16:creationId xmlns:a16="http://schemas.microsoft.com/office/drawing/2014/main" id="{6827BB06-FBD1-404F-B25C-9F846236C680}"/>
+                <a16:creationId xmlns:a16="http://schemas.microsoft.com/office/drawing/2014/main" id="{761C29BC-F507-41BF-BAD1-860DB126DC51}"/>
               </a:ext>
             </a:extLst>
           </p:cNvPr>
@@ -35145,7 +35145,7 @@
           <p:cNvPr id="19" name="여러 작업에서 다시 참고">
             <a:extLst xmlns:a="http://schemas.openxmlformats.org/drawingml/2006/main">
               <a:ext uri="{FF2B5EF4-FFF2-40B4-BE49-F238E27FC236}">
-                <a16:creationId xmlns:a16="http://schemas.microsoft.com/office/drawing/2014/main" id="{B035E686-B62F-4F3C-B393-9C315FEC5E84}"/>
+                <a16:creationId xmlns:a16="http://schemas.microsoft.com/office/drawing/2014/main" id="{CE672148-7298-41C9-BFC6-02810DBB3A4A}"/>
               </a:ext>
             </a:extLst>
           </p:cNvPr>
@@ -35303,7 +35303,7 @@
           <p:cNvPr id="20" name="Legacy module connection">
             <a:extLst xmlns:a="http://schemas.openxmlformats.org/drawingml/2006/main">
               <a:ext uri="{FF2B5EF4-FFF2-40B4-BE49-F238E27FC236}">
-                <a16:creationId xmlns:a16="http://schemas.microsoft.com/office/drawing/2014/main" id="{621893FA-6A02-46FF-969B-6BEC2B97EEB7}"/>
+                <a16:creationId xmlns:a16="http://schemas.microsoft.com/office/drawing/2014/main" id="{11E4B9DE-2B5E-48EE-B2B6-E2F2734B59B2}"/>
               </a:ext>
             </a:extLst>
           </p:cNvPr>
@@ -35459,7 +35459,7 @@
     </p:spTree>
     <p:extLst>
       <p:ext uri="{BB962C8B-B14F-4D97-AF65-F5344CB8AC3E}">
-        <p14:creationId xmlns:p14="http://schemas.microsoft.com/office/powerpoint/2010/main" val="1480938011"/>
+        <p14:creationId xmlns:p14="http://schemas.microsoft.com/office/powerpoint/2010/main" val="403419196"/>
       </p:ext>
     </p:extLst>
   </p:cSld>
@@ -35490,7 +35490,7 @@
           <p:cNvPr id="27" name="ACT 2 · Context가 쌓이는 과정">
             <a:extLst xmlns:a="http://schemas.openxmlformats.org/drawingml/2006/main">
               <a:ext uri="{FF2B5EF4-FFF2-40B4-BE49-F238E27FC236}">
-                <a16:creationId xmlns:a16="http://schemas.microsoft.com/office/drawing/2014/main" id="{751E7FFA-F00F-41B4-8923-F8DBBE9F1EDE}"/>
+                <a16:creationId xmlns:a16="http://schemas.microsoft.com/office/drawing/2014/main" id="{9797694B-8A08-40AE-849E-396528ECF71A}"/>
               </a:ext>
             </a:extLst>
           </p:cNvPr>
@@ -35645,10 +35645,10 @@
       </p:sp>
       <p:sp>
         <p:nvSpPr>
-          <p:cNvPr id="2" name="S28">
+          <p:cNvPr id="2" name="S36">
             <a:extLst xmlns:a="http://schemas.openxmlformats.org/drawingml/2006/main">
               <a:ext uri="{FF2B5EF4-FFF2-40B4-BE49-F238E27FC236}">
-                <a16:creationId xmlns:a16="http://schemas.microsoft.com/office/drawing/2014/main" id="{267A8194-166F-44B6-9441-F3CB79FE94B0}"/>
+                <a16:creationId xmlns:a16="http://schemas.microsoft.com/office/drawing/2014/main" id="{8FCF5E9A-7AA8-4901-B0FB-D67195BA8282}"/>
               </a:ext>
             </a:extLst>
           </p:cNvPr>
@@ -35796,7 +35796,7 @@
                 <a:ea typeface="Malgun Gothic"/>
                 <a:cs typeface="Malgun Gothic"/>
               </a:rPr>
-              <a:t>S28</a:t>
+              <a:t>S36</a:t>
             </a:r>
           </a:p>
         </p:txBody>
@@ -35806,7 +35806,7 @@
           <p:cNvPr id="3" name="정확한 정보도 계속 늘어난다">
             <a:extLst xmlns:a="http://schemas.openxmlformats.org/drawingml/2006/main">
               <a:ext uri="{FF2B5EF4-FFF2-40B4-BE49-F238E27FC236}">
-                <a16:creationId xmlns:a16="http://schemas.microsoft.com/office/drawing/2014/main" id="{2884C122-122D-4EF5-A896-E7A8C06097C9}"/>
+                <a16:creationId xmlns:a16="http://schemas.microsoft.com/office/drawing/2014/main" id="{10B4D636-6D0C-42A0-B489-DB271BA32441}"/>
               </a:ext>
             </a:extLst>
           </p:cNvPr>
@@ -35964,7 +35964,7 @@
           <p:cNvPr id="4" name="">
             <a:extLst xmlns:a="http://schemas.openxmlformats.org/drawingml/2006/main">
               <a:ext uri="{FF2B5EF4-FFF2-40B4-BE49-F238E27FC236}">
-                <a16:creationId xmlns:a16="http://schemas.microsoft.com/office/drawing/2014/main" id="{4F5B0CC4-133F-4BE4-A31E-C3570805110D}"/>
+                <a16:creationId xmlns:a16="http://schemas.microsoft.com/office/drawing/2014/main" id="{2AFDF035-0CF5-4F6F-BF52-3495CB9CE764}"/>
               </a:ext>
             </a:extLst>
           </p:cNvPr>
@@ -35995,7 +35995,7 @@
           <p:cNvPr id="5" name="STATE-01 → STATE-02 · 실제 AGENTS.md 상태 비교">
             <a:extLst xmlns:a="http://schemas.openxmlformats.org/drawingml/2006/main">
               <a:ext uri="{FF2B5EF4-FFF2-40B4-BE49-F238E27FC236}">
-                <a16:creationId xmlns:a16="http://schemas.microsoft.com/office/drawing/2014/main" id="{40FB8DC8-327A-4A7B-AE7E-60B14FD757A2}"/>
+                <a16:creationId xmlns:a16="http://schemas.microsoft.com/office/drawing/2014/main" id="{C0A0EF01-CF78-4889-8C98-2E8BA4105BBA}"/>
               </a:ext>
             </a:extLst>
           </p:cNvPr>
@@ -36153,7 +36153,7 @@
           <p:cNvPr id="6" name="문서 크기는 상태 식별 정보 · Context 증가가 실패를 일으켰다는 근거는 아님">
             <a:extLst xmlns:a="http://schemas.openxmlformats.org/drawingml/2006/main">
               <a:ext uri="{FF2B5EF4-FFF2-40B4-BE49-F238E27FC236}">
-                <a16:creationId xmlns:a16="http://schemas.microsoft.com/office/drawing/2014/main" id="{A7DFAD1E-8361-4461-91F6-A8E755E6DE16}"/>
+                <a16:creationId xmlns:a16="http://schemas.microsoft.com/office/drawing/2014/main" id="{7A709BFA-76DF-46CB-A45E-B328E114495F}"/>
               </a:ext>
             </a:extLst>
           </p:cNvPr>
@@ -36311,7 +36311,7 @@
           <p:cNvPr id="7" name="STATE-01">
             <a:extLst xmlns:a="http://schemas.openxmlformats.org/drawingml/2006/main">
               <a:ext uri="{FF2B5EF4-FFF2-40B4-BE49-F238E27FC236}">
-                <a16:creationId xmlns:a16="http://schemas.microsoft.com/office/drawing/2014/main" id="{04C525CC-BC9D-4306-9044-1DF71EEF6C7A}"/>
+                <a16:creationId xmlns:a16="http://schemas.microsoft.com/office/drawing/2014/main" id="{19134183-A001-401D-A5B0-F29E08BB27B4}"/>
               </a:ext>
             </a:extLst>
           </p:cNvPr>
@@ -36469,7 +36469,7 @@
           <p:cNvPr id="8" name="목적 · 실행 · 테스트&#10;기본 제약">
             <a:extLst xmlns:a="http://schemas.openxmlformats.org/drawingml/2006/main">
               <a:ext uri="{FF2B5EF4-FFF2-40B4-BE49-F238E27FC236}">
-                <a16:creationId xmlns:a16="http://schemas.microsoft.com/office/drawing/2014/main" id="{5A6E8518-A49F-4457-AACA-76A79DC7E542}"/>
+                <a16:creationId xmlns:a16="http://schemas.microsoft.com/office/drawing/2014/main" id="{F15A2634-B628-42F1-A4D8-EF6414E21406}"/>
               </a:ext>
             </a:extLst>
           </p:cNvPr>
@@ -36650,7 +36650,7 @@
           <p:cNvPr id="9" name="15줄 · 567 bytes">
             <a:extLst xmlns:a="http://schemas.openxmlformats.org/drawingml/2006/main">
               <a:ext uri="{FF2B5EF4-FFF2-40B4-BE49-F238E27FC236}">
-                <a16:creationId xmlns:a16="http://schemas.microsoft.com/office/drawing/2014/main" id="{E739AD71-6302-4D72-8FFD-8BBAEAD314FB}"/>
+                <a16:creationId xmlns:a16="http://schemas.microsoft.com/office/drawing/2014/main" id="{5796BAC6-0B43-44EA-BD3B-E2DB50B4A12E}"/>
               </a:ext>
             </a:extLst>
           </p:cNvPr>
@@ -36808,7 +36808,7 @@
           <p:cNvPr id="10" name="">
             <a:extLst xmlns:a="http://schemas.openxmlformats.org/drawingml/2006/main">
               <a:ext uri="{FF2B5EF4-FFF2-40B4-BE49-F238E27FC236}">
-                <a16:creationId xmlns:a16="http://schemas.microsoft.com/office/drawing/2014/main" id="{154C7B35-EC9D-487A-9978-CB82612D9D50}"/>
+                <a16:creationId xmlns:a16="http://schemas.microsoft.com/office/drawing/2014/main" id="{D9F50817-64C3-492C-9FC1-E747221579BB}"/>
               </a:ext>
             </a:extLst>
           </p:cNvPr>
@@ -36838,7 +36838,7 @@
           <p:cNvPr id="11" name="STATE-02에 추가된 실제 정보">
             <a:extLst xmlns:a="http://schemas.openxmlformats.org/drawingml/2006/main">
               <a:ext uri="{FF2B5EF4-FFF2-40B4-BE49-F238E27FC236}">
-                <a16:creationId xmlns:a16="http://schemas.microsoft.com/office/drawing/2014/main" id="{56E77DB3-C74B-4432-992A-752B4C7799DB}"/>
+                <a16:creationId xmlns:a16="http://schemas.microsoft.com/office/drawing/2014/main" id="{B634FDF9-DB55-467A-8EED-8A95733097E4}"/>
               </a:ext>
             </a:extLst>
           </p:cNvPr>
@@ -36996,7 +36996,7 @@
           <p:cNvPr id="12" name="">
             <a:extLst xmlns:a="http://schemas.openxmlformats.org/drawingml/2006/main">
               <a:ext uri="{FF2B5EF4-FFF2-40B4-BE49-F238E27FC236}">
-                <a16:creationId xmlns:a16="http://schemas.microsoft.com/office/drawing/2014/main" id="{9E467596-A136-4460-8441-C62C5EF5BF27}"/>
+                <a16:creationId xmlns:a16="http://schemas.microsoft.com/office/drawing/2014/main" id="{ADD5C464-950D-4644-B31F-F49F7F0AF713}"/>
               </a:ext>
             </a:extLst>
           </p:cNvPr>
@@ -37027,7 +37027,7 @@
           <p:cNvPr id="13" name="처리 순서">
             <a:extLst xmlns:a="http://schemas.openxmlformats.org/drawingml/2006/main">
               <a:ext uri="{FF2B5EF4-FFF2-40B4-BE49-F238E27FC236}">
-                <a16:creationId xmlns:a16="http://schemas.microsoft.com/office/drawing/2014/main" id="{19BDFD19-B872-4069-9455-79A2383BB779}"/>
+                <a16:creationId xmlns:a16="http://schemas.microsoft.com/office/drawing/2014/main" id="{C061B364-8F27-49ED-8CF4-E67B6614DFE9}"/>
               </a:ext>
             </a:extLst>
           </p:cNvPr>
@@ -37185,7 +37185,7 @@
           <p:cNvPr id="14" name="load → normalize → … → write">
             <a:extLst xmlns:a="http://schemas.openxmlformats.org/drawingml/2006/main">
               <a:ext uri="{FF2B5EF4-FFF2-40B4-BE49-F238E27FC236}">
-                <a16:creationId xmlns:a16="http://schemas.microsoft.com/office/drawing/2014/main" id="{FB99D8FC-F51F-481F-866E-9E2308C0080A}"/>
+                <a16:creationId xmlns:a16="http://schemas.microsoft.com/office/drawing/2014/main" id="{F296361A-65C0-40F1-A3A3-13271DD32B38}"/>
               </a:ext>
             </a:extLst>
           </p:cNvPr>
@@ -37343,7 +37343,7 @@
           <p:cNvPr id="15" name="">
             <a:extLst xmlns:a="http://schemas.openxmlformats.org/drawingml/2006/main">
               <a:ext uri="{FF2B5EF4-FFF2-40B4-BE49-F238E27FC236}">
-                <a16:creationId xmlns:a16="http://schemas.microsoft.com/office/drawing/2014/main" id="{8A12D990-09B6-4947-93E1-2C8CECF279A6}"/>
+                <a16:creationId xmlns:a16="http://schemas.microsoft.com/office/drawing/2014/main" id="{F9F8C748-4796-4159-8D4A-49D3293270F1}"/>
               </a:ext>
             </a:extLst>
           </p:cNvPr>
@@ -37374,7 +37374,7 @@
           <p:cNvPr id="16" name="이미지 계약">
             <a:extLst xmlns:a="http://schemas.openxmlformats.org/drawingml/2006/main">
               <a:ext uri="{FF2B5EF4-FFF2-40B4-BE49-F238E27FC236}">
-                <a16:creationId xmlns:a16="http://schemas.microsoft.com/office/drawing/2014/main" id="{F938C6A1-EFE1-4BC8-9D43-AFC7322B693F}"/>
+                <a16:creationId xmlns:a16="http://schemas.microsoft.com/office/drawing/2014/main" id="{EC9D0D28-E0D9-4AAA-B8CC-90F64510C268}"/>
               </a:ext>
             </a:extLst>
           </p:cNvPr>
@@ -37532,7 +37532,7 @@
           <p:cNvPr id="17" name="crop: [x_start, x_end)">
             <a:extLst xmlns:a="http://schemas.openxmlformats.org/drawingml/2006/main">
               <a:ext uri="{FF2B5EF4-FFF2-40B4-BE49-F238E27FC236}">
-                <a16:creationId xmlns:a16="http://schemas.microsoft.com/office/drawing/2014/main" id="{C54741AD-F773-48FB-9F5F-ECF666BF6B68}"/>
+                <a16:creationId xmlns:a16="http://schemas.microsoft.com/office/drawing/2014/main" id="{A0DEF1BF-089E-4D51-BA47-DD1CECE2D53F}"/>
               </a:ext>
             </a:extLst>
           </p:cNvPr>
@@ -37690,7 +37690,7 @@
           <p:cNvPr id="18" name="">
             <a:extLst xmlns:a="http://schemas.openxmlformats.org/drawingml/2006/main">
               <a:ext uri="{FF2B5EF4-FFF2-40B4-BE49-F238E27FC236}">
-                <a16:creationId xmlns:a16="http://schemas.microsoft.com/office/drawing/2014/main" id="{F3321A30-CFE0-4129-8565-EDB515A18F96}"/>
+                <a16:creationId xmlns:a16="http://schemas.microsoft.com/office/drawing/2014/main" id="{98623167-80A1-4DC2-AB94-7F7041F88B50}"/>
               </a:ext>
             </a:extLst>
           </p:cNvPr>
@@ -37721,7 +37721,7 @@
           <p:cNvPr id="19" name="테스트 구조">
             <a:extLst xmlns:a="http://schemas.openxmlformats.org/drawingml/2006/main">
               <a:ext uri="{FF2B5EF4-FFF2-40B4-BE49-F238E27FC236}">
-                <a16:creationId xmlns:a16="http://schemas.microsoft.com/office/drawing/2014/main" id="{63B27F2D-0A87-41C0-AE49-C8ABC9CA5271}"/>
+                <a16:creationId xmlns:a16="http://schemas.microsoft.com/office/drawing/2014/main" id="{989414E1-3703-4B79-A9C8-34A86320E68A}"/>
               </a:ext>
             </a:extLst>
           </p:cNvPr>
@@ -37879,7 +37879,7 @@
           <p:cNvPr id="20" name="tests/test_pipeline.py">
             <a:extLst xmlns:a="http://schemas.openxmlformats.org/drawingml/2006/main">
               <a:ext uri="{FF2B5EF4-FFF2-40B4-BE49-F238E27FC236}">
-                <a16:creationId xmlns:a16="http://schemas.microsoft.com/office/drawing/2014/main" id="{3DCE8FA0-4C58-4DC8-903E-550B6BDCFA39}"/>
+                <a16:creationId xmlns:a16="http://schemas.microsoft.com/office/drawing/2014/main" id="{C9B5D153-CC6D-4693-AFAC-4BE49FD9A1CD}"/>
               </a:ext>
             </a:extLst>
           </p:cNvPr>
@@ -38037,7 +38037,7 @@
           <p:cNvPr id="21" name="">
             <a:extLst xmlns:a="http://schemas.openxmlformats.org/drawingml/2006/main">
               <a:ext uri="{FF2B5EF4-FFF2-40B4-BE49-F238E27FC236}">
-                <a16:creationId xmlns:a16="http://schemas.microsoft.com/office/drawing/2014/main" id="{5544379A-2DF8-4A8A-9720-066C715723F7}"/>
+                <a16:creationId xmlns:a16="http://schemas.microsoft.com/office/drawing/2014/main" id="{0D26240C-AAE1-46D3-BA91-381D6D19226A}"/>
               </a:ext>
             </a:extLst>
           </p:cNvPr>
@@ -38068,7 +38068,7 @@
           <p:cNvPr id="22" name="CLI 출력">
             <a:extLst xmlns:a="http://schemas.openxmlformats.org/drawingml/2006/main">
               <a:ext uri="{FF2B5EF4-FFF2-40B4-BE49-F238E27FC236}">
-                <a16:creationId xmlns:a16="http://schemas.microsoft.com/office/drawing/2014/main" id="{AB282F90-DA8F-4E15-BBD7-51C912B98248}"/>
+                <a16:creationId xmlns:a16="http://schemas.microsoft.com/office/drawing/2014/main" id="{272C7178-A64D-46B2-9DAA-27466912491D}"/>
               </a:ext>
             </a:extLst>
           </p:cNvPr>
@@ -38226,7 +38226,7 @@
           <p:cNvPr id="23" name="width · height · pixel_count …">
             <a:extLst xmlns:a="http://schemas.openxmlformats.org/drawingml/2006/main">
               <a:ext uri="{FF2B5EF4-FFF2-40B4-BE49-F238E27FC236}">
-                <a16:creationId xmlns:a16="http://schemas.microsoft.com/office/drawing/2014/main" id="{40AE1C97-9B1B-4CD6-A530-DB76761AD8CF}"/>
+                <a16:creationId xmlns:a16="http://schemas.microsoft.com/office/drawing/2014/main" id="{613E6E63-64BB-4034-B3DB-52521786B326}"/>
               </a:ext>
             </a:extLst>
           </p:cNvPr>
@@ -38384,7 +38384,7 @@
           <p:cNvPr id="24" name="32줄 · 1,303 bytes">
             <a:extLst xmlns:a="http://schemas.openxmlformats.org/drawingml/2006/main">
               <a:ext uri="{FF2B5EF4-FFF2-40B4-BE49-F238E27FC236}">
-                <a16:creationId xmlns:a16="http://schemas.microsoft.com/office/drawing/2014/main" id="{7A5A97A7-4E8B-41E5-AD9E-E9010A548B67}"/>
+                <a16:creationId xmlns:a16="http://schemas.microsoft.com/office/drawing/2014/main" id="{D438F208-4CBB-4F30-BA17-DAEBDC03ECE8}"/>
               </a:ext>
             </a:extLst>
           </p:cNvPr>
@@ -38542,7 +38542,7 @@
           <p:cNvPr id="25" name="이번 Task에도 필요할까?">
             <a:extLst xmlns:a="http://schemas.openxmlformats.org/drawingml/2006/main">
               <a:ext uri="{FF2B5EF4-FFF2-40B4-BE49-F238E27FC236}">
-                <a16:creationId xmlns:a16="http://schemas.microsoft.com/office/drawing/2014/main" id="{9D0588BF-43DE-416C-85B8-0D3F088F9512}"/>
+                <a16:creationId xmlns:a16="http://schemas.microsoft.com/office/drawing/2014/main" id="{C547E1FF-A929-4575-95EA-E2F55EF32470}"/>
               </a:ext>
             </a:extLst>
           </p:cNvPr>
@@ -38700,7 +38700,7 @@
           <p:cNvPr id="26" name="Legacy module connection">
             <a:extLst xmlns:a="http://schemas.openxmlformats.org/drawingml/2006/main">
               <a:ext uri="{FF2B5EF4-FFF2-40B4-BE49-F238E27FC236}">
-                <a16:creationId xmlns:a16="http://schemas.microsoft.com/office/drawing/2014/main" id="{EACFF834-11D3-4093-B92A-6DD95B36B6BE}"/>
+                <a16:creationId xmlns:a16="http://schemas.microsoft.com/office/drawing/2014/main" id="{50721512-6B70-4529-BC54-C666AFC726E5}"/>
               </a:ext>
             </a:extLst>
           </p:cNvPr>
@@ -38856,7 +38856,7 @@
     </p:spTree>
     <p:extLst>
       <p:ext uri="{BB962C8B-B14F-4D97-AF65-F5344CB8AC3E}">
-        <p14:creationId xmlns:p14="http://schemas.microsoft.com/office/powerpoint/2010/main" val="649155487"/>
+        <p14:creationId xmlns:p14="http://schemas.microsoft.com/office/powerpoint/2010/main" val="533264254"/>
       </p:ext>
     </p:extLst>
   </p:cSld>
@@ -38887,7 +38887,7 @@
           <p:cNvPr id="17" name="ACT 2 · 관련성을 확인하기">
             <a:extLst xmlns:a="http://schemas.openxmlformats.org/drawingml/2006/main">
               <a:ext uri="{FF2B5EF4-FFF2-40B4-BE49-F238E27FC236}">
-                <a16:creationId xmlns:a16="http://schemas.microsoft.com/office/drawing/2014/main" id="{BA60A74B-9FE1-4A38-939C-E234BCA354C8}"/>
+                <a16:creationId xmlns:a16="http://schemas.microsoft.com/office/drawing/2014/main" id="{586BCBB9-F055-49CF-BC2B-7714102BEE6D}"/>
               </a:ext>
             </a:extLst>
           </p:cNvPr>
@@ -39042,10 +39042,10 @@
       </p:sp>
       <p:sp>
         <p:nvSpPr>
-          <p:cNvPr id="2" name="S29">
+          <p:cNvPr id="2" name="S37">
             <a:extLst xmlns:a="http://schemas.openxmlformats.org/drawingml/2006/main">
               <a:ext uri="{FF2B5EF4-FFF2-40B4-BE49-F238E27FC236}">
-                <a16:creationId xmlns:a16="http://schemas.microsoft.com/office/drawing/2014/main" id="{0BEEA1F5-042D-4227-BB9D-536A1A530F5C}"/>
+                <a16:creationId xmlns:a16="http://schemas.microsoft.com/office/drawing/2014/main" id="{D50AB93F-48AA-46EB-A4F6-D7F5E573A08E}"/>
               </a:ext>
             </a:extLst>
           </p:cNvPr>
@@ -39193,7 +39193,7 @@
                 <a:ea typeface="Malgun Gothic"/>
                 <a:cs typeface="Malgun Gothic"/>
               </a:rPr>
-              <a:t>S29</a:t>
+              <a:t>S37</a:t>
             </a:r>
           </a:p>
         </p:txBody>
@@ -39203,7 +39203,7 @@
           <p:cNvPr id="3" name="정확하지만 이번 Task에는 불필요한 정보">
             <a:extLst xmlns:a="http://schemas.openxmlformats.org/drawingml/2006/main">
               <a:ext uri="{FF2B5EF4-FFF2-40B4-BE49-F238E27FC236}">
-                <a16:creationId xmlns:a16="http://schemas.microsoft.com/office/drawing/2014/main" id="{B3647C86-E620-4D7F-998C-73FC8C4DFE27}"/>
+                <a16:creationId xmlns:a16="http://schemas.microsoft.com/office/drawing/2014/main" id="{1BB52CA4-936C-4BF9-A77B-8C416EEFA287}"/>
               </a:ext>
             </a:extLst>
           </p:cNvPr>
@@ -39361,7 +39361,7 @@
           <p:cNvPr id="4" name="">
             <a:extLst xmlns:a="http://schemas.openxmlformats.org/drawingml/2006/main">
               <a:ext uri="{FF2B5EF4-FFF2-40B4-BE49-F238E27FC236}">
-                <a16:creationId xmlns:a16="http://schemas.microsoft.com/office/drawing/2014/main" id="{1F77B39E-F96D-4938-9DF9-71DA7145F63A}"/>
+                <a16:creationId xmlns:a16="http://schemas.microsoft.com/office/drawing/2014/main" id="{CB2A9ADC-91E4-4ADF-94BF-212925164717}"/>
               </a:ext>
             </a:extLst>
           </p:cNvPr>
@@ -39392,7 +39392,7 @@
           <p:cNvPr id="5" name="TRIAL-004 · README의 build tools 안내를 명확히 하는 작업">
             <a:extLst xmlns:a="http://schemas.openxmlformats.org/drawingml/2006/main">
               <a:ext uri="{FF2B5EF4-FFF2-40B4-BE49-F238E27FC236}">
-                <a16:creationId xmlns:a16="http://schemas.microsoft.com/office/drawing/2014/main" id="{004E45D6-947B-4A18-BBFA-6BD3D1AE3FAF}"/>
+                <a16:creationId xmlns:a16="http://schemas.microsoft.com/office/drawing/2014/main" id="{D72D5240-A136-4922-A6FE-CD608A0BE751}"/>
               </a:ext>
             </a:extLst>
           </p:cNvPr>
@@ -39550,7 +39550,7 @@
           <p:cNvPr id="6" name="Agent 혼란과 Context 관련 실패는 관찰되지 않았다">
             <a:extLst xmlns:a="http://schemas.openxmlformats.org/drawingml/2006/main">
               <a:ext uri="{FF2B5EF4-FFF2-40B4-BE49-F238E27FC236}">
-                <a16:creationId xmlns:a16="http://schemas.microsoft.com/office/drawing/2014/main" id="{039AFD3D-9268-421F-896C-7A0792966CAB}"/>
+                <a16:creationId xmlns:a16="http://schemas.microsoft.com/office/drawing/2014/main" id="{340B20E4-BF28-4E1B-8E2A-9E781BD49F60}"/>
               </a:ext>
             </a:extLst>
           </p:cNvPr>
@@ -39708,7 +39708,7 @@
           <p:cNvPr id="7" name="작업: README의 빌드 도구 안내를 고친다">
             <a:extLst xmlns:a="http://schemas.openxmlformats.org/drawingml/2006/main">
               <a:ext uri="{FF2B5EF4-FFF2-40B4-BE49-F238E27FC236}">
-                <a16:creationId xmlns:a16="http://schemas.microsoft.com/office/drawing/2014/main" id="{CB1CEFF0-7C15-4708-A0BE-BD23E1EA8ECD}"/>
+                <a16:creationId xmlns:a16="http://schemas.microsoft.com/office/drawing/2014/main" id="{C9A74AC1-9A0C-46D6-BFEA-A101A9C1E2A5}"/>
               </a:ext>
             </a:extLst>
           </p:cNvPr>
@@ -39866,7 +39866,7 @@
           <p:cNvPr id="8" name="이번 질문과 직접 관련">
             <a:extLst xmlns:a="http://schemas.openxmlformats.org/drawingml/2006/main">
               <a:ext uri="{FF2B5EF4-FFF2-40B4-BE49-F238E27FC236}">
-                <a16:creationId xmlns:a16="http://schemas.microsoft.com/office/drawing/2014/main" id="{AB8BFB26-AAE1-48DD-935D-21CDF7D91D1D}"/>
+                <a16:creationId xmlns:a16="http://schemas.microsoft.com/office/drawing/2014/main" id="{FA9F3C03-67FA-465C-B8BA-9A7EB21B7128}"/>
               </a:ext>
             </a:extLst>
           </p:cNvPr>
@@ -40024,7 +40024,7 @@
           <p:cNvPr id="9" name="함께 있었지만 관련이 낮은 정보">
             <a:extLst xmlns:a="http://schemas.openxmlformats.org/drawingml/2006/main">
               <a:ext uri="{FF2B5EF4-FFF2-40B4-BE49-F238E27FC236}">
-                <a16:creationId xmlns:a16="http://schemas.microsoft.com/office/drawing/2014/main" id="{847AEF8D-694B-432B-B9C9-080468D8654D}"/>
+                <a16:creationId xmlns:a16="http://schemas.microsoft.com/office/drawing/2014/main" id="{88A0C49D-816A-4CDA-B2E6-84A00A8BDF57}"/>
               </a:ext>
             </a:extLst>
           </p:cNvPr>
@@ -40182,7 +40182,7 @@
           <p:cNvPr id="10" name="">
             <a:extLst xmlns:a="http://schemas.openxmlformats.org/drawingml/2006/main">
               <a:ext uri="{FF2B5EF4-FFF2-40B4-BE49-F238E27FC236}">
-                <a16:creationId xmlns:a16="http://schemas.microsoft.com/office/drawing/2014/main" id="{58926CD2-CA53-44C0-8A85-86207A91EA28}"/>
+                <a16:creationId xmlns:a16="http://schemas.microsoft.com/office/drawing/2014/main" id="{2FBB20E5-33FE-4F3D-9FDD-CC88E74B8A1F}"/>
               </a:ext>
             </a:extLst>
           </p:cNvPr>
@@ -40213,7 +40213,7 @@
           <p:cNvPr id="11" name="">
             <a:extLst xmlns:a="http://schemas.openxmlformats.org/drawingml/2006/main">
               <a:ext uri="{FF2B5EF4-FFF2-40B4-BE49-F238E27FC236}">
-                <a16:creationId xmlns:a16="http://schemas.microsoft.com/office/drawing/2014/main" id="{71CC3813-961A-4EAC-94DA-68BFE875A817}"/>
+                <a16:creationId xmlns:a16="http://schemas.microsoft.com/office/drawing/2014/main" id="{DDFAE7F2-22F3-44D9-AA53-B404F860CD88}"/>
               </a:ext>
             </a:extLst>
           </p:cNvPr>
@@ -40244,7 +40244,7 @@
           <p:cNvPr id="12" name="">
             <a:extLst xmlns:a="http://schemas.openxmlformats.org/drawingml/2006/main">
               <a:ext uri="{FF2B5EF4-FFF2-40B4-BE49-F238E27FC236}">
-                <a16:creationId xmlns:a16="http://schemas.microsoft.com/office/drawing/2014/main" id="{D775FF71-D8D3-40E2-A254-5905A63C59D6}"/>
+                <a16:creationId xmlns:a16="http://schemas.microsoft.com/office/drawing/2014/main" id="{AC37F22B-86D0-4C1B-860F-8FD440DCDCD0}"/>
               </a:ext>
             </a:extLst>
           </p:cNvPr>
@@ -40275,7 +40275,7 @@
           <p:cNvPr id="13" name="README&#10;pyproject.toml의 빌드 설정">
             <a:extLst xmlns:a="http://schemas.openxmlformats.org/drawingml/2006/main">
               <a:ext uri="{FF2B5EF4-FFF2-40B4-BE49-F238E27FC236}">
-                <a16:creationId xmlns:a16="http://schemas.microsoft.com/office/drawing/2014/main" id="{9930D8EB-8275-4793-8A13-44EFB3F3FDA6}"/>
+                <a16:creationId xmlns:a16="http://schemas.microsoft.com/office/drawing/2014/main" id="{F3D80731-AFAE-4080-B3CC-7EB6F8118C65}"/>
               </a:ext>
             </a:extLst>
           </p:cNvPr>
@@ -40456,7 +40456,7 @@
           <p:cNvPr id="14" name="crop / resize 계약&#10;이미지 처리 pipeline 세부사항">
             <a:extLst xmlns:a="http://schemas.openxmlformats.org/drawingml/2006/main">
               <a:ext uri="{FF2B5EF4-FFF2-40B4-BE49-F238E27FC236}">
-                <a16:creationId xmlns:a16="http://schemas.microsoft.com/office/drawing/2014/main" id="{9FBEBDAA-4C8E-4114-AEDF-24E720F2F36B}"/>
+                <a16:creationId xmlns:a16="http://schemas.microsoft.com/office/drawing/2014/main" id="{14BF5DCA-001D-41B1-88F6-9D41F786C71E}"/>
               </a:ext>
             </a:extLst>
           </p:cNvPr>
@@ -40637,7 +40637,7 @@
           <p:cNvPr id="15" name="정확한 정보라도, 모든 질문에 필요한 것은 아니다">
             <a:extLst xmlns:a="http://schemas.openxmlformats.org/drawingml/2006/main">
               <a:ext uri="{FF2B5EF4-FFF2-40B4-BE49-F238E27FC236}">
-                <a16:creationId xmlns:a16="http://schemas.microsoft.com/office/drawing/2014/main" id="{FCD20457-5927-4A21-93D9-53A39F48BE76}"/>
+                <a16:creationId xmlns:a16="http://schemas.microsoft.com/office/drawing/2014/main" id="{E25AE782-E782-448A-AD3F-A3CD3F30A18C}"/>
               </a:ext>
             </a:extLst>
           </p:cNvPr>
@@ -40795,7 +40795,7 @@
           <p:cNvPr id="16" name="Legacy module connection">
             <a:extLst xmlns:a="http://schemas.openxmlformats.org/drawingml/2006/main">
               <a:ext uri="{FF2B5EF4-FFF2-40B4-BE49-F238E27FC236}">
-                <a16:creationId xmlns:a16="http://schemas.microsoft.com/office/drawing/2014/main" id="{B41ADE80-D6D0-4628-9B09-6A427469174C}"/>
+                <a16:creationId xmlns:a16="http://schemas.microsoft.com/office/drawing/2014/main" id="{EFC567FE-BACB-4CC4-89F2-BE1877513048}"/>
               </a:ext>
             </a:extLst>
           </p:cNvPr>
@@ -40951,7 +40951,7 @@
     </p:spTree>
     <p:extLst>
       <p:ext uri="{BB962C8B-B14F-4D97-AF65-F5344CB8AC3E}">
-        <p14:creationId xmlns:p14="http://schemas.microsoft.com/office/powerpoint/2010/main" val="1752223276"/>
+        <p14:creationId xmlns:p14="http://schemas.microsoft.com/office/powerpoint/2010/main" val="1863675344"/>
       </p:ext>
     </p:extLst>
   </p:cSld>
@@ -40982,7 +40982,7 @@
           <p:cNvPr id="20" name="ACT 2 · 언제 필요한 정보인가">
             <a:extLst xmlns:a="http://schemas.openxmlformats.org/drawingml/2006/main">
               <a:ext uri="{FF2B5EF4-FFF2-40B4-BE49-F238E27FC236}">
-                <a16:creationId xmlns:a16="http://schemas.microsoft.com/office/drawing/2014/main" id="{C799C139-460B-4845-8E25-10D3BDCC792E}"/>
+                <a16:creationId xmlns:a16="http://schemas.microsoft.com/office/drawing/2014/main" id="{CC9CB057-CEF0-40E2-9715-7584E5071BCE}"/>
               </a:ext>
             </a:extLst>
           </p:cNvPr>
@@ -41137,10 +41137,10 @@
       </p:sp>
       <p:sp>
         <p:nvSpPr>
-          <p:cNvPr id="2" name="S30">
+          <p:cNvPr id="2" name="S38">
             <a:extLst xmlns:a="http://schemas.openxmlformats.org/drawingml/2006/main">
               <a:ext uri="{FF2B5EF4-FFF2-40B4-BE49-F238E27FC236}">
-                <a16:creationId xmlns:a16="http://schemas.microsoft.com/office/drawing/2014/main" id="{5A1CA48B-DBD9-4319-8D2D-EAFA5D147BCF}"/>
+                <a16:creationId xmlns:a16="http://schemas.microsoft.com/office/drawing/2014/main" id="{5EE8507A-D406-402E-B022-AA9323DBB29E}"/>
               </a:ext>
             </a:extLst>
           </p:cNvPr>
@@ -41288,7 +41288,7 @@
                 <a:ea typeface="Malgun Gothic"/>
                 <a:cs typeface="Malgun Gothic"/>
               </a:rPr>
-              <a:t>S30</a:t>
+              <a:t>S38</a:t>
             </a:r>
           </a:p>
         </p:txBody>
@@ -41298,7 +41298,7 @@
           <p:cNvPr id="3" name="정보의 범위와 제공 시점">
             <a:extLst xmlns:a="http://schemas.openxmlformats.org/drawingml/2006/main">
               <a:ext uri="{FF2B5EF4-FFF2-40B4-BE49-F238E27FC236}">
-                <a16:creationId xmlns:a16="http://schemas.microsoft.com/office/drawing/2014/main" id="{8EBEB1EF-6888-42CC-B06C-2A76CF8E9B9A}"/>
+                <a16:creationId xmlns:a16="http://schemas.microsoft.com/office/drawing/2014/main" id="{60C97437-0FF3-46B6-AC63-E0AC3D37171B}"/>
               </a:ext>
             </a:extLst>
           </p:cNvPr>
@@ -41456,7 +41456,7 @@
           <p:cNvPr id="4" name="">
             <a:extLst xmlns:a="http://schemas.openxmlformats.org/drawingml/2006/main">
               <a:ext uri="{FF2B5EF4-FFF2-40B4-BE49-F238E27FC236}">
-                <a16:creationId xmlns:a16="http://schemas.microsoft.com/office/drawing/2014/main" id="{5C224DDE-BEEE-470D-B586-40CF6E192DFF}"/>
+                <a16:creationId xmlns:a16="http://schemas.microsoft.com/office/drawing/2014/main" id="{196900AA-1058-40F4-9727-B8E6E16CBFF2}"/>
               </a:ext>
             </a:extLst>
           </p:cNvPr>
@@ -41487,7 +41487,7 @@
           <p:cNvPr id="5" name="교육용 분류 모델 · OpenAI의 공식 기능 분류가 아님">
             <a:extLst xmlns:a="http://schemas.openxmlformats.org/drawingml/2006/main">
               <a:ext uri="{FF2B5EF4-FFF2-40B4-BE49-F238E27FC236}">
-                <a16:creationId xmlns:a16="http://schemas.microsoft.com/office/drawing/2014/main" id="{376F206B-20A7-42D9-815F-431C9FC4448C}"/>
+                <a16:creationId xmlns:a16="http://schemas.microsoft.com/office/drawing/2014/main" id="{73AC593C-F26C-466A-A744-1E1CA6A37DF4}"/>
               </a:ext>
             </a:extLst>
           </p:cNvPr>
@@ -41645,7 +41645,7 @@
           <p:cNvPr id="6" name="성능 조사 절차는 설명을 위한 예시이며 STATE-02에 저장돼 있었다는 뜻이 아님">
             <a:extLst xmlns:a="http://schemas.openxmlformats.org/drawingml/2006/main">
               <a:ext uri="{FF2B5EF4-FFF2-40B4-BE49-F238E27FC236}">
-                <a16:creationId xmlns:a16="http://schemas.microsoft.com/office/drawing/2014/main" id="{6C4B2FDF-7633-4FB3-84D6-2BC798ADBB59}"/>
+                <a16:creationId xmlns:a16="http://schemas.microsoft.com/office/drawing/2014/main" id="{CE41F7AB-CE23-4561-90AA-18452A64DD8A}"/>
               </a:ext>
             </a:extLst>
           </p:cNvPr>
@@ -41803,7 +41803,7 @@
           <p:cNvPr id="7" name="">
             <a:extLst xmlns:a="http://schemas.openxmlformats.org/drawingml/2006/main">
               <a:ext uri="{FF2B5EF4-FFF2-40B4-BE49-F238E27FC236}">
-                <a16:creationId xmlns:a16="http://schemas.microsoft.com/office/drawing/2014/main" id="{777DC095-7868-41D8-9C56-BD2853063D36}"/>
+                <a16:creationId xmlns:a16="http://schemas.microsoft.com/office/drawing/2014/main" id="{E5031754-656E-4386-96D2-61C697A7D48F}"/>
               </a:ext>
             </a:extLst>
           </p:cNvPr>
@@ -41834,7 +41834,7 @@
           <p:cNvPr id="8" name="항상 알아야 할 안내">
             <a:extLst xmlns:a="http://schemas.openxmlformats.org/drawingml/2006/main">
               <a:ext uri="{FF2B5EF4-FFF2-40B4-BE49-F238E27FC236}">
-                <a16:creationId xmlns:a16="http://schemas.microsoft.com/office/drawing/2014/main" id="{0B112C6C-189E-4AF1-BD90-F0D6A0801B84}"/>
+                <a16:creationId xmlns:a16="http://schemas.microsoft.com/office/drawing/2014/main" id="{D6EF15F9-38A7-43FD-B831-D44EF968BD8A}"/>
               </a:ext>
             </a:extLst>
           </p:cNvPr>
@@ -41992,7 +41992,7 @@
           <p:cNvPr id="9" name="프로젝트 목적 · 기본 제약">
             <a:extLst xmlns:a="http://schemas.openxmlformats.org/drawingml/2006/main">
               <a:ext uri="{FF2B5EF4-FFF2-40B4-BE49-F238E27FC236}">
-                <a16:creationId xmlns:a16="http://schemas.microsoft.com/office/drawing/2014/main" id="{9C92B6E3-71D9-4EA1-B5F9-9DC080ACC39C}"/>
+                <a16:creationId xmlns:a16="http://schemas.microsoft.com/office/drawing/2014/main" id="{D90B6140-55BF-4B8E-B077-12DF744128FD}"/>
               </a:ext>
             </a:extLst>
           </p:cNvPr>
@@ -42150,7 +42150,7 @@
           <p:cNvPr id="10" name="ALWAYS-ON">
             <a:extLst xmlns:a="http://schemas.openxmlformats.org/drawingml/2006/main">
               <a:ext uri="{FF2B5EF4-FFF2-40B4-BE49-F238E27FC236}">
-                <a16:creationId xmlns:a16="http://schemas.microsoft.com/office/drawing/2014/main" id="{0AB0C1B4-55D2-4A23-AEFE-65C7A6417DA4}"/>
+                <a16:creationId xmlns:a16="http://schemas.microsoft.com/office/drawing/2014/main" id="{1E508521-27F5-4CF6-82CE-BAD20D0D2E8A}"/>
               </a:ext>
             </a:extLst>
           </p:cNvPr>
@@ -42308,7 +42308,7 @@
           <p:cNvPr id="11" name="">
             <a:extLst xmlns:a="http://schemas.openxmlformats.org/drawingml/2006/main">
               <a:ext uri="{FF2B5EF4-FFF2-40B4-BE49-F238E27FC236}">
-                <a16:creationId xmlns:a16="http://schemas.microsoft.com/office/drawing/2014/main" id="{47DAB3D7-987F-49C9-A916-3F1032F32160}"/>
+                <a16:creationId xmlns:a16="http://schemas.microsoft.com/office/drawing/2014/main" id="{35506272-891B-4183-B830-DB14CF08672A}"/>
               </a:ext>
             </a:extLst>
           </p:cNvPr>
@@ -42339,7 +42339,7 @@
           <p:cNvPr id="12" name="질문에 따라 찾아볼 상세">
             <a:extLst xmlns:a="http://schemas.openxmlformats.org/drawingml/2006/main">
               <a:ext uri="{FF2B5EF4-FFF2-40B4-BE49-F238E27FC236}">
-                <a16:creationId xmlns:a16="http://schemas.microsoft.com/office/drawing/2014/main" id="{9A5F14DC-1486-4C2C-8717-5E50FE4AB621}"/>
+                <a16:creationId xmlns:a16="http://schemas.microsoft.com/office/drawing/2014/main" id="{D96EDA47-40E2-40F2-83BB-4022E67E86F1}"/>
               </a:ext>
             </a:extLst>
           </p:cNvPr>
@@ -42497,7 +42497,7 @@
           <p:cNvPr id="13" name="crop 계약 · 모듈 구조">
             <a:extLst xmlns:a="http://schemas.openxmlformats.org/drawingml/2006/main">
               <a:ext uri="{FF2B5EF4-FFF2-40B4-BE49-F238E27FC236}">
-                <a16:creationId xmlns:a16="http://schemas.microsoft.com/office/drawing/2014/main" id="{486EC4FF-1DAC-4060-8580-93BD51904518}"/>
+                <a16:creationId xmlns:a16="http://schemas.microsoft.com/office/drawing/2014/main" id="{11B8E7BF-AAD0-484A-8DF3-90AA06795A21}"/>
               </a:ext>
             </a:extLst>
           </p:cNvPr>
@@ -42655,7 +42655,7 @@
           <p:cNvPr id="14" name="ON-DEMAND">
             <a:extLst xmlns:a="http://schemas.openxmlformats.org/drawingml/2006/main">
               <a:ext uri="{FF2B5EF4-FFF2-40B4-BE49-F238E27FC236}">
-                <a16:creationId xmlns:a16="http://schemas.microsoft.com/office/drawing/2014/main" id="{222F3500-9D07-4B50-87B9-D35CF69525F8}"/>
+                <a16:creationId xmlns:a16="http://schemas.microsoft.com/office/drawing/2014/main" id="{115778E6-0DD4-4946-9ADB-73C290BE6289}"/>
               </a:ext>
             </a:extLst>
           </p:cNvPr>
@@ -42813,7 +42813,7 @@
           <p:cNvPr id="15" name="">
             <a:extLst xmlns:a="http://schemas.openxmlformats.org/drawingml/2006/main">
               <a:ext uri="{FF2B5EF4-FFF2-40B4-BE49-F238E27FC236}">
-                <a16:creationId xmlns:a16="http://schemas.microsoft.com/office/drawing/2014/main" id="{5408687C-06DD-479A-BD91-AC15B2B46B2A}"/>
+                <a16:creationId xmlns:a16="http://schemas.microsoft.com/office/drawing/2014/main" id="{B77FA98A-02D2-415C-B8C9-3F657AD83AB0}"/>
               </a:ext>
             </a:extLst>
           </p:cNvPr>
@@ -42844,7 +42844,7 @@
           <p:cNvPr id="16" name="이런 일을 수행하는 방법">
             <a:extLst xmlns:a="http://schemas.openxmlformats.org/drawingml/2006/main">
               <a:ext uri="{FF2B5EF4-FFF2-40B4-BE49-F238E27FC236}">
-                <a16:creationId xmlns:a16="http://schemas.microsoft.com/office/drawing/2014/main" id="{9DE5B00E-3C28-4E47-842D-AB307B0FF00A}"/>
+                <a16:creationId xmlns:a16="http://schemas.microsoft.com/office/drawing/2014/main" id="{C6228961-C7C9-4C85-8AD0-C9C01455059C}"/>
               </a:ext>
             </a:extLst>
           </p:cNvPr>
@@ -43002,7 +43002,7 @@
           <p:cNvPr id="17" name="변경 전 측정 → 조사 → 검증">
             <a:extLst xmlns:a="http://schemas.openxmlformats.org/drawingml/2006/main">
               <a:ext uri="{FF2B5EF4-FFF2-40B4-BE49-F238E27FC236}">
-                <a16:creationId xmlns:a16="http://schemas.microsoft.com/office/drawing/2014/main" id="{18DCA656-CD64-4452-900F-08DF3AFCDB6A}"/>
+                <a16:creationId xmlns:a16="http://schemas.microsoft.com/office/drawing/2014/main" id="{3120F62D-8F30-47CA-9970-DAC14054A5DD}"/>
               </a:ext>
             </a:extLst>
           </p:cNvPr>
@@ -43160,7 +43160,7 @@
           <p:cNvPr id="18" name="WORKFLOW">
             <a:extLst xmlns:a="http://schemas.openxmlformats.org/drawingml/2006/main">
               <a:ext uri="{FF2B5EF4-FFF2-40B4-BE49-F238E27FC236}">
-                <a16:creationId xmlns:a16="http://schemas.microsoft.com/office/drawing/2014/main" id="{CDF5EC49-7E6A-4C99-992E-8DD25E99F412}"/>
+                <a16:creationId xmlns:a16="http://schemas.microsoft.com/office/drawing/2014/main" id="{4C9D711A-3B59-4B48-AACD-2E17908E1E2D}"/>
               </a:ext>
             </a:extLst>
           </p:cNvPr>
@@ -43318,7 +43318,7 @@
           <p:cNvPr id="19" name="Legacy module connection">
             <a:extLst xmlns:a="http://schemas.openxmlformats.org/drawingml/2006/main">
               <a:ext uri="{FF2B5EF4-FFF2-40B4-BE49-F238E27FC236}">
-                <a16:creationId xmlns:a16="http://schemas.microsoft.com/office/drawing/2014/main" id="{7B5B132F-2EE7-420D-8EEB-92FBE5F9A4CE}"/>
+                <a16:creationId xmlns:a16="http://schemas.microsoft.com/office/drawing/2014/main" id="{836A9727-9052-4279-B6A3-2AE29363D032}"/>
               </a:ext>
             </a:extLst>
           </p:cNvPr>
@@ -43474,7 +43474,7 @@
     </p:spTree>
     <p:extLst>
       <p:ext uri="{BB962C8B-B14F-4D97-AF65-F5344CB8AC3E}">
-        <p14:creationId xmlns:p14="http://schemas.microsoft.com/office/powerpoint/2010/main" val="1394434875"/>
+        <p14:creationId xmlns:p14="http://schemas.microsoft.com/office/powerpoint/2010/main" val="1336713854"/>
       </p:ext>
     </p:extLst>
   </p:cSld>
@@ -43505,7 +43505,7 @@
           <p:cNvPr id="38" name="ACT 2 · 정보의 양을 다시 묻는 연구">
             <a:extLst xmlns:a="http://schemas.openxmlformats.org/drawingml/2006/main">
               <a:ext uri="{FF2B5EF4-FFF2-40B4-BE49-F238E27FC236}">
-                <a16:creationId xmlns:a16="http://schemas.microsoft.com/office/drawing/2014/main" id="{425BB323-B1F3-4994-8B43-806E9CF02F57}"/>
+                <a16:creationId xmlns:a16="http://schemas.microsoft.com/office/drawing/2014/main" id="{7C128BB3-5EB7-455E-8DDF-F3FAA44D9740}"/>
               </a:ext>
             </a:extLst>
           </p:cNvPr>
@@ -43660,10 +43660,10 @@
       </p:sp>
       <p:sp>
         <p:nvSpPr>
-          <p:cNvPr id="2" name="S31">
+          <p:cNvPr id="2" name="S39">
             <a:extLst xmlns:a="http://schemas.openxmlformats.org/drawingml/2006/main">
               <a:ext uri="{FF2B5EF4-FFF2-40B4-BE49-F238E27FC236}">
-                <a16:creationId xmlns:a16="http://schemas.microsoft.com/office/drawing/2014/main" id="{7C977493-1307-4323-9284-F7CAF6133F11}"/>
+                <a16:creationId xmlns:a16="http://schemas.microsoft.com/office/drawing/2014/main" id="{E4600FBA-5C28-44FF-9655-F94680B851EB}"/>
               </a:ext>
             </a:extLst>
           </p:cNvPr>
@@ -43811,7 +43811,7 @@
                 <a:ea typeface="Malgun Gothic"/>
                 <a:cs typeface="Malgun Gothic"/>
               </a:rPr>
-              <a:t>S31</a:t>
+              <a:t>S39</a:t>
             </a:r>
           </a:p>
         </p:txBody>
@@ -43821,7 +43821,7 @@
           <p:cNvPr id="3" name="Long Context 연구가 말해주는 범위">
             <a:extLst xmlns:a="http://schemas.openxmlformats.org/drawingml/2006/main">
               <a:ext uri="{FF2B5EF4-FFF2-40B4-BE49-F238E27FC236}">
-                <a16:creationId xmlns:a16="http://schemas.microsoft.com/office/drawing/2014/main" id="{702852F1-E955-4DD5-8B3A-B9A7A58457F2}"/>
+                <a16:creationId xmlns:a16="http://schemas.microsoft.com/office/drawing/2014/main" id="{BE2046A1-7552-439F-90B1-823C365EC61E}"/>
               </a:ext>
             </a:extLst>
           </p:cNvPr>
@@ -43979,7 +43979,7 @@
           <p:cNvPr id="4" name="">
             <a:extLst xmlns:a="http://schemas.openxmlformats.org/drawingml/2006/main">
               <a:ext uri="{FF2B5EF4-FFF2-40B4-BE49-F238E27FC236}">
-                <a16:creationId xmlns:a16="http://schemas.microsoft.com/office/drawing/2014/main" id="{1BCB2ABB-CD44-4D89-9200-BB34DAD3E0C9}"/>
+                <a16:creationId xmlns:a16="http://schemas.microsoft.com/office/drawing/2014/main" id="{504416E8-75E8-4B18-A9BB-BE25EC1BF28D}"/>
               </a:ext>
             </a:extLst>
           </p:cNvPr>
@@ -44010,7 +44010,7 @@
           <p:cNvPr id="5" name="Liu et al., Lost in the Middle, TACL 2024 · RepoQA, 2024">
             <a:extLst xmlns:a="http://schemas.openxmlformats.org/drawingml/2006/main">
               <a:ext uri="{FF2B5EF4-FFF2-40B4-BE49-F238E27FC236}">
-                <a16:creationId xmlns:a16="http://schemas.microsoft.com/office/drawing/2014/main" id="{9E95174A-A7DD-4826-89F8-F44D90B8EB0D}"/>
+                <a16:creationId xmlns:a16="http://schemas.microsoft.com/office/drawing/2014/main" id="{E0EAD1A3-7307-4BBD-8F55-344EC2AE1966}"/>
               </a:ext>
             </a:extLst>
           </p:cNvPr>
@@ -44168,7 +44168,7 @@
           <p:cNvPr id="6" name="특정 모델·과제의 결과 · 현재 Codex의 Repository coding 한계를 입증하지 않음">
             <a:extLst xmlns:a="http://schemas.openxmlformats.org/drawingml/2006/main">
               <a:ext uri="{FF2B5EF4-FFF2-40B4-BE49-F238E27FC236}">
-                <a16:creationId xmlns:a16="http://schemas.microsoft.com/office/drawing/2014/main" id="{66389AF9-4D63-4C6D-AA2B-A732FBBB23DE}"/>
+                <a16:creationId xmlns:a16="http://schemas.microsoft.com/office/drawing/2014/main" id="{38E2D5C3-663E-472A-90BD-399D7D37FCE4}"/>
               </a:ext>
             </a:extLst>
           </p:cNvPr>
@@ -44326,7 +44326,7 @@
           <p:cNvPr id="7" name="더 많은 Context가 항상 더 좋은 것은 아니다">
             <a:extLst xmlns:a="http://schemas.openxmlformats.org/drawingml/2006/main">
               <a:ext uri="{FF2B5EF4-FFF2-40B4-BE49-F238E27FC236}">
-                <a16:creationId xmlns:a16="http://schemas.microsoft.com/office/drawing/2014/main" id="{5E898CA4-C755-45A1-B81A-FF0CC58CD7F9}"/>
+                <a16:creationId xmlns:a16="http://schemas.microsoft.com/office/drawing/2014/main" id="{136D2CBD-F13C-42E2-B01F-504A53D39EBC}"/>
               </a:ext>
             </a:extLst>
           </p:cNvPr>
@@ -44484,7 +44484,7 @@
           <p:cNvPr id="8" name="Lost in the Middle">
             <a:extLst xmlns:a="http://schemas.openxmlformats.org/drawingml/2006/main">
               <a:ext uri="{FF2B5EF4-FFF2-40B4-BE49-F238E27FC236}">
-                <a16:creationId xmlns:a16="http://schemas.microsoft.com/office/drawing/2014/main" id="{387E86CD-5BE3-4B72-A847-04396F23CDE2}"/>
+                <a16:creationId xmlns:a16="http://schemas.microsoft.com/office/drawing/2014/main" id="{0CE07E84-494E-4903-82EC-2A0B72496CF8}"/>
               </a:ext>
             </a:extLst>
           </p:cNvPr>
@@ -44642,7 +44642,7 @@
           <p:cNvPr id="9" name="RepoQA">
             <a:extLst xmlns:a="http://schemas.openxmlformats.org/drawingml/2006/main">
               <a:ext uri="{FF2B5EF4-FFF2-40B4-BE49-F238E27FC236}">
-                <a16:creationId xmlns:a16="http://schemas.microsoft.com/office/drawing/2014/main" id="{D94CA73A-1F37-4CDF-90AA-1DCB10B13A69}"/>
+                <a16:creationId xmlns:a16="http://schemas.microsoft.com/office/drawing/2014/main" id="{07F26D39-948A-4BE4-9C94-10BE87625C06}"/>
               </a:ext>
             </a:extLst>
           </p:cNvPr>
@@ -44800,7 +44800,7 @@
           <p:cNvPr id="10" name="여러 문서의 질문 답변 · key-value 검색">
             <a:extLst xmlns:a="http://schemas.openxmlformats.org/drawingml/2006/main">
               <a:ext uri="{FF2B5EF4-FFF2-40B4-BE49-F238E27FC236}">
-                <a16:creationId xmlns:a16="http://schemas.microsoft.com/office/drawing/2014/main" id="{4B875860-D597-419A-9B03-75CC7ABE6337}"/>
+                <a16:creationId xmlns:a16="http://schemas.microsoft.com/office/drawing/2014/main" id="{7FFA4F4D-BD00-4E67-922A-43B6E6B68FE0}"/>
               </a:ext>
             </a:extLst>
           </p:cNvPr>
@@ -44958,7 +44958,7 @@
           <p:cNvPr id="11" name="50개 Repository의 코드 검색 과제">
             <a:extLst xmlns:a="http://schemas.openxmlformats.org/drawingml/2006/main">
               <a:ext uri="{FF2B5EF4-FFF2-40B4-BE49-F238E27FC236}">
-                <a16:creationId xmlns:a16="http://schemas.microsoft.com/office/drawing/2014/main" id="{D041D59E-19F1-4166-A0E8-8A6755B3F660}"/>
+                <a16:creationId xmlns:a16="http://schemas.microsoft.com/office/drawing/2014/main" id="{D5BEC1CD-220E-49B3-9A7D-BF72726647EF}"/>
               </a:ext>
             </a:extLst>
           </p:cNvPr>
@@ -45116,7 +45116,7 @@
           <p:cNvPr id="12" name="관련 정보의 위치를 달리하는 구성">
             <a:extLst xmlns:a="http://schemas.openxmlformats.org/drawingml/2006/main">
               <a:ext uri="{FF2B5EF4-FFF2-40B4-BE49-F238E27FC236}">
-                <a16:creationId xmlns:a16="http://schemas.microsoft.com/office/drawing/2014/main" id="{8557B346-DE4A-47A1-AB33-1E33AA572435}"/>
+                <a16:creationId xmlns:a16="http://schemas.microsoft.com/office/drawing/2014/main" id="{2035B199-3492-416D-90EE-DE5351BCC144}"/>
               </a:ext>
             </a:extLst>
           </p:cNvPr>
@@ -45274,7 +45274,7 @@
           <p:cNvPr id="13" name="">
             <a:extLst xmlns:a="http://schemas.openxmlformats.org/drawingml/2006/main">
               <a:ext uri="{FF2B5EF4-FFF2-40B4-BE49-F238E27FC236}">
-                <a16:creationId xmlns:a16="http://schemas.microsoft.com/office/drawing/2014/main" id="{65E2A3C9-505F-4ACE-B507-E94908B451F4}"/>
+                <a16:creationId xmlns:a16="http://schemas.microsoft.com/office/drawing/2014/main" id="{3241FD08-2262-4CF4-8AC5-AE347387AE37}"/>
               </a:ext>
             </a:extLst>
           </p:cNvPr>
@@ -45307,7 +45307,7 @@
           <p:cNvPr id="14" name="">
             <a:extLst xmlns:a="http://schemas.openxmlformats.org/drawingml/2006/main">
               <a:ext uri="{FF2B5EF4-FFF2-40B4-BE49-F238E27FC236}">
-                <a16:creationId xmlns:a16="http://schemas.microsoft.com/office/drawing/2014/main" id="{DE8E9A65-5F93-46D0-B973-6C82FA44CFBF}"/>
+                <a16:creationId xmlns:a16="http://schemas.microsoft.com/office/drawing/2014/main" id="{0451B282-54E1-40DE-B2F1-686D59124B75}"/>
               </a:ext>
             </a:extLst>
           </p:cNvPr>
@@ -45340,7 +45340,7 @@
           <p:cNvPr id="15" name="">
             <a:extLst xmlns:a="http://schemas.openxmlformats.org/drawingml/2006/main">
               <a:ext uri="{FF2B5EF4-FFF2-40B4-BE49-F238E27FC236}">
-                <a16:creationId xmlns:a16="http://schemas.microsoft.com/office/drawing/2014/main" id="{E190351D-17F5-401F-AE3E-7E5D8D8B091F}"/>
+                <a16:creationId xmlns:a16="http://schemas.microsoft.com/office/drawing/2014/main" id="{70A67FC4-AB6E-4510-A3A0-6AA8E4D51493}"/>
               </a:ext>
             </a:extLst>
           </p:cNvPr>
@@ -45373,7 +45373,7 @@
           <p:cNvPr id="16" name="">
             <a:extLst xmlns:a="http://schemas.openxmlformats.org/drawingml/2006/main">
               <a:ext uri="{FF2B5EF4-FFF2-40B4-BE49-F238E27FC236}">
-                <a16:creationId xmlns:a16="http://schemas.microsoft.com/office/drawing/2014/main" id="{6FF0F157-E65F-4C4D-BAED-9B94A768A669}"/>
+                <a16:creationId xmlns:a16="http://schemas.microsoft.com/office/drawing/2014/main" id="{1D4FB2D3-BD2B-47DF-AAB6-8ABF56DCBF38}"/>
               </a:ext>
             </a:extLst>
           </p:cNvPr>
@@ -45406,7 +45406,7 @@
           <p:cNvPr id="17" name="">
             <a:extLst xmlns:a="http://schemas.openxmlformats.org/drawingml/2006/main">
               <a:ext uri="{FF2B5EF4-FFF2-40B4-BE49-F238E27FC236}">
-                <a16:creationId xmlns:a16="http://schemas.microsoft.com/office/drawing/2014/main" id="{0CC127F3-6185-4FDE-9192-6DAF888C85CE}"/>
+                <a16:creationId xmlns:a16="http://schemas.microsoft.com/office/drawing/2014/main" id="{10BCB6D7-632E-436B-83F0-A6E14C2CB91C}"/>
               </a:ext>
             </a:extLst>
           </p:cNvPr>
@@ -45439,7 +45439,7 @@
           <p:cNvPr id="18" name="">
             <a:extLst xmlns:a="http://schemas.openxmlformats.org/drawingml/2006/main">
               <a:ext uri="{FF2B5EF4-FFF2-40B4-BE49-F238E27FC236}">
-                <a16:creationId xmlns:a16="http://schemas.microsoft.com/office/drawing/2014/main" id="{2C23A8A1-BE2C-406C-B6CF-5B2E2B9407E2}"/>
+                <a16:creationId xmlns:a16="http://schemas.microsoft.com/office/drawing/2014/main" id="{5D514FDD-B78B-4960-903B-0A3A5F961C72}"/>
               </a:ext>
             </a:extLst>
           </p:cNvPr>
@@ -45472,7 +45472,7 @@
           <p:cNvPr id="19" name="">
             <a:extLst xmlns:a="http://schemas.openxmlformats.org/drawingml/2006/main">
               <a:ext uri="{FF2B5EF4-FFF2-40B4-BE49-F238E27FC236}">
-                <a16:creationId xmlns:a16="http://schemas.microsoft.com/office/drawing/2014/main" id="{08EB6308-5A8F-4A14-A1DC-77F55F40FB8F}"/>
+                <a16:creationId xmlns:a16="http://schemas.microsoft.com/office/drawing/2014/main" id="{B421C779-23E2-4974-889F-F6F21CA5A0C1}"/>
               </a:ext>
             </a:extLst>
           </p:cNvPr>
@@ -45505,7 +45505,7 @@
           <p:cNvPr id="20" name="">
             <a:extLst xmlns:a="http://schemas.openxmlformats.org/drawingml/2006/main">
               <a:ext uri="{FF2B5EF4-FFF2-40B4-BE49-F238E27FC236}">
-                <a16:creationId xmlns:a16="http://schemas.microsoft.com/office/drawing/2014/main" id="{E3472CA9-0F63-48A1-80BA-82A783232405}"/>
+                <a16:creationId xmlns:a16="http://schemas.microsoft.com/office/drawing/2014/main" id="{2B0E2A48-84A5-451B-B61B-25040A184D98}"/>
               </a:ext>
             </a:extLst>
           </p:cNvPr>
@@ -45538,7 +45538,7 @@
           <p:cNvPr id="21" name="">
             <a:extLst xmlns:a="http://schemas.openxmlformats.org/drawingml/2006/main">
               <a:ext uri="{FF2B5EF4-FFF2-40B4-BE49-F238E27FC236}">
-                <a16:creationId xmlns:a16="http://schemas.microsoft.com/office/drawing/2014/main" id="{1B498836-6345-4D1F-98CD-CB7A51C0DC31}"/>
+                <a16:creationId xmlns:a16="http://schemas.microsoft.com/office/drawing/2014/main" id="{8ECD6C1E-037C-4F1B-A898-9F8F35086F1C}"/>
               </a:ext>
             </a:extLst>
           </p:cNvPr>
@@ -45571,7 +45571,7 @@
           <p:cNvPr id="22" name="">
             <a:extLst xmlns:a="http://schemas.openxmlformats.org/drawingml/2006/main">
               <a:ext uri="{FF2B5EF4-FFF2-40B4-BE49-F238E27FC236}">
-                <a16:creationId xmlns:a16="http://schemas.microsoft.com/office/drawing/2014/main" id="{380E3F25-2374-4AF2-B99F-B7024835E9EF}"/>
+                <a16:creationId xmlns:a16="http://schemas.microsoft.com/office/drawing/2014/main" id="{D0115620-A373-403E-B7FA-52E32B5E8609}"/>
               </a:ext>
             </a:extLst>
           </p:cNvPr>
@@ -45604,7 +45604,7 @@
           <p:cNvPr id="23" name="">
             <a:extLst xmlns:a="http://schemas.openxmlformats.org/drawingml/2006/main">
               <a:ext uri="{FF2B5EF4-FFF2-40B4-BE49-F238E27FC236}">
-                <a16:creationId xmlns:a16="http://schemas.microsoft.com/office/drawing/2014/main" id="{BD31E22D-361B-45D2-A8B5-41B8931D4E34}"/>
+                <a16:creationId xmlns:a16="http://schemas.microsoft.com/office/drawing/2014/main" id="{5C3D7B77-9D2C-4322-BBE8-C232DB4CAB06}"/>
               </a:ext>
             </a:extLst>
           </p:cNvPr>
@@ -45637,7 +45637,7 @@
           <p:cNvPr id="24" name="">
             <a:extLst xmlns:a="http://schemas.openxmlformats.org/drawingml/2006/main">
               <a:ext uri="{FF2B5EF4-FFF2-40B4-BE49-F238E27FC236}">
-                <a16:creationId xmlns:a16="http://schemas.microsoft.com/office/drawing/2014/main" id="{AFE1F7B1-5A54-4909-8D4F-18460AA5DF94}"/>
+                <a16:creationId xmlns:a16="http://schemas.microsoft.com/office/drawing/2014/main" id="{CD3AC52F-38C6-4914-95F6-D4678FD4CD79}"/>
               </a:ext>
             </a:extLst>
           </p:cNvPr>
@@ -45670,7 +45670,7 @@
           <p:cNvPr id="25" name="">
             <a:extLst xmlns:a="http://schemas.openxmlformats.org/drawingml/2006/main">
               <a:ext uri="{FF2B5EF4-FFF2-40B4-BE49-F238E27FC236}">
-                <a16:creationId xmlns:a16="http://schemas.microsoft.com/office/drawing/2014/main" id="{DE4D2960-15B4-4FC9-B68D-8302296F1AC4}"/>
+                <a16:creationId xmlns:a16="http://schemas.microsoft.com/office/drawing/2014/main" id="{8F1FACF3-1A9C-45DF-AB4F-6AD68609E94E}"/>
               </a:ext>
             </a:extLst>
           </p:cNvPr>
@@ -45703,7 +45703,7 @@
           <p:cNvPr id="26" name="">
             <a:extLst xmlns:a="http://schemas.openxmlformats.org/drawingml/2006/main">
               <a:ext uri="{FF2B5EF4-FFF2-40B4-BE49-F238E27FC236}">
-                <a16:creationId xmlns:a16="http://schemas.microsoft.com/office/drawing/2014/main" id="{07CAC182-08CE-4C22-806F-5C70D0A5BE48}"/>
+                <a16:creationId xmlns:a16="http://schemas.microsoft.com/office/drawing/2014/main" id="{8B4EEFEB-6C5A-443D-AD3A-2EB031CEDBDE}"/>
               </a:ext>
             </a:extLst>
           </p:cNvPr>
@@ -45736,7 +45736,7 @@
           <p:cNvPr id="27" name="">
             <a:extLst xmlns:a="http://schemas.openxmlformats.org/drawingml/2006/main">
               <a:ext uri="{FF2B5EF4-FFF2-40B4-BE49-F238E27FC236}">
-                <a16:creationId xmlns:a16="http://schemas.microsoft.com/office/drawing/2014/main" id="{6E06434E-293D-4135-BD12-2CE5A2DBD932}"/>
+                <a16:creationId xmlns:a16="http://schemas.microsoft.com/office/drawing/2014/main" id="{CD357FE5-5974-47BE-A33A-FE75A4E8B20C}"/>
               </a:ext>
             </a:extLst>
           </p:cNvPr>
@@ -45769,7 +45769,7 @@
           <p:cNvPr id="28" name="질문">
             <a:extLst xmlns:a="http://schemas.openxmlformats.org/drawingml/2006/main">
               <a:ext uri="{FF2B5EF4-FFF2-40B4-BE49-F238E27FC236}">
-                <a16:creationId xmlns:a16="http://schemas.microsoft.com/office/drawing/2014/main" id="{EB561274-93C6-4329-8AD7-9724F6CAA049}"/>
+                <a16:creationId xmlns:a16="http://schemas.microsoft.com/office/drawing/2014/main" id="{303E3EC0-E84D-405A-9EE5-AD25D39B428C}"/>
               </a:ext>
             </a:extLst>
           </p:cNvPr>
@@ -45927,7 +45927,7 @@
           <p:cNvPr id="29" name="">
             <a:extLst xmlns:a="http://schemas.openxmlformats.org/drawingml/2006/main">
               <a:ext uri="{FF2B5EF4-FFF2-40B4-BE49-F238E27FC236}">
-                <a16:creationId xmlns:a16="http://schemas.microsoft.com/office/drawing/2014/main" id="{69428B5F-7BBB-4481-B0E4-474334D916B5}"/>
+                <a16:creationId xmlns:a16="http://schemas.microsoft.com/office/drawing/2014/main" id="{A96DBBA2-93BC-40FD-8C9A-D818F3B225E8}"/>
               </a:ext>
             </a:extLst>
           </p:cNvPr>
@@ -45957,7 +45957,7 @@
           <p:cNvPr id="30" name="">
             <a:extLst xmlns:a="http://schemas.openxmlformats.org/drawingml/2006/main">
               <a:ext uri="{FF2B5EF4-FFF2-40B4-BE49-F238E27FC236}">
-                <a16:creationId xmlns:a16="http://schemas.microsoft.com/office/drawing/2014/main" id="{917D9954-692B-4336-8CF2-10461D5B8171}"/>
+                <a16:creationId xmlns:a16="http://schemas.microsoft.com/office/drawing/2014/main" id="{0764A1F9-3846-4D5F-817B-46194AF1112E}"/>
               </a:ext>
             </a:extLst>
           </p:cNvPr>
@@ -45990,7 +45990,7 @@
           <p:cNvPr id="31" name="Repository의 코드">
             <a:extLst xmlns:a="http://schemas.openxmlformats.org/drawingml/2006/main">
               <a:ext uri="{FF2B5EF4-FFF2-40B4-BE49-F238E27FC236}">
-                <a16:creationId xmlns:a16="http://schemas.microsoft.com/office/drawing/2014/main" id="{CF8C2BB8-1F16-47EB-9A79-8595637D7578}"/>
+                <a16:creationId xmlns:a16="http://schemas.microsoft.com/office/drawing/2014/main" id="{6DC06317-9402-4BE9-9383-FA2E4C1FF447}"/>
               </a:ext>
             </a:extLst>
           </p:cNvPr>
@@ -46148,7 +46148,7 @@
           <p:cNvPr id="32" name="관련 코드 찾기">
             <a:extLst xmlns:a="http://schemas.openxmlformats.org/drawingml/2006/main">
               <a:ext uri="{FF2B5EF4-FFF2-40B4-BE49-F238E27FC236}">
-                <a16:creationId xmlns:a16="http://schemas.microsoft.com/office/drawing/2014/main" id="{6B0F6515-AD04-49FA-9E03-AC2A1DE123F6}"/>
+                <a16:creationId xmlns:a16="http://schemas.microsoft.com/office/drawing/2014/main" id="{49CAFEAA-00AA-46E1-8274-A53886A6B7CA}"/>
               </a:ext>
             </a:extLst>
           </p:cNvPr>
@@ -46306,7 +46306,7 @@
           <p:cNvPr id="33" name="관련 정보의 위치가&#10;일부 조건에서 중요할 수 있다">
             <a:extLst xmlns:a="http://schemas.openxmlformats.org/drawingml/2006/main">
               <a:ext uri="{FF2B5EF4-FFF2-40B4-BE49-F238E27FC236}">
-                <a16:creationId xmlns:a16="http://schemas.microsoft.com/office/drawing/2014/main" id="{F776B4D8-3FB0-474F-8148-8B1A7CDC8411}"/>
+                <a16:creationId xmlns:a16="http://schemas.microsoft.com/office/drawing/2014/main" id="{803FB023-1DA1-4331-8F62-441A6A39C700}"/>
               </a:ext>
             </a:extLst>
           </p:cNvPr>
@@ -46487,7 +46487,7 @@
           <p:cNvPr id="34" name="관련 코드 정보를&#10;선택하고 찾는 능력을 평가">
             <a:extLst xmlns:a="http://schemas.openxmlformats.org/drawingml/2006/main">
               <a:ext uri="{FF2B5EF4-FFF2-40B4-BE49-F238E27FC236}">
-                <a16:creationId xmlns:a16="http://schemas.microsoft.com/office/drawing/2014/main" id="{703AA459-F52C-4E2E-BDF0-3911DDA41A7A}"/>
+                <a16:creationId xmlns:a16="http://schemas.microsoft.com/office/drawing/2014/main" id="{572C394E-5C1F-4274-88A9-642C498D4E41}"/>
               </a:ext>
             </a:extLst>
           </p:cNvPr>
@@ -46668,7 +46668,7 @@
           <p:cNvPr id="35" name="aclanthology.org/2024.tacl-1.9/">
             <a:extLst xmlns:a="http://schemas.openxmlformats.org/drawingml/2006/main">
               <a:ext uri="{FF2B5EF4-FFF2-40B4-BE49-F238E27FC236}">
-                <a16:creationId xmlns:a16="http://schemas.microsoft.com/office/drawing/2014/main" id="{FF420632-78C8-41AE-86B4-F0725B5EA6E7}"/>
+                <a16:creationId xmlns:a16="http://schemas.microsoft.com/office/drawing/2014/main" id="{720122DF-67BC-44EB-89A0-B3453F23BDDF}"/>
               </a:ext>
             </a:extLst>
           </p:cNvPr>
@@ -46826,7 +46826,7 @@
           <p:cNvPr id="36" name="arxiv.org/abs/2406.06025">
             <a:extLst xmlns:a="http://schemas.openxmlformats.org/drawingml/2006/main">
               <a:ext uri="{FF2B5EF4-FFF2-40B4-BE49-F238E27FC236}">
-                <a16:creationId xmlns:a16="http://schemas.microsoft.com/office/drawing/2014/main" id="{A364B8D8-DD78-4483-8719-9F4A5E31770F}"/>
+                <a16:creationId xmlns:a16="http://schemas.microsoft.com/office/drawing/2014/main" id="{85D4E282-6F05-47DC-904B-F0CDD86F05BE}"/>
               </a:ext>
             </a:extLst>
           </p:cNvPr>
@@ -46984,7 +46984,7 @@
           <p:cNvPr id="37" name="Legacy module connection">
             <a:extLst xmlns:a="http://schemas.openxmlformats.org/drawingml/2006/main">
               <a:ext uri="{FF2B5EF4-FFF2-40B4-BE49-F238E27FC236}">
-                <a16:creationId xmlns:a16="http://schemas.microsoft.com/office/drawing/2014/main" id="{F2E4C352-53E6-4BD3-8F4C-B18F17D9CFBE}"/>
+                <a16:creationId xmlns:a16="http://schemas.microsoft.com/office/drawing/2014/main" id="{632852C7-C7B4-4858-A2F0-9A6CB2E4CD7A}"/>
               </a:ext>
             </a:extLst>
           </p:cNvPr>
@@ -47140,7 +47140,7 @@
     </p:spTree>
     <p:extLst>
       <p:ext uri="{BB962C8B-B14F-4D97-AF65-F5344CB8AC3E}">
-        <p14:creationId xmlns:p14="http://schemas.microsoft.com/office/powerpoint/2010/main" val="1348319445"/>
+        <p14:creationId xmlns:p14="http://schemas.microsoft.com/office/powerpoint/2010/main" val="377690732"/>
       </p:ext>
     </p:extLst>
   </p:cSld>
@@ -47171,7 +47171,7 @@
           <p:cNvPr id="21" name="ACT 2 · 필요한 상세 정보의 탐색 경로">
             <a:extLst xmlns:a="http://schemas.openxmlformats.org/drawingml/2006/main">
               <a:ext uri="{FF2B5EF4-FFF2-40B4-BE49-F238E27FC236}">
-                <a16:creationId xmlns:a16="http://schemas.microsoft.com/office/drawing/2014/main" id="{4667B5C0-B1D0-425D-910E-3B29253FD555}"/>
+                <a16:creationId xmlns:a16="http://schemas.microsoft.com/office/drawing/2014/main" id="{74BABB10-91D4-4009-AA17-210B4936D26F}"/>
               </a:ext>
             </a:extLst>
           </p:cNvPr>
@@ -47326,10 +47326,10 @@
       </p:sp>
       <p:sp>
         <p:nvSpPr>
-          <p:cNvPr id="2" name="S32">
+          <p:cNvPr id="2" name="S40">
             <a:extLst xmlns:a="http://schemas.openxmlformats.org/drawingml/2006/main">
               <a:ext uri="{FF2B5EF4-FFF2-40B4-BE49-F238E27FC236}">
-                <a16:creationId xmlns:a16="http://schemas.microsoft.com/office/drawing/2014/main" id="{313C36CD-13BF-4148-9745-8DE91CDB75C5}"/>
+                <a16:creationId xmlns:a16="http://schemas.microsoft.com/office/drawing/2014/main" id="{4D8106C2-3C20-418F-ACD8-BD5AFEA7D416}"/>
               </a:ext>
             </a:extLst>
           </p:cNvPr>
@@ -47477,7 +47477,7 @@
                 <a:ea typeface="Malgun Gothic"/>
                 <a:cs typeface="Malgun Gothic"/>
               </a:rPr>
-              <a:t>S32</a:t>
+              <a:t>S40</a:t>
             </a:r>
           </a:p>
         </p:txBody>
@@ -47487,7 +47487,7 @@
           <p:cNvPr id="3" name="필요한 상세 정보로 가는 길">
             <a:extLst xmlns:a="http://schemas.openxmlformats.org/drawingml/2006/main">
               <a:ext uri="{FF2B5EF4-FFF2-40B4-BE49-F238E27FC236}">
-                <a16:creationId xmlns:a16="http://schemas.microsoft.com/office/drawing/2014/main" id="{EF02402D-E93E-45E3-AEE9-72C1E162AEC9}"/>
+                <a16:creationId xmlns:a16="http://schemas.microsoft.com/office/drawing/2014/main" id="{2A511D63-C4FF-45DA-8943-69ED6512BD11}"/>
               </a:ext>
             </a:extLst>
           </p:cNvPr>
@@ -47645,7 +47645,7 @@
           <p:cNvPr id="4" name="">
             <a:extLst xmlns:a="http://schemas.openxmlformats.org/drawingml/2006/main">
               <a:ext uri="{FF2B5EF4-FFF2-40B4-BE49-F238E27FC236}">
-                <a16:creationId xmlns:a16="http://schemas.microsoft.com/office/drawing/2014/main" id="{B8FC1BA9-3629-477C-A2F4-08D0D6BC5EAB}"/>
+                <a16:creationId xmlns:a16="http://schemas.microsoft.com/office/drawing/2014/main" id="{1C000521-FBEB-4947-9C86-B751A5F993F3}"/>
               </a:ext>
             </a:extLst>
           </p:cNvPr>
@@ -47676,7 +47676,7 @@
           <p:cNvPr id="5" name="교육용 Routing 모델 · 실제 문서 접근 결과는 다음 구간에서 확인">
             <a:extLst xmlns:a="http://schemas.openxmlformats.org/drawingml/2006/main">
               <a:ext uri="{FF2B5EF4-FFF2-40B4-BE49-F238E27FC236}">
-                <a16:creationId xmlns:a16="http://schemas.microsoft.com/office/drawing/2014/main" id="{9B0D8327-90FB-4F9F-AB02-842ADC61A10A}"/>
+                <a16:creationId xmlns:a16="http://schemas.microsoft.com/office/drawing/2014/main" id="{8B1BB493-FF6E-4632-9494-4B5553557E2F}"/>
               </a:ext>
             </a:extLst>
           </p:cNvPr>
@@ -47834,7 +47834,7 @@
           <p:cNvPr id="6" name="검색 성능 향상이나 토큰 절약을 입증한 그림이 아님">
             <a:extLst xmlns:a="http://schemas.openxmlformats.org/drawingml/2006/main">
               <a:ext uri="{FF2B5EF4-FFF2-40B4-BE49-F238E27FC236}">
-                <a16:creationId xmlns:a16="http://schemas.microsoft.com/office/drawing/2014/main" id="{339E2E1C-C8BE-416C-A95D-00F2D418030E}"/>
+                <a16:creationId xmlns:a16="http://schemas.microsoft.com/office/drawing/2014/main" id="{0797909E-AFA6-47AA-A506-4CCB68A755BE}"/>
               </a:ext>
             </a:extLst>
           </p:cNvPr>
@@ -47992,7 +47992,7 @@
           <p:cNvPr id="7" name="어떤 질문에서 어떤 상세 정보가 필요할까?">
             <a:extLst xmlns:a="http://schemas.openxmlformats.org/drawingml/2006/main">
               <a:ext uri="{FF2B5EF4-FFF2-40B4-BE49-F238E27FC236}">
-                <a16:creationId xmlns:a16="http://schemas.microsoft.com/office/drawing/2014/main" id="{71C29E6D-3D2C-4C45-BAFA-5045859AAEEF}"/>
+                <a16:creationId xmlns:a16="http://schemas.microsoft.com/office/drawing/2014/main" id="{54D8AF2E-EAE5-4023-B34E-ECB1B4F76704}"/>
               </a:ext>
             </a:extLst>
           </p:cNvPr>
@@ -48150,7 +48150,7 @@
           <p:cNvPr id="8" name="">
             <a:extLst xmlns:a="http://schemas.openxmlformats.org/drawingml/2006/main">
               <a:ext uri="{FF2B5EF4-FFF2-40B4-BE49-F238E27FC236}">
-                <a16:creationId xmlns:a16="http://schemas.microsoft.com/office/drawing/2014/main" id="{CDC1E14C-81DD-4541-968B-9DB0BC0033D7}"/>
+                <a16:creationId xmlns:a16="http://schemas.microsoft.com/office/drawing/2014/main" id="{1FA60849-3FDC-44A4-B902-F31FF139F301}"/>
               </a:ext>
             </a:extLst>
           </p:cNvPr>
@@ -48181,7 +48181,7 @@
           <p:cNvPr id="9" name="Task">
             <a:extLst xmlns:a="http://schemas.openxmlformats.org/drawingml/2006/main">
               <a:ext uri="{FF2B5EF4-FFF2-40B4-BE49-F238E27FC236}">
-                <a16:creationId xmlns:a16="http://schemas.microsoft.com/office/drawing/2014/main" id="{9C3A81C5-E12B-40BD-8833-CB3B9D9BC5F2}"/>
+                <a16:creationId xmlns:a16="http://schemas.microsoft.com/office/drawing/2014/main" id="{0F7C6C0A-B02A-417F-8342-A4239E4F4CF9}"/>
               </a:ext>
             </a:extLst>
           </p:cNvPr>
@@ -48339,7 +48339,7 @@
           <p:cNvPr id="10" name="지금 해결할 질문">
             <a:extLst xmlns:a="http://schemas.openxmlformats.org/drawingml/2006/main">
               <a:ext uri="{FF2B5EF4-FFF2-40B4-BE49-F238E27FC236}">
-                <a16:creationId xmlns:a16="http://schemas.microsoft.com/office/drawing/2014/main" id="{F0905F7D-B4AC-4622-9E42-19DCCCC72ED5}"/>
+                <a16:creationId xmlns:a16="http://schemas.microsoft.com/office/drawing/2014/main" id="{D2B623E9-CCC2-4087-A278-AEBAA96D355E}"/>
               </a:ext>
             </a:extLst>
           </p:cNvPr>
@@ -48497,7 +48497,7 @@
           <p:cNvPr id="11" name="">
             <a:extLst xmlns:a="http://schemas.openxmlformats.org/drawingml/2006/main">
               <a:ext uri="{FF2B5EF4-FFF2-40B4-BE49-F238E27FC236}">
-                <a16:creationId xmlns:a16="http://schemas.microsoft.com/office/drawing/2014/main" id="{D31299D9-871E-4535-B05B-F991D1DFD482}"/>
+                <a16:creationId xmlns:a16="http://schemas.microsoft.com/office/drawing/2014/main" id="{CE958E34-D219-405C-A419-811B93279ABA}"/>
               </a:ext>
             </a:extLst>
           </p:cNvPr>
@@ -48527,7 +48527,7 @@
           <p:cNvPr id="12" name="">
             <a:extLst xmlns:a="http://schemas.openxmlformats.org/drawingml/2006/main">
               <a:ext uri="{FF2B5EF4-FFF2-40B4-BE49-F238E27FC236}">
-                <a16:creationId xmlns:a16="http://schemas.microsoft.com/office/drawing/2014/main" id="{2F008C2B-943A-4C76-A84D-AD4BFDDB514B}"/>
+                <a16:creationId xmlns:a16="http://schemas.microsoft.com/office/drawing/2014/main" id="{47A284D2-A06A-4DE7-A4EA-9C068AAB80E8}"/>
               </a:ext>
             </a:extLst>
           </p:cNvPr>
@@ -48558,7 +48558,7 @@
           <p:cNvPr id="13" name="Core Context">
             <a:extLst xmlns:a="http://schemas.openxmlformats.org/drawingml/2006/main">
               <a:ext uri="{FF2B5EF4-FFF2-40B4-BE49-F238E27FC236}">
-                <a16:creationId xmlns:a16="http://schemas.microsoft.com/office/drawing/2014/main" id="{4BF8B9C9-FF72-4DCF-98A9-DBA1BE83A51C}"/>
+                <a16:creationId xmlns:a16="http://schemas.microsoft.com/office/drawing/2014/main" id="{A78A26AF-266C-4DC4-B08F-3B98AB9BFC98}"/>
               </a:ext>
             </a:extLst>
           </p:cNvPr>
@@ -48716,7 +48716,7 @@
           <p:cNvPr id="14" name="프로젝트 안내와&#10;찾아갈 위치">
             <a:extLst xmlns:a="http://schemas.openxmlformats.org/drawingml/2006/main">
               <a:ext uri="{FF2B5EF4-FFF2-40B4-BE49-F238E27FC236}">
-                <a16:creationId xmlns:a16="http://schemas.microsoft.com/office/drawing/2014/main" id="{3BEFA54B-C41F-4C7D-A9BC-88CC1B97BCF1}"/>
+                <a16:creationId xmlns:a16="http://schemas.microsoft.com/office/drawing/2014/main" id="{7B7B7D7C-6C6A-46E3-A0ED-39F8A129C544}"/>
               </a:ext>
             </a:extLst>
           </p:cNvPr>
@@ -48897,7 +48897,7 @@
           <p:cNvPr id="15" name="">
             <a:extLst xmlns:a="http://schemas.openxmlformats.org/drawingml/2006/main">
               <a:ext uri="{FF2B5EF4-FFF2-40B4-BE49-F238E27FC236}">
-                <a16:creationId xmlns:a16="http://schemas.microsoft.com/office/drawing/2014/main" id="{DA87EAC6-51C7-4D74-9EA8-3CFA6E396506}"/>
+                <a16:creationId xmlns:a16="http://schemas.microsoft.com/office/drawing/2014/main" id="{B3C63980-5F1B-4084-A496-743F6DDBDE8F}"/>
               </a:ext>
             </a:extLst>
           </p:cNvPr>
@@ -48927,7 +48927,7 @@
           <p:cNvPr id="16" name="">
             <a:extLst xmlns:a="http://schemas.openxmlformats.org/drawingml/2006/main">
               <a:ext uri="{FF2B5EF4-FFF2-40B4-BE49-F238E27FC236}">
-                <a16:creationId xmlns:a16="http://schemas.microsoft.com/office/drawing/2014/main" id="{A4CAF7B5-DFE4-48FE-9BF4-3F00EED2510F}"/>
+                <a16:creationId xmlns:a16="http://schemas.microsoft.com/office/drawing/2014/main" id="{2CCFE5D2-2B0F-414B-9A6A-415B0C62DCE5}"/>
               </a:ext>
             </a:extLst>
           </p:cNvPr>
@@ -48958,7 +48958,7 @@
           <p:cNvPr id="17" name="관련 상세 정보">
             <a:extLst xmlns:a="http://schemas.openxmlformats.org/drawingml/2006/main">
               <a:ext uri="{FF2B5EF4-FFF2-40B4-BE49-F238E27FC236}">
-                <a16:creationId xmlns:a16="http://schemas.microsoft.com/office/drawing/2014/main" id="{8ECAA4D7-9200-4071-BD8E-800928B25931}"/>
+                <a16:creationId xmlns:a16="http://schemas.microsoft.com/office/drawing/2014/main" id="{21573FAC-F474-45A1-8890-C6767356771E}"/>
               </a:ext>
             </a:extLst>
           </p:cNvPr>
@@ -49116,7 +49116,7 @@
           <p:cNvPr id="18" name="질문에 필요한&#10;계약 · 구조 · 테스트">
             <a:extLst xmlns:a="http://schemas.openxmlformats.org/drawingml/2006/main">
               <a:ext uri="{FF2B5EF4-FFF2-40B4-BE49-F238E27FC236}">
-                <a16:creationId xmlns:a16="http://schemas.microsoft.com/office/drawing/2014/main" id="{EA66A5B8-A7CF-4918-9494-2D91DBD4EC0C}"/>
+                <a16:creationId xmlns:a16="http://schemas.microsoft.com/office/drawing/2014/main" id="{A95AD691-9BC8-4233-B426-0421D9688EF1}"/>
               </a:ext>
             </a:extLst>
           </p:cNvPr>
@@ -49297,7 +49297,7 @@
           <p:cNvPr id="19" name="C++ 예: 공통 제약을 확인한 뒤, 해당 알고리즘의 계약으로">
             <a:extLst xmlns:a="http://schemas.openxmlformats.org/drawingml/2006/main">
               <a:ext uri="{FF2B5EF4-FFF2-40B4-BE49-F238E27FC236}">
-                <a16:creationId xmlns:a16="http://schemas.microsoft.com/office/drawing/2014/main" id="{6FF09B60-E5E9-4470-9257-D3BB6037D029}"/>
+                <a16:creationId xmlns:a16="http://schemas.microsoft.com/office/drawing/2014/main" id="{48641AA7-A114-4D8B-94C7-C7606AE8B01A}"/>
               </a:ext>
             </a:extLst>
           </p:cNvPr>
@@ -49455,7 +49455,7 @@
           <p:cNvPr id="20" name="Legacy module connection">
             <a:extLst xmlns:a="http://schemas.openxmlformats.org/drawingml/2006/main">
               <a:ext uri="{FF2B5EF4-FFF2-40B4-BE49-F238E27FC236}">
-                <a16:creationId xmlns:a16="http://schemas.microsoft.com/office/drawing/2014/main" id="{13FCAB07-84AD-4ED4-A9A5-4C4DD7252F39}"/>
+                <a16:creationId xmlns:a16="http://schemas.microsoft.com/office/drawing/2014/main" id="{FAA8BCE5-F661-4F9B-A9E6-F8C811069C71}"/>
               </a:ext>
             </a:extLst>
           </p:cNvPr>
@@ -49611,7 +49611,7 @@
     </p:spTree>
     <p:extLst>
       <p:ext uri="{BB962C8B-B14F-4D97-AF65-F5344CB8AC3E}">
-        <p14:creationId xmlns:p14="http://schemas.microsoft.com/office/powerpoint/2010/main" val="1580477114"/>
+        <p14:creationId xmlns:p14="http://schemas.microsoft.com/office/powerpoint/2010/main" val="881488602"/>
       </p:ext>
     </p:extLst>
   </p:cSld>

</xml_diff>